<commit_message>
docs: paper sections 8-9 (supply match, RON95) + 2 slides + glossary
Paper: descriptive methodology/assumptions/caveats paragraphs per section,
all abbreviations spelled out, 16-row glossary. Slides 10 (supply check
utilisation chart) and 11 (RON95 two-route table + net -1.8% stat);
closing gains the RON95 recommendation. Table widths fixed to page.

Co-Authored-By: Claude Fable 5 <noreply@anthropic.com>
</commit_message>
<xml_diff>
--- a/docs/Volume_Dividend_Slides.pptx
+++ b/docs/Volume_Dividend_Slides.pptx
@@ -15,9 +15,11 @@
     <p:sldId id="263" r:id="rId9"/>
     <p:sldId id="264" r:id="rId10"/>
     <p:sldId id="265" r:id="rId11"/>
+    <p:sldId id="266" r:id="rId12"/>
+    <p:sldId id="267" r:id="rId13"/>
   </p:sldIdLst>
   <p:notesMasterIdLst>
-    <p:notesMasterId r:id="rId12"/>
+    <p:notesMasterId r:id="rId14"/>
   </p:notesMasterIdLst>
   <p:sldSz cx="12192000" cy="6858000"/>
   <p:notesSz cx="6858000" cy="12192000"/>
@@ -1256,6 +1258,360 @@
 </c:chartSpace>
 </file>
 
+<file path=ppt/charts/chart5.xml><?xml version="1.0" encoding="utf-8"?>
+<c:chartSpace xmlns:c="http://schemas.openxmlformats.org/drawingml/2006/chart" xmlns:a="http://schemas.openxmlformats.org/drawingml/2006/main" xmlns:r="http://schemas.openxmlformats.org/officeDocument/2006/relationships">
+  <c:date1904 val="0"/>
+  <c:roundedCorners val="1"/>
+  <c:chart>
+    <c:autoTitleDeleted val="1"/>
+    <c:plotArea>
+      <c:layout/>
+      <c:barChart>
+        <c:barDir val="col"/>
+        <c:grouping val="clustered"/>
+        <c:varyColors val="0"/>
+        <c:ser>
+          <c:idx val="0"/>
+          <c:order val="0"/>
+          <c:tx>
+            <c:strRef>
+              <c:f>Sheet1!$B$1</c:f>
+              <c:strCache>
+                <c:ptCount val="1"/>
+                <c:pt idx="0">
+                  <c:v>Utilisation on 2,000 cr L (today)</c:v>
+                </c:pt>
+              </c:strCache>
+            </c:strRef>
+          </c:tx>
+          <c:spPr>
+            <a:solidFill>
+              <a:srgbClr val="16523F"/>
+            </a:solidFill>
+            <a:effectLst/>
+          </c:spPr>
+          <c:invertIfNegative val="0"/>
+          <c:dLbls>
+            <c:numFmt formatCode="#,##0" sourceLinked="0"/>
+            <c:txPr>
+              <a:bodyPr/>
+              <a:lstStyle/>
+              <a:p>
+                <a:pPr>
+                  <a:defRPr b="0" i="0" strike="noStrike" sz="1100" u="none">
+                    <a:solidFill>
+                      <a:srgbClr val="1C2B27"/>
+                    </a:solidFill>
+                    <a:latin typeface="Arial"/>
+                  </a:defRPr>
+                </a:pPr>
+              </a:p>
+            </c:txPr>
+            <c:showLegendKey val="0"/>
+            <c:showVal val="1"/>
+            <c:showCatName val="0"/>
+            <c:showSerName val="0"/>
+            <c:showPercent val="0"/>
+            <c:showBubbleSize val="0"/>
+            <c:showLeaderLines val="0"/>
+          </c:dLbls>
+          <c:cat>
+            <c:multiLvlStrRef>
+              <c:f>Sheet1!$A$2:$A$5</c:f>
+              <c:multiLvlStrCache>
+                <c:ptCount val="4"/>
+                <c:lvl>
+                  <c:pt idx="0">
+                    <c:v>E20</c:v>
+                  </c:pt>
+                  <c:pt idx="1">
+                    <c:v>E25</c:v>
+                  </c:pt>
+                  <c:pt idx="2">
+                    <c:v>E27</c:v>
+                  </c:pt>
+                  <c:pt idx="3">
+                    <c:v>E30</c:v>
+                  </c:pt>
+                </c:lvl>
+              </c:multiLvlStrCache>
+            </c:multiLvlStrRef>
+          </c:cat>
+          <c:val>
+            <c:numRef>
+              <c:f>Sheet1!$B$2:$B$5</c:f>
+              <c:numCache>
+                <c:formatCode>General</c:formatCode>
+                <c:ptCount val="4"/>
+                <c:pt idx="0">
+                  <c:v>70</c:v>
+                </c:pt>
+                <c:pt idx="1">
+                  <c:v>85</c:v>
+                </c:pt>
+                <c:pt idx="2">
+                  <c:v>91</c:v>
+                </c:pt>
+                <c:pt idx="3">
+                  <c:v>100</c:v>
+                </c:pt>
+              </c:numCache>
+            </c:numRef>
+          </c:val>
+        </c:ser>
+        <c:ser>
+          <c:idx val="1"/>
+          <c:order val="1"/>
+          <c:tx>
+            <c:strRef>
+              <c:f>Sheet1!$C$1</c:f>
+              <c:strCache>
+                <c:ptCount val="1"/>
+                <c:pt idx="0">
+                  <c:v>On 2,400 cr L (FY27)</c:v>
+                </c:pt>
+              </c:strCache>
+            </c:strRef>
+          </c:tx>
+          <c:spPr>
+            <a:solidFill>
+              <a:srgbClr val="2E9E6B"/>
+            </a:solidFill>
+            <a:effectLst/>
+          </c:spPr>
+          <c:invertIfNegative val="0"/>
+          <c:dLbls>
+            <c:numFmt formatCode="#,##0" sourceLinked="0"/>
+            <c:txPr>
+              <a:bodyPr/>
+              <a:lstStyle/>
+              <a:p>
+                <a:pPr>
+                  <a:defRPr b="0" i="0" strike="noStrike" sz="1100" u="none">
+                    <a:solidFill>
+                      <a:srgbClr val="1C2B27"/>
+                    </a:solidFill>
+                    <a:latin typeface="Arial"/>
+                  </a:defRPr>
+                </a:pPr>
+              </a:p>
+            </c:txPr>
+            <c:showLegendKey val="0"/>
+            <c:showVal val="1"/>
+            <c:showCatName val="0"/>
+            <c:showSerName val="0"/>
+            <c:showPercent val="0"/>
+            <c:showBubbleSize val="0"/>
+            <c:showLeaderLines val="0"/>
+          </c:dLbls>
+          <c:cat>
+            <c:multiLvlStrRef>
+              <c:f>Sheet1!$A$2:$A$5</c:f>
+              <c:multiLvlStrCache>
+                <c:ptCount val="4"/>
+                <c:lvl>
+                  <c:pt idx="0">
+                    <c:v>E20</c:v>
+                  </c:pt>
+                  <c:pt idx="1">
+                    <c:v>E25</c:v>
+                  </c:pt>
+                  <c:pt idx="2">
+                    <c:v>E27</c:v>
+                  </c:pt>
+                  <c:pt idx="3">
+                    <c:v>E30</c:v>
+                  </c:pt>
+                </c:lvl>
+              </c:multiLvlStrCache>
+            </c:multiLvlStrRef>
+          </c:cat>
+          <c:val>
+            <c:numRef>
+              <c:f>Sheet1!$C$2:$C$5</c:f>
+              <c:numCache>
+                <c:formatCode>General</c:formatCode>
+                <c:ptCount val="4"/>
+                <c:pt idx="0">
+                  <c:v>59</c:v>
+                </c:pt>
+                <c:pt idx="1">
+                  <c:v>71</c:v>
+                </c:pt>
+                <c:pt idx="2">
+                  <c:v>76</c:v>
+                </c:pt>
+                <c:pt idx="3">
+                  <c:v>83</c:v>
+                </c:pt>
+              </c:numCache>
+            </c:numRef>
+          </c:val>
+        </c:ser>
+        <c:dLbls>
+          <c:numFmt formatCode="#,##0" sourceLinked="0"/>
+          <c:txPr>
+            <a:bodyPr/>
+            <a:lstStyle/>
+            <a:p>
+              <a:pPr>
+                <a:defRPr b="0" i="0" strike="noStrike" sz="1100" u="none">
+                  <a:solidFill>
+                    <a:srgbClr val="1C2B27"/>
+                  </a:solidFill>
+                  <a:latin typeface="Arial"/>
+                </a:defRPr>
+              </a:pPr>
+            </a:p>
+          </c:txPr>
+          <c:showLegendKey val="0"/>
+          <c:showVal val="1"/>
+          <c:showCatName val="0"/>
+          <c:showSerName val="0"/>
+          <c:showPercent val="0"/>
+          <c:showBubbleSize val="0"/>
+          <c:showLeaderLines val="0"/>
+        </c:dLbls>
+        <c:gapWidth val="60"/>
+        <c:overlap val="0"/>
+        <c:axId val="2094734554"/>
+        <c:axId val="2094734552"/>
+        <c:axId val="2094734556"/>
+      </c:barChart>
+      <c:catAx>
+        <c:axId val="2094734554"/>
+        <c:scaling>
+          <c:orientation val="minMax"/>
+        </c:scaling>
+        <c:delete val="0"/>
+        <c:axPos val="b"/>
+        <c:numFmt formatCode="General" sourceLinked="1"/>
+        <c:majorTickMark val="out"/>
+        <c:minorTickMark val="none"/>
+        <c:tickLblPos val="low"/>
+        <c:spPr>
+          <a:ln w="12700" cap="flat">
+            <a:solidFill>
+              <a:srgbClr val="888888"/>
+            </a:solidFill>
+            <a:prstDash val="solid"/>
+            <a:round/>
+          </a:ln>
+        </c:spPr>
+        <c:txPr>
+          <a:bodyPr/>
+          <a:lstStyle/>
+          <a:p>
+            <a:pPr>
+              <a:defRPr sz="1200" b="0" i="0" u="none" strike="noStrike">
+                <a:solidFill>
+                  <a:srgbClr val="1C2B27"/>
+                </a:solidFill>
+                <a:latin typeface="Arial"/>
+              </a:defRPr>
+            </a:pPr>
+            <a:endParaRPr lang="en-US"/>
+          </a:p>
+        </c:txPr>
+        <c:crossAx val="2094734552"/>
+        <c:crosses val="autoZero"/>
+        <c:auto val="1"/>
+        <c:lblAlgn val="ctr"/>
+        <c:noMultiLvlLbl val="1"/>
+      </c:catAx>
+      <c:valAx>
+        <c:axId val="2094734552"/>
+        <c:scaling>
+          <c:orientation val="minMax"/>
+          <c:max val="110"/>
+        </c:scaling>
+        <c:delete val="0"/>
+        <c:axPos val="l"/>
+        <c:majorGridlines>
+          <c:spPr>
+            <a:ln w="6350" cap="flat">
+              <a:solidFill>
+                <a:srgbClr val="D5E0DB"/>
+              </a:solidFill>
+              <a:prstDash val="solid"/>
+              <a:round/>
+            </a:ln>
+          </c:spPr>
+        </c:majorGridlines>
+        <c:numFmt formatCode="General" sourceLinked="0"/>
+        <c:majorTickMark val="out"/>
+        <c:minorTickMark val="none"/>
+        <c:tickLblPos val="nextTo"/>
+        <c:spPr>
+          <a:ln w="12700" cap="flat">
+            <a:solidFill>
+              <a:srgbClr val="888888"/>
+            </a:solidFill>
+            <a:prstDash val="solid"/>
+            <a:round/>
+          </a:ln>
+        </c:spPr>
+        <c:txPr>
+          <a:bodyPr/>
+          <a:lstStyle/>
+          <a:p>
+            <a:pPr>
+              <a:defRPr sz="1200" b="0" i="0" u="none" strike="noStrike">
+                <a:solidFill>
+                  <a:srgbClr val="5C6B66"/>
+                </a:solidFill>
+                <a:latin typeface="Arial"/>
+              </a:defRPr>
+            </a:pPr>
+            <a:endParaRPr lang="en-US"/>
+          </a:p>
+        </c:txPr>
+        <c:crossAx val="2094734554"/>
+        <c:crosses val="autoZero"/>
+        <c:crossBetween val="between"/>
+      </c:valAx>
+      <c:spPr>
+        <a:noFill/>
+        <a:ln>
+          <a:noFill/>
+        </a:ln>
+        <a:effectLst/>
+      </c:spPr>
+    </c:plotArea>
+    <c:legend>
+      <c:legendPos val="b"/>
+      <c:overlay val="0"/>
+      <c:txPr>
+        <a:bodyPr/>
+        <a:lstStyle/>
+        <a:p>
+          <a:pPr>
+            <a:defRPr>
+              <a:solidFill>
+                <a:srgbClr val="1C2B27"/>
+              </a:solidFill>
+            </a:defRPr>
+          </a:pPr>
+          <a:endParaRPr lang="en-US"/>
+        </a:p>
+      </c:txPr>
+    </c:legend>
+    <c:plotVisOnly val="1"/>
+    <c:dispBlanksAs val="span"/>
+  </c:chart>
+  <c:spPr>
+    <a:noFill/>
+    <a:ln>
+      <a:noFill/>
+    </a:ln>
+    <a:effectLst/>
+  </c:spPr>
+  <c:externalData r:id="rId1">
+    <c:autoUpdate val="0"/>
+  </c:externalData>
+</c:chartSpace>
+</file>
+
 <file path=ppt/notesMasters/notesMaster1.xml><?xml version="1.0" encoding="utf-8"?>
 <p:notesMaster xmlns:a="http://schemas.openxmlformats.org/drawingml/2006/main" xmlns:r="http://schemas.openxmlformats.org/officeDocument/2006/relationships" xmlns:p="http://schemas.openxmlformats.org/presentationml/2006/main">
   <p:cSld>
@@ -1763,6 +2119,182 @@
             <a:fld id="{F7021451-1387-4CA6-816F-3879F97B5CBC}" type="slidenum">
               <a:rPr lang="en-US"/>
               <a:t>10</a:t>
+            </a:fld>
+            <a:endParaRPr lang="en-US"/>
+          </a:p>
+        </p:txBody>
+      </p:sp>
+    </p:spTree>
+    <p:extLst>
+      <p:ext uri="{BB962C8B-B14F-4D97-AF65-F5344CB8AC3E}">
+        <p14:creationId xmlns:p14="http://schemas.microsoft.com/office/powerpoint/2010/main" val="1024086991"/>
+      </p:ext>
+    </p:extLst>
+  </p:cSld>
+  <p:clrMapOvr>
+    <a:masterClrMapping/>
+  </p:clrMapOvr>
+</p:notes>
+</file>
+
+<file path=ppt/notesSlides/notesSlide11.xml><?xml version="1.0" encoding="utf-8"?>
+<p:notes xmlns:a="http://schemas.openxmlformats.org/drawingml/2006/main" xmlns:r="http://schemas.openxmlformats.org/officeDocument/2006/relationships" xmlns:p="http://schemas.openxmlformats.org/presentationml/2006/main">
+  <p:cSld>
+    <p:spTree>
+      <p:nvGrpSpPr>
+        <p:cNvPr id="1" name=""/>
+        <p:cNvGrpSpPr/>
+        <p:nvPr/>
+      </p:nvGrpSpPr>
+      <p:grpSpPr>
+        <a:xfrm>
+          <a:off x="0" y="0"/>
+          <a:ext cx="0" cy="0"/>
+          <a:chOff x="0" y="0"/>
+          <a:chExt cx="0" cy="0"/>
+        </a:xfrm>
+      </p:grpSpPr>
+      <p:sp>
+        <p:nvSpPr>
+          <p:cNvPr id="2" name="Slide Image Placeholder 1"/>
+          <p:cNvSpPr>
+            <a:spLocks noGrp="1" noRot="1" noChangeAspect="1"/>
+          </p:cNvSpPr>
+          <p:nvPr>
+            <p:ph type="sldImg"/>
+          </p:nvPr>
+        </p:nvSpPr>
+        <p:spPr/>
+      </p:sp>
+      <p:sp>
+        <p:nvSpPr>
+          <p:cNvPr id="3" name="Notes Placeholder 2"/>
+          <p:cNvSpPr>
+            <a:spLocks noGrp="1"/>
+          </p:cNvSpPr>
+          <p:nvPr>
+            <p:ph type="body" idx="1"/>
+          </p:nvPr>
+        </p:nvSpPr>
+        <p:spPr/>
+        <p:txBody>
+          <a:bodyPr/>
+          <a:lstStyle/>
+          <a:p>
+            <a:r>
+              <a:rPr lang="en-US" dirty="0"/>
+              <a:t/>
+            </a:r>
+            <a:endParaRPr lang="en-US" dirty="0"/>
+          </a:p>
+        </p:txBody>
+      </p:sp>
+      <p:sp>
+        <p:nvSpPr>
+          <p:cNvPr id="4" name="Slide Number Placeholder 3"/>
+          <p:cNvSpPr>
+            <a:spLocks noGrp="1"/>
+          </p:cNvSpPr>
+          <p:nvPr>
+            <p:ph type="sldNum" sz="quarter" idx="10"/>
+          </p:nvPr>
+        </p:nvSpPr>
+        <p:spPr/>
+        <p:txBody>
+          <a:bodyPr/>
+          <a:lstStyle/>
+          <a:p>
+            <a:fld id="{F7021451-1387-4CA6-816F-3879F97B5CBC}" type="slidenum">
+              <a:rPr lang="en-US"/>
+              <a:t>11</a:t>
+            </a:fld>
+            <a:endParaRPr lang="en-US"/>
+          </a:p>
+        </p:txBody>
+      </p:sp>
+    </p:spTree>
+    <p:extLst>
+      <p:ext uri="{BB962C8B-B14F-4D97-AF65-F5344CB8AC3E}">
+        <p14:creationId xmlns:p14="http://schemas.microsoft.com/office/powerpoint/2010/main" val="1024086991"/>
+      </p:ext>
+    </p:extLst>
+  </p:cSld>
+  <p:clrMapOvr>
+    <a:masterClrMapping/>
+  </p:clrMapOvr>
+</p:notes>
+</file>
+
+<file path=ppt/notesSlides/notesSlide12.xml><?xml version="1.0" encoding="utf-8"?>
+<p:notes xmlns:a="http://schemas.openxmlformats.org/drawingml/2006/main" xmlns:r="http://schemas.openxmlformats.org/officeDocument/2006/relationships" xmlns:p="http://schemas.openxmlformats.org/presentationml/2006/main">
+  <p:cSld>
+    <p:spTree>
+      <p:nvGrpSpPr>
+        <p:cNvPr id="1" name=""/>
+        <p:cNvGrpSpPr/>
+        <p:nvPr/>
+      </p:nvGrpSpPr>
+      <p:grpSpPr>
+        <a:xfrm>
+          <a:off x="0" y="0"/>
+          <a:ext cx="0" cy="0"/>
+          <a:chOff x="0" y="0"/>
+          <a:chExt cx="0" cy="0"/>
+        </a:xfrm>
+      </p:grpSpPr>
+      <p:sp>
+        <p:nvSpPr>
+          <p:cNvPr id="2" name="Slide Image Placeholder 1"/>
+          <p:cNvSpPr>
+            <a:spLocks noGrp="1" noRot="1" noChangeAspect="1"/>
+          </p:cNvSpPr>
+          <p:nvPr>
+            <p:ph type="sldImg"/>
+          </p:nvPr>
+        </p:nvSpPr>
+        <p:spPr/>
+      </p:sp>
+      <p:sp>
+        <p:nvSpPr>
+          <p:cNvPr id="3" name="Notes Placeholder 2"/>
+          <p:cNvSpPr>
+            <a:spLocks noGrp="1"/>
+          </p:cNvSpPr>
+          <p:nvPr>
+            <p:ph type="body" idx="1"/>
+          </p:nvPr>
+        </p:nvSpPr>
+        <p:spPr/>
+        <p:txBody>
+          <a:bodyPr/>
+          <a:lstStyle/>
+          <a:p>
+            <a:r>
+              <a:rPr lang="en-US" dirty="0"/>
+              <a:t/>
+            </a:r>
+            <a:endParaRPr lang="en-US" dirty="0"/>
+          </a:p>
+        </p:txBody>
+      </p:sp>
+      <p:sp>
+        <p:nvSpPr>
+          <p:cNvPr id="4" name="Slide Number Placeholder 3"/>
+          <p:cNvSpPr>
+            <a:spLocks noGrp="1"/>
+          </p:cNvSpPr>
+          <p:nvPr>
+            <p:ph type="sldNum" sz="quarter" idx="10"/>
+          </p:nvPr>
+        </p:nvSpPr>
+        <p:spPr/>
+        <p:txBody>
+          <a:bodyPr/>
+          <a:lstStyle/>
+          <a:p>
+            <a:fld id="{F7021451-1387-4CA6-816F-3879F97B5CBC}" type="slidenum">
+              <a:rPr lang="en-US"/>
+              <a:t>12</a:t>
             </a:fld>
             <a:endParaRPr lang="en-US"/>
           </a:p>
@@ -2947,6 +3479,2158 @@
     <p:bg>
       <p:bgPr>
         <a:solidFill>
+          <a:srgbClr val="FFFFFF"/>
+        </a:solidFill>
+      </p:bgPr>
+    </p:bg>
+    <p:spTree>
+      <p:nvGrpSpPr>
+        <p:cNvPr id="1" name=""/>
+        <p:cNvGrpSpPr/>
+        <p:nvPr/>
+      </p:nvGrpSpPr>
+      <p:grpSpPr>
+        <a:xfrm>
+          <a:off x="0" y="0"/>
+          <a:ext cx="0" cy="0"/>
+          <a:chOff x="0" y="0"/>
+          <a:chExt cx="0" cy="0"/>
+        </a:xfrm>
+      </p:grpSpPr>
+      <p:sp>
+        <p:nvSpPr>
+          <p:cNvPr id="2" name="Text 0"/>
+          <p:cNvSpPr/>
+          <p:nvPr/>
+        </p:nvSpPr>
+        <p:spPr>
+          <a:xfrm>
+            <a:off x="548640" y="320040"/>
+            <a:ext cx="11064240" cy="685800"/>
+          </a:xfrm>
+          <a:prstGeom prst="rect">
+            <a:avLst/>
+          </a:prstGeom>
+          <a:noFill/>
+          <a:ln/>
+        </p:spPr>
+        <p:txBody>
+          <a:bodyPr wrap="square" lIns="0" tIns="0" rIns="0" bIns="0" rtlCol="0" anchor="ctr"/>
+          <a:lstStyle/>
+          <a:p>
+            <a:pPr indent="0" marL="0">
+              <a:buNone/>
+            </a:pPr>
+            <a:r>
+              <a:rPr lang="en-US" sz="3000" b="1" dirty="0">
+                <a:solidFill>
+                  <a:srgbClr val="0E3B2E"/>
+                </a:solidFill>
+                <a:latin typeface="Cambria" pitchFamily="34" charset="0"/>
+                <a:ea typeface="Cambria" pitchFamily="34" charset="-122"/>
+                <a:cs typeface="Cambria" pitchFamily="34" charset="-120"/>
+              </a:rPr>
+              <a:t>Supply check: higher blends CURE the distillery overcapacity</a:t>
+            </a:r>
+            <a:endParaRPr lang="en-US" sz="3000" dirty="0"/>
+          </a:p>
+        </p:txBody>
+      </p:sp>
+      <p:sp>
+        <p:nvSpPr>
+          <p:cNvPr id="3" name="Text 1"/>
+          <p:cNvSpPr/>
+          <p:nvPr/>
+        </p:nvSpPr>
+        <p:spPr>
+          <a:xfrm>
+            <a:off x="548640" y="932688"/>
+            <a:ext cx="11064240" cy="365760"/>
+          </a:xfrm>
+          <a:prstGeom prst="rect">
+            <a:avLst/>
+          </a:prstGeom>
+          <a:noFill/>
+          <a:ln/>
+        </p:spPr>
+        <p:txBody>
+          <a:bodyPr wrap="square" lIns="0" tIns="0" rIns="0" bIns="0" rtlCol="0" anchor="ctr"/>
+          <a:lstStyle/>
+          <a:p>
+            <a:pPr indent="0" marL="0">
+              <a:buNone/>
+            </a:pPr>
+            <a:r>
+              <a:rPr lang="en-US" sz="1300" dirty="0">
+                <a:solidFill>
+                  <a:srgbClr val="5C6B66"/>
+                </a:solidFill>
+                <a:latin typeface="Calibri" pitchFamily="34" charset="0"/>
+                <a:ea typeface="Calibri" pitchFamily="34" charset="-122"/>
+                <a:cs typeface="Calibri" pitchFamily="34" charset="-120"/>
+              </a:rPr>
+              <a:t>Capacity utilisation = (fuel + non-fuel ethanol demand) ÷ capacity · CareEdge Ratings May-2026 supply data</a:t>
+            </a:r>
+            <a:endParaRPr lang="en-US" sz="1300" dirty="0"/>
+          </a:p>
+        </p:txBody>
+      </p:sp>
+      <p:graphicFrame>
+        <p:nvGraphicFramePr>
+          <p:cNvPr id="4" name="Chart 0" descr=""/>
+          <p:cNvGraphicFramePr/>
+          <p:nvPr/>
+        </p:nvGraphicFramePr>
+        <p:xfrm>
+          <a:off x="548640" y="1508760"/>
+          <a:ext cx="6766560" cy="4846320"/>
+        </p:xfrm>
+        <a:graphic xmlns:a="http://schemas.openxmlformats.org/drawingml/2006/main">
+          <a:graphicData uri="http://schemas.openxmlformats.org/drawingml/2006/chart">
+            <c:chart xmlns:c="http://schemas.openxmlformats.org/drawingml/2006/chart" r:id="rId1"/>
+          </a:graphicData>
+        </a:graphic>
+      </p:graphicFrame>
+      <p:sp>
+        <p:nvSpPr>
+          <p:cNvPr id="5" name="Shape 2"/>
+          <p:cNvSpPr/>
+          <p:nvPr/>
+        </p:nvSpPr>
+        <p:spPr>
+          <a:xfrm>
+            <a:off x="7589520" y="1508760"/>
+            <a:ext cx="4069080" cy="4846320"/>
+          </a:xfrm>
+          <a:prstGeom prst="roundRect">
+            <a:avLst>
+              <a:gd name="adj" fmla="val 1798"/>
+            </a:avLst>
+          </a:prstGeom>
+          <a:solidFill>
+            <a:srgbClr val="F2F6F4"/>
+          </a:solidFill>
+          <a:ln w="9525">
+            <a:solidFill>
+              <a:srgbClr val="D5E0DB"/>
+            </a:solidFill>
+            <a:prstDash val="solid"/>
+          </a:ln>
+        </p:spPr>
+      </p:sp>
+      <p:sp>
+        <p:nvSpPr>
+          <p:cNvPr id="6" name="Text 3"/>
+          <p:cNvSpPr/>
+          <p:nvPr/>
+        </p:nvSpPr>
+        <p:spPr>
+          <a:xfrm>
+            <a:off x="7818120" y="1737360"/>
+            <a:ext cx="3611880" cy="4480560"/>
+          </a:xfrm>
+          <a:prstGeom prst="rect">
+            <a:avLst/>
+          </a:prstGeom>
+          <a:noFill/>
+          <a:ln/>
+        </p:spPr>
+        <p:txBody>
+          <a:bodyPr wrap="square" lIns="0" tIns="0" rIns="0" bIns="0" rtlCol="0" anchor="t"/>
+          <a:lstStyle/>
+          <a:p>
+            <a:pPr marL="177800" indent="-177800">
+              <a:spcAft>
+                <a:spcPts val="800"/>
+              </a:spcAft>
+              <a:buSzPct val="100000"/>
+              <a:buChar char="•"/>
+            </a:pPr>
+            <a:r>
+              <a:rPr lang="en-US" sz="1150" dirty="0">
+                <a:solidFill>
+                  <a:srgbClr val="1C2B27"/>
+                </a:solidFill>
+                <a:latin typeface="Calibri" pitchFamily="34" charset="0"/>
+                <a:ea typeface="Calibri" pitchFamily="34" charset="-122"/>
+                <a:cs typeface="Calibri" pitchFamily="34" charset="-120"/>
+              </a:rPr>
+              <a:t>Installed ~2,000 cr L (+400 by FY27); at E20 only ~60% of offered ethanol is absorbed — CareEdge sees 65–75% utilisation for 3 years</a:t>
+            </a:r>
+            <a:endParaRPr lang="en-US" sz="1150" dirty="0"/>
+          </a:p>
+          <a:p>
+            <a:pPr marL="177800" indent="-177800">
+              <a:spcAft>
+                <a:spcPts val="800"/>
+              </a:spcAft>
+              <a:buSzPct val="100000"/>
+              <a:buChar char="•"/>
+            </a:pPr>
+            <a:r>
+              <a:rPr lang="en-US" sz="1150" dirty="0">
+                <a:solidFill>
+                  <a:srgbClr val="1C2B27"/>
+                </a:solidFill>
+                <a:latin typeface="Calibri" pitchFamily="34" charset="0"/>
+                <a:ea typeface="Calibri" pitchFamily="34" charset="-122"/>
+                <a:cs typeface="Calibri" pitchFamily="34" charset="-120"/>
+              </a:rPr>
+              <a:t>E27 lifts utilisation to 76% — top of the band, absorbs Maharashtra's +277 cr L surplus, zero new construction</a:t>
+            </a:r>
+            <a:endParaRPr lang="en-US" sz="1150" dirty="0"/>
+          </a:p>
+          <a:p>
+            <a:pPr marL="177800" indent="-177800">
+              <a:spcAft>
+                <a:spcPts val="800"/>
+              </a:spcAft>
+              <a:buSzPct val="100000"/>
+              <a:buChar char="•"/>
+            </a:pPr>
+            <a:r>
+              <a:rPr lang="en-US" sz="1150" dirty="0">
+                <a:solidFill>
+                  <a:srgbClr val="1C2B27"/>
+                </a:solidFill>
+                <a:latin typeface="Calibri" pitchFamily="34" charset="0"/>
+                <a:ea typeface="Calibri" pitchFamily="34" charset="-122"/>
+                <a:cs typeface="Calibri" pitchFamily="34" charset="-120"/>
+              </a:rPr>
+              <a:t>Coop-mill scheme ≠ capacity: of ₹10,005 cr NCDC gave 56 mills, 96.5% is working capital; the ₹251 cr ethanol tranche ≈ 9.7 cr L/yr (0.5% of installed)</a:t>
+            </a:r>
+            <a:endParaRPr lang="en-US" sz="1150" dirty="0"/>
+          </a:p>
+          <a:p>
+            <a:pPr marL="177800" indent="-177800">
+              <a:spcAft>
+                <a:spcPts val="800"/>
+              </a:spcAft>
+              <a:buSzPct val="100000"/>
+              <a:buChar char="•"/>
+            </a:pPr>
+            <a:r>
+              <a:rPr lang="en-US" sz="1150" dirty="0">
+                <a:solidFill>
+                  <a:srgbClr val="1C2B27"/>
+                </a:solidFill>
+                <a:latin typeface="Calibri" pitchFamily="34" charset="0"/>
+                <a:ea typeface="Calibri" pitchFamily="34" charset="-122"/>
+                <a:cs typeface="Calibri" pitchFamily="34" charset="-120"/>
+              </a:rPr>
+              <a:t>FCI rice leg ~211 cr L (3.9 blend pts, Jul-2023 suspension risk) — the E27/E30 increment rides on open-market maize, the dearest slab</a:t>
+            </a:r>
+            <a:endParaRPr lang="en-US" sz="1150" dirty="0"/>
+          </a:p>
+          <a:p>
+            <a:pPr marL="177800" indent="-177800">
+              <a:spcAft>
+                <a:spcPts val="800"/>
+              </a:spcAft>
+              <a:buSzPct val="100000"/>
+              <a:buChar char="•"/>
+            </a:pPr>
+            <a:r>
+              <a:rPr lang="en-US" sz="1150" dirty="0">
+                <a:solidFill>
+                  <a:srgbClr val="1C2B27"/>
+                </a:solidFill>
+                <a:latin typeface="Calibri" pitchFamily="34" charset="0"/>
+                <a:ea typeface="Calibri" pitchFamily="34" charset="-122"/>
+                <a:cs typeface="Calibri" pitchFamily="34" charset="-120"/>
+              </a:rPr>
+              <a:t>Demand-grown E30 (FY31, 2,173 cr L) hits ~104% — only then does the 4,530 cr L DFPD sanction register need to build</a:t>
+            </a:r>
+            <a:endParaRPr lang="en-US" sz="1150" dirty="0"/>
+          </a:p>
+        </p:txBody>
+      </p:sp>
+    </p:spTree>
+  </p:cSld>
+  <p:clrMapOvr>
+    <a:masterClrMapping/>
+  </p:clrMapOvr>
+</p:sld>
+</file>
+
+<file path=ppt/slides/slide11.xml><?xml version="1.0" encoding="utf-8"?>
+<p:sld xmlns:a="http://schemas.openxmlformats.org/drawingml/2006/main" xmlns:r="http://schemas.openxmlformats.org/officeDocument/2006/relationships" xmlns:p="http://schemas.openxmlformats.org/presentationml/2006/main">
+  <p:cSld name="Slide 11">
+    <p:bg>
+      <p:bgPr>
+        <a:solidFill>
+          <a:srgbClr val="FFFFFF"/>
+        </a:solidFill>
+      </p:bgPr>
+    </p:bg>
+    <p:spTree>
+      <p:nvGrpSpPr>
+        <p:cNvPr id="1" name=""/>
+        <p:cNvGrpSpPr/>
+        <p:nvPr/>
+      </p:nvGrpSpPr>
+      <p:grpSpPr>
+        <a:xfrm>
+          <a:off x="0" y="0"/>
+          <a:ext cx="0" cy="0"/>
+          <a:chOff x="0" y="0"/>
+          <a:chExt cx="0" cy="0"/>
+        </a:xfrm>
+      </p:grpSpPr>
+      <p:sp>
+        <p:nvSpPr>
+          <p:cNvPr id="2" name="Text 0"/>
+          <p:cNvSpPr/>
+          <p:nvPr/>
+        </p:nvSpPr>
+        <p:spPr>
+          <a:xfrm>
+            <a:off x="548640" y="320040"/>
+            <a:ext cx="11064240" cy="685800"/>
+          </a:xfrm>
+          <a:prstGeom prst="rect">
+            <a:avLst/>
+          </a:prstGeom>
+          <a:noFill/>
+          <a:ln/>
+        </p:spPr>
+        <p:txBody>
+          <a:bodyPr wrap="square" lIns="0" tIns="0" rIns="0" bIns="0" rtlCol="0" anchor="ctr"/>
+          <a:lstStyle/>
+          <a:p>
+            <a:pPr indent="0" marL="0">
+              <a:buNone/>
+            </a:pPr>
+            <a:r>
+              <a:rPr lang="en-US" sz="3000" b="1" dirty="0">
+                <a:solidFill>
+                  <a:srgbClr val="0E3B2E"/>
+                </a:solidFill>
+                <a:latin typeface="Cambria" pitchFamily="34" charset="0"/>
+                <a:ea typeface="Cambria" pitchFamily="34" charset="-122"/>
+                <a:cs typeface="Cambria" pitchFamily="34" charset="-120"/>
+              </a:rPr>
+              <a:t>The RON95 dividend: octane the consumer never sees</a:t>
+            </a:r>
+            <a:endParaRPr lang="en-US" sz="3000" dirty="0"/>
+          </a:p>
+        </p:txBody>
+      </p:sp>
+      <p:sp>
+        <p:nvSpPr>
+          <p:cNvPr id="3" name="Text 1"/>
+          <p:cNvSpPr/>
+          <p:nvPr/>
+        </p:nvSpPr>
+        <p:spPr>
+          <a:xfrm>
+            <a:off x="548640" y="932688"/>
+            <a:ext cx="11064240" cy="365760"/>
+          </a:xfrm>
+          <a:prstGeom prst="rect">
+            <a:avLst/>
+          </a:prstGeom>
+          <a:noFill/>
+          <a:ln/>
+        </p:spPr>
+        <p:txBody>
+          <a:bodyPr wrap="square" lIns="0" tIns="0" rIns="0" bIns="0" rtlCol="0" anchor="ctr"/>
+          <a:lstStyle/>
+          <a:p>
+            <a:pPr indent="0" marL="0">
+              <a:buNone/>
+            </a:pPr>
+            <a:r>
+              <a:rPr lang="en-US" sz="1300" dirty="0">
+                <a:solidFill>
+                  <a:srgbClr val="5C6B66"/>
+                </a:solidFill>
+                <a:latin typeface="Calibri" pitchFamily="34" charset="0"/>
+                <a:ea typeface="Calibri" pitchFamily="34" charset="-122"/>
+                <a:cs typeface="Calibri" pitchFamily="34" charset="-120"/>
+              </a:rPr>
+              <a:t>RON = knock resistance (regular petrol 91, premium 95) · ethanol blending RON ~112 · BOB = the petrol base before blending</a:t>
+            </a:r>
+            <a:endParaRPr lang="en-US" sz="1300" dirty="0"/>
+          </a:p>
+        </p:txBody>
+      </p:sp>
+      <p:sp>
+        <p:nvSpPr>
+          <p:cNvPr id="4" name="Shape 2"/>
+          <p:cNvSpPr/>
+          <p:nvPr/>
+        </p:nvSpPr>
+        <p:spPr>
+          <a:xfrm>
+            <a:off x="548640" y="1600200"/>
+            <a:ext cx="1097280" cy="512064"/>
+          </a:xfrm>
+          <a:prstGeom prst="rect">
+            <a:avLst/>
+          </a:prstGeom>
+          <a:solidFill>
+            <a:srgbClr val="0E3B2E"/>
+          </a:solidFill>
+          <a:ln w="9525">
+            <a:solidFill>
+              <a:srgbClr val="D5E0DB"/>
+            </a:solidFill>
+            <a:prstDash val="solid"/>
+          </a:ln>
+        </p:spPr>
+      </p:sp>
+      <p:sp>
+        <p:nvSpPr>
+          <p:cNvPr id="5" name="Text 3"/>
+          <p:cNvSpPr/>
+          <p:nvPr/>
+        </p:nvSpPr>
+        <p:spPr>
+          <a:xfrm>
+            <a:off x="621792" y="1600200"/>
+            <a:ext cx="950976" cy="512064"/>
+          </a:xfrm>
+          <a:prstGeom prst="rect">
+            <a:avLst/>
+          </a:prstGeom>
+          <a:noFill/>
+          <a:ln/>
+        </p:spPr>
+        <p:txBody>
+          <a:bodyPr wrap="square" lIns="0" tIns="0" rIns="0" bIns="0" rtlCol="0" anchor="ctr"/>
+          <a:lstStyle/>
+          <a:p>
+            <a:pPr algn="l" indent="0" marL="0">
+              <a:buNone/>
+            </a:pPr>
+            <a:r>
+              <a:rPr lang="en-US" sz="1150" b="1" dirty="0">
+                <a:solidFill>
+                  <a:srgbClr val="FFFFFF"/>
+                </a:solidFill>
+                <a:latin typeface="Calibri" pitchFamily="34" charset="0"/>
+                <a:ea typeface="Calibri" pitchFamily="34" charset="-122"/>
+                <a:cs typeface="Calibri" pitchFamily="34" charset="-120"/>
+              </a:rPr>
+              <a:t>Blend</a:t>
+            </a:r>
+            <a:endParaRPr lang="en-US" sz="1150" dirty="0"/>
+          </a:p>
+        </p:txBody>
+      </p:sp>
+      <p:sp>
+        <p:nvSpPr>
+          <p:cNvPr id="6" name="Shape 4"/>
+          <p:cNvSpPr/>
+          <p:nvPr/>
+        </p:nvSpPr>
+        <p:spPr>
+          <a:xfrm>
+            <a:off x="1737360" y="1600200"/>
+            <a:ext cx="2743200" cy="512064"/>
+          </a:xfrm>
+          <a:prstGeom prst="rect">
+            <a:avLst/>
+          </a:prstGeom>
+          <a:solidFill>
+            <a:srgbClr val="0E3B2E"/>
+          </a:solidFill>
+          <a:ln w="9525">
+            <a:solidFill>
+              <a:srgbClr val="D5E0DB"/>
+            </a:solidFill>
+            <a:prstDash val="solid"/>
+          </a:ln>
+        </p:spPr>
+      </p:sp>
+      <p:sp>
+        <p:nvSpPr>
+          <p:cNvPr id="7" name="Text 5"/>
+          <p:cNvSpPr/>
+          <p:nvPr/>
+        </p:nvSpPr>
+        <p:spPr>
+          <a:xfrm>
+            <a:off x="1810512" y="1600200"/>
+            <a:ext cx="2596896" cy="512064"/>
+          </a:xfrm>
+          <a:prstGeom prst="rect">
+            <a:avLst/>
+          </a:prstGeom>
+          <a:noFill/>
+          <a:ln/>
+        </p:spPr>
+        <p:txBody>
+          <a:bodyPr wrap="square" lIns="0" tIns="0" rIns="0" bIns="0" rtlCol="0" anchor="ctr"/>
+          <a:lstStyle/>
+          <a:p>
+            <a:pPr algn="ctr" indent="0" marL="0">
+              <a:buNone/>
+            </a:pPr>
+            <a:r>
+              <a:rPr lang="en-US" sz="1150" b="1" dirty="0">
+                <a:solidFill>
+                  <a:srgbClr val="FFFFFF"/>
+                </a:solidFill>
+                <a:latin typeface="Calibri" pitchFamily="34" charset="0"/>
+                <a:ea typeface="Calibri" pitchFamily="34" charset="-122"/>
+                <a:cs typeface="Calibri" pitchFamily="34" charset="-120"/>
+              </a:rPr>
+              <a:t>BOB needed if pump stays RON 91</a:t>
+            </a:r>
+            <a:endParaRPr lang="en-US" sz="1150" dirty="0"/>
+          </a:p>
+        </p:txBody>
+      </p:sp>
+      <p:sp>
+        <p:nvSpPr>
+          <p:cNvPr id="8" name="Shape 6"/>
+          <p:cNvSpPr/>
+          <p:nvPr/>
+        </p:nvSpPr>
+        <p:spPr>
+          <a:xfrm>
+            <a:off x="4572000" y="1600200"/>
+            <a:ext cx="2743200" cy="512064"/>
+          </a:xfrm>
+          <a:prstGeom prst="rect">
+            <a:avLst/>
+          </a:prstGeom>
+          <a:solidFill>
+            <a:srgbClr val="0E3B2E"/>
+          </a:solidFill>
+          <a:ln w="9525">
+            <a:solidFill>
+              <a:srgbClr val="D5E0DB"/>
+            </a:solidFill>
+            <a:prstDash val="solid"/>
+          </a:ln>
+        </p:spPr>
+      </p:sp>
+      <p:sp>
+        <p:nvSpPr>
+          <p:cNvPr id="9" name="Text 7"/>
+          <p:cNvSpPr/>
+          <p:nvPr/>
+        </p:nvSpPr>
+        <p:spPr>
+          <a:xfrm>
+            <a:off x="4645152" y="1600200"/>
+            <a:ext cx="2596896" cy="512064"/>
+          </a:xfrm>
+          <a:prstGeom prst="rect">
+            <a:avLst/>
+          </a:prstGeom>
+          <a:noFill/>
+          <a:ln/>
+        </p:spPr>
+        <p:txBody>
+          <a:bodyPr wrap="square" lIns="0" tIns="0" rIns="0" bIns="0" rtlCol="0" anchor="ctr"/>
+          <a:lstStyle/>
+          <a:p>
+            <a:pPr algn="ctr" indent="0" marL="0">
+              <a:buNone/>
+            </a:pPr>
+            <a:r>
+              <a:rPr lang="en-US" sz="1150" b="1" dirty="0">
+                <a:solidFill>
+                  <a:srgbClr val="FFFFFF"/>
+                </a:solidFill>
+                <a:latin typeface="Calibri" pitchFamily="34" charset="0"/>
+                <a:ea typeface="Calibri" pitchFamily="34" charset="-122"/>
+                <a:cs typeface="Calibri" pitchFamily="34" charset="-120"/>
+              </a:rPr>
+              <a:t>Pump RON if BOB stays 91</a:t>
+            </a:r>
+            <a:endParaRPr lang="en-US" sz="1150" dirty="0"/>
+          </a:p>
+        </p:txBody>
+      </p:sp>
+      <p:sp>
+        <p:nvSpPr>
+          <p:cNvPr id="10" name="Shape 8"/>
+          <p:cNvSpPr/>
+          <p:nvPr/>
+        </p:nvSpPr>
+        <p:spPr>
+          <a:xfrm>
+            <a:off x="7406640" y="1600200"/>
+            <a:ext cx="1554480" cy="512064"/>
+          </a:xfrm>
+          <a:prstGeom prst="rect">
+            <a:avLst/>
+          </a:prstGeom>
+          <a:solidFill>
+            <a:srgbClr val="0E3B2E"/>
+          </a:solidFill>
+          <a:ln w="9525">
+            <a:solidFill>
+              <a:srgbClr val="D5E0DB"/>
+            </a:solidFill>
+            <a:prstDash val="solid"/>
+          </a:ln>
+        </p:spPr>
+      </p:sp>
+      <p:sp>
+        <p:nvSpPr>
+          <p:cNvPr id="11" name="Text 9"/>
+          <p:cNvSpPr/>
+          <p:nvPr/>
+        </p:nvSpPr>
+        <p:spPr>
+          <a:xfrm>
+            <a:off x="7479792" y="1600200"/>
+            <a:ext cx="1408176" cy="512064"/>
+          </a:xfrm>
+          <a:prstGeom prst="rect">
+            <a:avLst/>
+          </a:prstGeom>
+          <a:noFill/>
+          <a:ln/>
+        </p:spPr>
+        <p:txBody>
+          <a:bodyPr wrap="square" lIns="0" tIns="0" rIns="0" bIns="0" rtlCol="0" anchor="ctr"/>
+          <a:lstStyle/>
+          <a:p>
+            <a:pPr algn="ctr" indent="0" marL="0">
+              <a:buNone/>
+            </a:pPr>
+            <a:r>
+              <a:rPr lang="en-US" sz="1150" b="1" dirty="0">
+                <a:solidFill>
+                  <a:srgbClr val="FFFFFF"/>
+                </a:solidFill>
+                <a:latin typeface="Calibri" pitchFamily="34" charset="0"/>
+                <a:ea typeface="Calibri" pitchFamily="34" charset="-122"/>
+                <a:cs typeface="Calibri" pitchFamily="34" charset="-120"/>
+              </a:rPr>
+              <a:t>Octane credit ₹/L*</a:t>
+            </a:r>
+            <a:endParaRPr lang="en-US" sz="1150" dirty="0"/>
+          </a:p>
+        </p:txBody>
+      </p:sp>
+      <p:sp>
+        <p:nvSpPr>
+          <p:cNvPr id="12" name="Shape 10"/>
+          <p:cNvSpPr/>
+          <p:nvPr/>
+        </p:nvSpPr>
+        <p:spPr>
+          <a:xfrm>
+            <a:off x="548640" y="2167128"/>
+            <a:ext cx="1097280" cy="512064"/>
+          </a:xfrm>
+          <a:prstGeom prst="rect">
+            <a:avLst/>
+          </a:prstGeom>
+          <a:solidFill>
+            <a:srgbClr val="F2F6F4"/>
+          </a:solidFill>
+          <a:ln w="9525">
+            <a:solidFill>
+              <a:srgbClr val="D5E0DB"/>
+            </a:solidFill>
+            <a:prstDash val="solid"/>
+          </a:ln>
+        </p:spPr>
+      </p:sp>
+      <p:sp>
+        <p:nvSpPr>
+          <p:cNvPr id="13" name="Text 11"/>
+          <p:cNvSpPr/>
+          <p:nvPr/>
+        </p:nvSpPr>
+        <p:spPr>
+          <a:xfrm>
+            <a:off x="621792" y="2167128"/>
+            <a:ext cx="950976" cy="512064"/>
+          </a:xfrm>
+          <a:prstGeom prst="rect">
+            <a:avLst/>
+          </a:prstGeom>
+          <a:noFill/>
+          <a:ln/>
+        </p:spPr>
+        <p:txBody>
+          <a:bodyPr wrap="square" lIns="0" tIns="0" rIns="0" bIns="0" rtlCol="0" anchor="ctr"/>
+          <a:lstStyle/>
+          <a:p>
+            <a:pPr algn="l" indent="0" marL="0">
+              <a:buNone/>
+            </a:pPr>
+            <a:r>
+              <a:rPr lang="en-US" sz="1300" b="1" dirty="0">
+                <a:solidFill>
+                  <a:srgbClr val="1C2B27"/>
+                </a:solidFill>
+                <a:latin typeface="Calibri" pitchFamily="34" charset="0"/>
+                <a:ea typeface="Calibri" pitchFamily="34" charset="-122"/>
+                <a:cs typeface="Calibri" pitchFamily="34" charset="-120"/>
+              </a:rPr>
+              <a:t>E10</a:t>
+            </a:r>
+            <a:endParaRPr lang="en-US" sz="1300" dirty="0"/>
+          </a:p>
+        </p:txBody>
+      </p:sp>
+      <p:sp>
+        <p:nvSpPr>
+          <p:cNvPr id="14" name="Shape 12"/>
+          <p:cNvSpPr/>
+          <p:nvPr/>
+        </p:nvSpPr>
+        <p:spPr>
+          <a:xfrm>
+            <a:off x="1737360" y="2167128"/>
+            <a:ext cx="2743200" cy="512064"/>
+          </a:xfrm>
+          <a:prstGeom prst="rect">
+            <a:avLst/>
+          </a:prstGeom>
+          <a:solidFill>
+            <a:srgbClr val="F2F6F4"/>
+          </a:solidFill>
+          <a:ln w="9525">
+            <a:solidFill>
+              <a:srgbClr val="D5E0DB"/>
+            </a:solidFill>
+            <a:prstDash val="solid"/>
+          </a:ln>
+        </p:spPr>
+      </p:sp>
+      <p:sp>
+        <p:nvSpPr>
+          <p:cNvPr id="15" name="Text 13"/>
+          <p:cNvSpPr/>
+          <p:nvPr/>
+        </p:nvSpPr>
+        <p:spPr>
+          <a:xfrm>
+            <a:off x="1810512" y="2167128"/>
+            <a:ext cx="2596896" cy="512064"/>
+          </a:xfrm>
+          <a:prstGeom prst="rect">
+            <a:avLst/>
+          </a:prstGeom>
+          <a:noFill/>
+          <a:ln/>
+        </p:spPr>
+        <p:txBody>
+          <a:bodyPr wrap="square" lIns="0" tIns="0" rIns="0" bIns="0" rtlCol="0" anchor="ctr"/>
+          <a:lstStyle/>
+          <a:p>
+            <a:pPr algn="ctr" indent="0" marL="0">
+              <a:buNone/>
+            </a:pPr>
+            <a:r>
+              <a:rPr lang="en-US" sz="1300" dirty="0">
+                <a:solidFill>
+                  <a:srgbClr val="1C2B27"/>
+                </a:solidFill>
+                <a:latin typeface="Calibri" pitchFamily="34" charset="0"/>
+                <a:ea typeface="Calibri" pitchFamily="34" charset="-122"/>
+                <a:cs typeface="Calibri" pitchFamily="34" charset="-120"/>
+              </a:rPr>
+              <a:t>88.7</a:t>
+            </a:r>
+            <a:endParaRPr lang="en-US" sz="1300" dirty="0"/>
+          </a:p>
+        </p:txBody>
+      </p:sp>
+      <p:sp>
+        <p:nvSpPr>
+          <p:cNvPr id="16" name="Shape 14"/>
+          <p:cNvSpPr/>
+          <p:nvPr/>
+        </p:nvSpPr>
+        <p:spPr>
+          <a:xfrm>
+            <a:off x="4572000" y="2167128"/>
+            <a:ext cx="2743200" cy="512064"/>
+          </a:xfrm>
+          <a:prstGeom prst="rect">
+            <a:avLst/>
+          </a:prstGeom>
+          <a:solidFill>
+            <a:srgbClr val="F2F6F4"/>
+          </a:solidFill>
+          <a:ln w="9525">
+            <a:solidFill>
+              <a:srgbClr val="D5E0DB"/>
+            </a:solidFill>
+            <a:prstDash val="solid"/>
+          </a:ln>
+        </p:spPr>
+      </p:sp>
+      <p:sp>
+        <p:nvSpPr>
+          <p:cNvPr id="17" name="Text 15"/>
+          <p:cNvSpPr/>
+          <p:nvPr/>
+        </p:nvSpPr>
+        <p:spPr>
+          <a:xfrm>
+            <a:off x="4645152" y="2167128"/>
+            <a:ext cx="2596896" cy="512064"/>
+          </a:xfrm>
+          <a:prstGeom prst="rect">
+            <a:avLst/>
+          </a:prstGeom>
+          <a:noFill/>
+          <a:ln/>
+        </p:spPr>
+        <p:txBody>
+          <a:bodyPr wrap="square" lIns="0" tIns="0" rIns="0" bIns="0" rtlCol="0" anchor="ctr"/>
+          <a:lstStyle/>
+          <a:p>
+            <a:pPr algn="ctr" indent="0" marL="0">
+              <a:buNone/>
+            </a:pPr>
+            <a:r>
+              <a:rPr lang="en-US" sz="1300" dirty="0">
+                <a:solidFill>
+                  <a:srgbClr val="1C2B27"/>
+                </a:solidFill>
+                <a:latin typeface="Calibri" pitchFamily="34" charset="0"/>
+                <a:ea typeface="Calibri" pitchFamily="34" charset="-122"/>
+                <a:cs typeface="Calibri" pitchFamily="34" charset="-120"/>
+              </a:rPr>
+              <a:t>93.1</a:t>
+            </a:r>
+            <a:endParaRPr lang="en-US" sz="1300" dirty="0"/>
+          </a:p>
+        </p:txBody>
+      </p:sp>
+      <p:sp>
+        <p:nvSpPr>
+          <p:cNvPr id="18" name="Shape 16"/>
+          <p:cNvSpPr/>
+          <p:nvPr/>
+        </p:nvSpPr>
+        <p:spPr>
+          <a:xfrm>
+            <a:off x="7406640" y="2167128"/>
+            <a:ext cx="1554480" cy="512064"/>
+          </a:xfrm>
+          <a:prstGeom prst="rect">
+            <a:avLst/>
+          </a:prstGeom>
+          <a:solidFill>
+            <a:srgbClr val="F2F6F4"/>
+          </a:solidFill>
+          <a:ln w="9525">
+            <a:solidFill>
+              <a:srgbClr val="D5E0DB"/>
+            </a:solidFill>
+            <a:prstDash val="solid"/>
+          </a:ln>
+        </p:spPr>
+      </p:sp>
+      <p:sp>
+        <p:nvSpPr>
+          <p:cNvPr id="19" name="Text 17"/>
+          <p:cNvSpPr/>
+          <p:nvPr/>
+        </p:nvSpPr>
+        <p:spPr>
+          <a:xfrm>
+            <a:off x="7479792" y="2167128"/>
+            <a:ext cx="1408176" cy="512064"/>
+          </a:xfrm>
+          <a:prstGeom prst="rect">
+            <a:avLst/>
+          </a:prstGeom>
+          <a:noFill/>
+          <a:ln/>
+        </p:spPr>
+        <p:txBody>
+          <a:bodyPr wrap="square" lIns="0" tIns="0" rIns="0" bIns="0" rtlCol="0" anchor="ctr"/>
+          <a:lstStyle/>
+          <a:p>
+            <a:pPr algn="ctr" indent="0" marL="0">
+              <a:buNone/>
+            </a:pPr>
+            <a:r>
+              <a:rPr lang="en-US" sz="1300" dirty="0">
+                <a:solidFill>
+                  <a:srgbClr val="1C2B27"/>
+                </a:solidFill>
+                <a:latin typeface="Calibri" pitchFamily="34" charset="0"/>
+                <a:ea typeface="Calibri" pitchFamily="34" charset="-122"/>
+                <a:cs typeface="Calibri" pitchFamily="34" charset="-120"/>
+              </a:rPr>
+              <a:t>4.7</a:t>
+            </a:r>
+            <a:endParaRPr lang="en-US" sz="1300" dirty="0"/>
+          </a:p>
+        </p:txBody>
+      </p:sp>
+      <p:sp>
+        <p:nvSpPr>
+          <p:cNvPr id="20" name="Shape 18"/>
+          <p:cNvSpPr/>
+          <p:nvPr/>
+        </p:nvSpPr>
+        <p:spPr>
+          <a:xfrm>
+            <a:off x="548640" y="2734056"/>
+            <a:ext cx="1097280" cy="512064"/>
+          </a:xfrm>
+          <a:prstGeom prst="rect">
+            <a:avLst/>
+          </a:prstGeom>
+          <a:solidFill>
+            <a:srgbClr val="FFFFFF"/>
+          </a:solidFill>
+          <a:ln w="9525">
+            <a:solidFill>
+              <a:srgbClr val="D5E0DB"/>
+            </a:solidFill>
+            <a:prstDash val="solid"/>
+          </a:ln>
+        </p:spPr>
+      </p:sp>
+      <p:sp>
+        <p:nvSpPr>
+          <p:cNvPr id="21" name="Text 19"/>
+          <p:cNvSpPr/>
+          <p:nvPr/>
+        </p:nvSpPr>
+        <p:spPr>
+          <a:xfrm>
+            <a:off x="621792" y="2734056"/>
+            <a:ext cx="950976" cy="512064"/>
+          </a:xfrm>
+          <a:prstGeom prst="rect">
+            <a:avLst/>
+          </a:prstGeom>
+          <a:noFill/>
+          <a:ln/>
+        </p:spPr>
+        <p:txBody>
+          <a:bodyPr wrap="square" lIns="0" tIns="0" rIns="0" bIns="0" rtlCol="0" anchor="ctr"/>
+          <a:lstStyle/>
+          <a:p>
+            <a:pPr algn="l" indent="0" marL="0">
+              <a:buNone/>
+            </a:pPr>
+            <a:r>
+              <a:rPr lang="en-US" sz="1300" b="1" dirty="0">
+                <a:solidFill>
+                  <a:srgbClr val="1C2B27"/>
+                </a:solidFill>
+                <a:latin typeface="Calibri" pitchFamily="34" charset="0"/>
+                <a:ea typeface="Calibri" pitchFamily="34" charset="-122"/>
+                <a:cs typeface="Calibri" pitchFamily="34" charset="-120"/>
+              </a:rPr>
+              <a:t>E20</a:t>
+            </a:r>
+            <a:endParaRPr lang="en-US" sz="1300" dirty="0"/>
+          </a:p>
+        </p:txBody>
+      </p:sp>
+      <p:sp>
+        <p:nvSpPr>
+          <p:cNvPr id="22" name="Shape 20"/>
+          <p:cNvSpPr/>
+          <p:nvPr/>
+        </p:nvSpPr>
+        <p:spPr>
+          <a:xfrm>
+            <a:off x="1737360" y="2734056"/>
+            <a:ext cx="2743200" cy="512064"/>
+          </a:xfrm>
+          <a:prstGeom prst="rect">
+            <a:avLst/>
+          </a:prstGeom>
+          <a:solidFill>
+            <a:srgbClr val="FFFFFF"/>
+          </a:solidFill>
+          <a:ln w="9525">
+            <a:solidFill>
+              <a:srgbClr val="D5E0DB"/>
+            </a:solidFill>
+            <a:prstDash val="solid"/>
+          </a:ln>
+        </p:spPr>
+      </p:sp>
+      <p:sp>
+        <p:nvSpPr>
+          <p:cNvPr id="23" name="Text 21"/>
+          <p:cNvSpPr/>
+          <p:nvPr/>
+        </p:nvSpPr>
+        <p:spPr>
+          <a:xfrm>
+            <a:off x="1810512" y="2734056"/>
+            <a:ext cx="2596896" cy="512064"/>
+          </a:xfrm>
+          <a:prstGeom prst="rect">
+            <a:avLst/>
+          </a:prstGeom>
+          <a:noFill/>
+          <a:ln/>
+        </p:spPr>
+        <p:txBody>
+          <a:bodyPr wrap="square" lIns="0" tIns="0" rIns="0" bIns="0" rtlCol="0" anchor="ctr"/>
+          <a:lstStyle/>
+          <a:p>
+            <a:pPr algn="ctr" indent="0" marL="0">
+              <a:buNone/>
+            </a:pPr>
+            <a:r>
+              <a:rPr lang="en-US" sz="1300" dirty="0">
+                <a:solidFill>
+                  <a:srgbClr val="1C2B27"/>
+                </a:solidFill>
+                <a:latin typeface="Calibri" pitchFamily="34" charset="0"/>
+                <a:ea typeface="Calibri" pitchFamily="34" charset="-122"/>
+                <a:cs typeface="Calibri" pitchFamily="34" charset="-120"/>
+              </a:rPr>
+              <a:t>85.7</a:t>
+            </a:r>
+            <a:endParaRPr lang="en-US" sz="1300" dirty="0"/>
+          </a:p>
+        </p:txBody>
+      </p:sp>
+      <p:sp>
+        <p:nvSpPr>
+          <p:cNvPr id="24" name="Shape 22"/>
+          <p:cNvSpPr/>
+          <p:nvPr/>
+        </p:nvSpPr>
+        <p:spPr>
+          <a:xfrm>
+            <a:off x="4572000" y="2734056"/>
+            <a:ext cx="2743200" cy="512064"/>
+          </a:xfrm>
+          <a:prstGeom prst="rect">
+            <a:avLst/>
+          </a:prstGeom>
+          <a:solidFill>
+            <a:srgbClr val="FFFFFF"/>
+          </a:solidFill>
+          <a:ln w="9525">
+            <a:solidFill>
+              <a:srgbClr val="D5E0DB"/>
+            </a:solidFill>
+            <a:prstDash val="solid"/>
+          </a:ln>
+        </p:spPr>
+      </p:sp>
+      <p:sp>
+        <p:nvSpPr>
+          <p:cNvPr id="25" name="Text 23"/>
+          <p:cNvSpPr/>
+          <p:nvPr/>
+        </p:nvSpPr>
+        <p:spPr>
+          <a:xfrm>
+            <a:off x="4645152" y="2734056"/>
+            <a:ext cx="2596896" cy="512064"/>
+          </a:xfrm>
+          <a:prstGeom prst="rect">
+            <a:avLst/>
+          </a:prstGeom>
+          <a:noFill/>
+          <a:ln/>
+        </p:spPr>
+        <p:txBody>
+          <a:bodyPr wrap="square" lIns="0" tIns="0" rIns="0" bIns="0" rtlCol="0" anchor="ctr"/>
+          <a:lstStyle/>
+          <a:p>
+            <a:pPr algn="ctr" indent="0" marL="0">
+              <a:buNone/>
+            </a:pPr>
+            <a:r>
+              <a:rPr lang="en-US" sz="1300" dirty="0">
+                <a:solidFill>
+                  <a:srgbClr val="1C2B27"/>
+                </a:solidFill>
+                <a:latin typeface="Calibri" pitchFamily="34" charset="0"/>
+                <a:ea typeface="Calibri" pitchFamily="34" charset="-122"/>
+                <a:cs typeface="Calibri" pitchFamily="34" charset="-120"/>
+              </a:rPr>
+              <a:t>95.2</a:t>
+            </a:r>
+            <a:endParaRPr lang="en-US" sz="1300" dirty="0"/>
+          </a:p>
+        </p:txBody>
+      </p:sp>
+      <p:sp>
+        <p:nvSpPr>
+          <p:cNvPr id="26" name="Shape 24"/>
+          <p:cNvSpPr/>
+          <p:nvPr/>
+        </p:nvSpPr>
+        <p:spPr>
+          <a:xfrm>
+            <a:off x="7406640" y="2734056"/>
+            <a:ext cx="1554480" cy="512064"/>
+          </a:xfrm>
+          <a:prstGeom prst="rect">
+            <a:avLst/>
+          </a:prstGeom>
+          <a:solidFill>
+            <a:srgbClr val="FFFFFF"/>
+          </a:solidFill>
+          <a:ln w="9525">
+            <a:solidFill>
+              <a:srgbClr val="D5E0DB"/>
+            </a:solidFill>
+            <a:prstDash val="solid"/>
+          </a:ln>
+        </p:spPr>
+      </p:sp>
+      <p:sp>
+        <p:nvSpPr>
+          <p:cNvPr id="27" name="Text 25"/>
+          <p:cNvSpPr/>
+          <p:nvPr/>
+        </p:nvSpPr>
+        <p:spPr>
+          <a:xfrm>
+            <a:off x="7479792" y="2734056"/>
+            <a:ext cx="1408176" cy="512064"/>
+          </a:xfrm>
+          <a:prstGeom prst="rect">
+            <a:avLst/>
+          </a:prstGeom>
+          <a:noFill/>
+          <a:ln/>
+        </p:spPr>
+        <p:txBody>
+          <a:bodyPr wrap="square" lIns="0" tIns="0" rIns="0" bIns="0" rtlCol="0" anchor="ctr"/>
+          <a:lstStyle/>
+          <a:p>
+            <a:pPr algn="ctr" indent="0" marL="0">
+              <a:buNone/>
+            </a:pPr>
+            <a:r>
+              <a:rPr lang="en-US" sz="1300" dirty="0">
+                <a:solidFill>
+                  <a:srgbClr val="1C2B27"/>
+                </a:solidFill>
+                <a:latin typeface="Calibri" pitchFamily="34" charset="0"/>
+                <a:ea typeface="Calibri" pitchFamily="34" charset="-122"/>
+                <a:cs typeface="Calibri" pitchFamily="34" charset="-120"/>
+              </a:rPr>
+              <a:t>9.5</a:t>
+            </a:r>
+            <a:endParaRPr lang="en-US" sz="1300" dirty="0"/>
+          </a:p>
+        </p:txBody>
+      </p:sp>
+      <p:sp>
+        <p:nvSpPr>
+          <p:cNvPr id="28" name="Shape 26"/>
+          <p:cNvSpPr/>
+          <p:nvPr/>
+        </p:nvSpPr>
+        <p:spPr>
+          <a:xfrm>
+            <a:off x="548640" y="3300984"/>
+            <a:ext cx="1097280" cy="512064"/>
+          </a:xfrm>
+          <a:prstGeom prst="rect">
+            <a:avLst/>
+          </a:prstGeom>
+          <a:solidFill>
+            <a:srgbClr val="F2F6F4"/>
+          </a:solidFill>
+          <a:ln w="9525">
+            <a:solidFill>
+              <a:srgbClr val="D5E0DB"/>
+            </a:solidFill>
+            <a:prstDash val="solid"/>
+          </a:ln>
+        </p:spPr>
+      </p:sp>
+      <p:sp>
+        <p:nvSpPr>
+          <p:cNvPr id="29" name="Text 27"/>
+          <p:cNvSpPr/>
+          <p:nvPr/>
+        </p:nvSpPr>
+        <p:spPr>
+          <a:xfrm>
+            <a:off x="621792" y="3300984"/>
+            <a:ext cx="950976" cy="512064"/>
+          </a:xfrm>
+          <a:prstGeom prst="rect">
+            <a:avLst/>
+          </a:prstGeom>
+          <a:noFill/>
+          <a:ln/>
+        </p:spPr>
+        <p:txBody>
+          <a:bodyPr wrap="square" lIns="0" tIns="0" rIns="0" bIns="0" rtlCol="0" anchor="ctr"/>
+          <a:lstStyle/>
+          <a:p>
+            <a:pPr algn="l" indent="0" marL="0">
+              <a:buNone/>
+            </a:pPr>
+            <a:r>
+              <a:rPr lang="en-US" sz="1300" b="1" dirty="0">
+                <a:solidFill>
+                  <a:srgbClr val="1C2B27"/>
+                </a:solidFill>
+                <a:latin typeface="Calibri" pitchFamily="34" charset="0"/>
+                <a:ea typeface="Calibri" pitchFamily="34" charset="-122"/>
+                <a:cs typeface="Calibri" pitchFamily="34" charset="-120"/>
+              </a:rPr>
+              <a:t>E25</a:t>
+            </a:r>
+            <a:endParaRPr lang="en-US" sz="1300" dirty="0"/>
+          </a:p>
+        </p:txBody>
+      </p:sp>
+      <p:sp>
+        <p:nvSpPr>
+          <p:cNvPr id="30" name="Shape 28"/>
+          <p:cNvSpPr/>
+          <p:nvPr/>
+        </p:nvSpPr>
+        <p:spPr>
+          <a:xfrm>
+            <a:off x="1737360" y="3300984"/>
+            <a:ext cx="2743200" cy="512064"/>
+          </a:xfrm>
+          <a:prstGeom prst="rect">
+            <a:avLst/>
+          </a:prstGeom>
+          <a:solidFill>
+            <a:srgbClr val="F2F6F4"/>
+          </a:solidFill>
+          <a:ln w="9525">
+            <a:solidFill>
+              <a:srgbClr val="D5E0DB"/>
+            </a:solidFill>
+            <a:prstDash val="solid"/>
+          </a:ln>
+        </p:spPr>
+      </p:sp>
+      <p:sp>
+        <p:nvSpPr>
+          <p:cNvPr id="31" name="Text 29"/>
+          <p:cNvSpPr/>
+          <p:nvPr/>
+        </p:nvSpPr>
+        <p:spPr>
+          <a:xfrm>
+            <a:off x="1810512" y="3300984"/>
+            <a:ext cx="2596896" cy="512064"/>
+          </a:xfrm>
+          <a:prstGeom prst="rect">
+            <a:avLst/>
+          </a:prstGeom>
+          <a:noFill/>
+          <a:ln/>
+        </p:spPr>
+        <p:txBody>
+          <a:bodyPr wrap="square" lIns="0" tIns="0" rIns="0" bIns="0" rtlCol="0" anchor="ctr"/>
+          <a:lstStyle/>
+          <a:p>
+            <a:pPr algn="ctr" indent="0" marL="0">
+              <a:buNone/>
+            </a:pPr>
+            <a:r>
+              <a:rPr lang="en-US" sz="1300" dirty="0">
+                <a:solidFill>
+                  <a:srgbClr val="1C2B27"/>
+                </a:solidFill>
+                <a:latin typeface="Calibri" pitchFamily="34" charset="0"/>
+                <a:ea typeface="Calibri" pitchFamily="34" charset="-122"/>
+                <a:cs typeface="Calibri" pitchFamily="34" charset="-120"/>
+              </a:rPr>
+              <a:t>84.0</a:t>
+            </a:r>
+            <a:endParaRPr lang="en-US" sz="1300" dirty="0"/>
+          </a:p>
+        </p:txBody>
+      </p:sp>
+      <p:sp>
+        <p:nvSpPr>
+          <p:cNvPr id="32" name="Shape 30"/>
+          <p:cNvSpPr/>
+          <p:nvPr/>
+        </p:nvSpPr>
+        <p:spPr>
+          <a:xfrm>
+            <a:off x="4572000" y="3300984"/>
+            <a:ext cx="2743200" cy="512064"/>
+          </a:xfrm>
+          <a:prstGeom prst="rect">
+            <a:avLst/>
+          </a:prstGeom>
+          <a:solidFill>
+            <a:srgbClr val="F2F6F4"/>
+          </a:solidFill>
+          <a:ln w="9525">
+            <a:solidFill>
+              <a:srgbClr val="D5E0DB"/>
+            </a:solidFill>
+            <a:prstDash val="solid"/>
+          </a:ln>
+        </p:spPr>
+      </p:sp>
+      <p:sp>
+        <p:nvSpPr>
+          <p:cNvPr id="33" name="Text 31"/>
+          <p:cNvSpPr/>
+          <p:nvPr/>
+        </p:nvSpPr>
+        <p:spPr>
+          <a:xfrm>
+            <a:off x="4645152" y="3300984"/>
+            <a:ext cx="2596896" cy="512064"/>
+          </a:xfrm>
+          <a:prstGeom prst="rect">
+            <a:avLst/>
+          </a:prstGeom>
+          <a:noFill/>
+          <a:ln/>
+        </p:spPr>
+        <p:txBody>
+          <a:bodyPr wrap="square" lIns="0" tIns="0" rIns="0" bIns="0" rtlCol="0" anchor="ctr"/>
+          <a:lstStyle/>
+          <a:p>
+            <a:pPr algn="ctr" indent="0" marL="0">
+              <a:buNone/>
+            </a:pPr>
+            <a:r>
+              <a:rPr lang="en-US" sz="1300" dirty="0">
+                <a:solidFill>
+                  <a:srgbClr val="1C2B27"/>
+                </a:solidFill>
+                <a:latin typeface="Calibri" pitchFamily="34" charset="0"/>
+                <a:ea typeface="Calibri" pitchFamily="34" charset="-122"/>
+                <a:cs typeface="Calibri" pitchFamily="34" charset="-120"/>
+              </a:rPr>
+              <a:t>96.2</a:t>
+            </a:r>
+            <a:endParaRPr lang="en-US" sz="1300" dirty="0"/>
+          </a:p>
+        </p:txBody>
+      </p:sp>
+      <p:sp>
+        <p:nvSpPr>
+          <p:cNvPr id="34" name="Shape 32"/>
+          <p:cNvSpPr/>
+          <p:nvPr/>
+        </p:nvSpPr>
+        <p:spPr>
+          <a:xfrm>
+            <a:off x="7406640" y="3300984"/>
+            <a:ext cx="1554480" cy="512064"/>
+          </a:xfrm>
+          <a:prstGeom prst="rect">
+            <a:avLst/>
+          </a:prstGeom>
+          <a:solidFill>
+            <a:srgbClr val="F2F6F4"/>
+          </a:solidFill>
+          <a:ln w="9525">
+            <a:solidFill>
+              <a:srgbClr val="D5E0DB"/>
+            </a:solidFill>
+            <a:prstDash val="solid"/>
+          </a:ln>
+        </p:spPr>
+      </p:sp>
+      <p:sp>
+        <p:nvSpPr>
+          <p:cNvPr id="35" name="Text 33"/>
+          <p:cNvSpPr/>
+          <p:nvPr/>
+        </p:nvSpPr>
+        <p:spPr>
+          <a:xfrm>
+            <a:off x="7479792" y="3300984"/>
+            <a:ext cx="1408176" cy="512064"/>
+          </a:xfrm>
+          <a:prstGeom prst="rect">
+            <a:avLst/>
+          </a:prstGeom>
+          <a:noFill/>
+          <a:ln/>
+        </p:spPr>
+        <p:txBody>
+          <a:bodyPr wrap="square" lIns="0" tIns="0" rIns="0" bIns="0" rtlCol="0" anchor="ctr"/>
+          <a:lstStyle/>
+          <a:p>
+            <a:pPr algn="ctr" indent="0" marL="0">
+              <a:buNone/>
+            </a:pPr>
+            <a:r>
+              <a:rPr lang="en-US" sz="1300" dirty="0">
+                <a:solidFill>
+                  <a:srgbClr val="1C2B27"/>
+                </a:solidFill>
+                <a:latin typeface="Calibri" pitchFamily="34" charset="0"/>
+                <a:ea typeface="Calibri" pitchFamily="34" charset="-122"/>
+                <a:cs typeface="Calibri" pitchFamily="34" charset="-120"/>
+              </a:rPr>
+              <a:t>11.8</a:t>
+            </a:r>
+            <a:endParaRPr lang="en-US" sz="1300" dirty="0"/>
+          </a:p>
+        </p:txBody>
+      </p:sp>
+      <p:sp>
+        <p:nvSpPr>
+          <p:cNvPr id="36" name="Shape 34"/>
+          <p:cNvSpPr/>
+          <p:nvPr/>
+        </p:nvSpPr>
+        <p:spPr>
+          <a:xfrm>
+            <a:off x="548640" y="3867912"/>
+            <a:ext cx="1097280" cy="512064"/>
+          </a:xfrm>
+          <a:prstGeom prst="rect">
+            <a:avLst/>
+          </a:prstGeom>
+          <a:solidFill>
+            <a:srgbClr val="FFFFFF"/>
+          </a:solidFill>
+          <a:ln w="9525">
+            <a:solidFill>
+              <a:srgbClr val="D5E0DB"/>
+            </a:solidFill>
+            <a:prstDash val="solid"/>
+          </a:ln>
+        </p:spPr>
+      </p:sp>
+      <p:sp>
+        <p:nvSpPr>
+          <p:cNvPr id="37" name="Text 35"/>
+          <p:cNvSpPr/>
+          <p:nvPr/>
+        </p:nvSpPr>
+        <p:spPr>
+          <a:xfrm>
+            <a:off x="621792" y="3867912"/>
+            <a:ext cx="950976" cy="512064"/>
+          </a:xfrm>
+          <a:prstGeom prst="rect">
+            <a:avLst/>
+          </a:prstGeom>
+          <a:noFill/>
+          <a:ln/>
+        </p:spPr>
+        <p:txBody>
+          <a:bodyPr wrap="square" lIns="0" tIns="0" rIns="0" bIns="0" rtlCol="0" anchor="ctr"/>
+          <a:lstStyle/>
+          <a:p>
+            <a:pPr algn="l" indent="0" marL="0">
+              <a:buNone/>
+            </a:pPr>
+            <a:r>
+              <a:rPr lang="en-US" sz="1300" b="1" dirty="0">
+                <a:solidFill>
+                  <a:srgbClr val="1C2B27"/>
+                </a:solidFill>
+                <a:latin typeface="Calibri" pitchFamily="34" charset="0"/>
+                <a:ea typeface="Calibri" pitchFamily="34" charset="-122"/>
+                <a:cs typeface="Calibri" pitchFamily="34" charset="-120"/>
+              </a:rPr>
+              <a:t>E27</a:t>
+            </a:r>
+            <a:endParaRPr lang="en-US" sz="1300" dirty="0"/>
+          </a:p>
+        </p:txBody>
+      </p:sp>
+      <p:sp>
+        <p:nvSpPr>
+          <p:cNvPr id="38" name="Shape 36"/>
+          <p:cNvSpPr/>
+          <p:nvPr/>
+        </p:nvSpPr>
+        <p:spPr>
+          <a:xfrm>
+            <a:off x="1737360" y="3867912"/>
+            <a:ext cx="2743200" cy="512064"/>
+          </a:xfrm>
+          <a:prstGeom prst="rect">
+            <a:avLst/>
+          </a:prstGeom>
+          <a:solidFill>
+            <a:srgbClr val="FFFFFF"/>
+          </a:solidFill>
+          <a:ln w="9525">
+            <a:solidFill>
+              <a:srgbClr val="D5E0DB"/>
+            </a:solidFill>
+            <a:prstDash val="solid"/>
+          </a:ln>
+        </p:spPr>
+      </p:sp>
+      <p:sp>
+        <p:nvSpPr>
+          <p:cNvPr id="39" name="Text 37"/>
+          <p:cNvSpPr/>
+          <p:nvPr/>
+        </p:nvSpPr>
+        <p:spPr>
+          <a:xfrm>
+            <a:off x="1810512" y="3867912"/>
+            <a:ext cx="2596896" cy="512064"/>
+          </a:xfrm>
+          <a:prstGeom prst="rect">
+            <a:avLst/>
+          </a:prstGeom>
+          <a:noFill/>
+          <a:ln/>
+        </p:spPr>
+        <p:txBody>
+          <a:bodyPr wrap="square" lIns="0" tIns="0" rIns="0" bIns="0" rtlCol="0" anchor="ctr"/>
+          <a:lstStyle/>
+          <a:p>
+            <a:pPr algn="ctr" indent="0" marL="0">
+              <a:buNone/>
+            </a:pPr>
+            <a:r>
+              <a:rPr lang="en-US" sz="1300" dirty="0">
+                <a:solidFill>
+                  <a:srgbClr val="1C2B27"/>
+                </a:solidFill>
+                <a:latin typeface="Calibri" pitchFamily="34" charset="0"/>
+                <a:ea typeface="Calibri" pitchFamily="34" charset="-122"/>
+                <a:cs typeface="Calibri" pitchFamily="34" charset="-120"/>
+              </a:rPr>
+              <a:t>83.2</a:t>
+            </a:r>
+            <a:endParaRPr lang="en-US" sz="1300" dirty="0"/>
+          </a:p>
+        </p:txBody>
+      </p:sp>
+      <p:sp>
+        <p:nvSpPr>
+          <p:cNvPr id="40" name="Shape 38"/>
+          <p:cNvSpPr/>
+          <p:nvPr/>
+        </p:nvSpPr>
+        <p:spPr>
+          <a:xfrm>
+            <a:off x="4572000" y="3867912"/>
+            <a:ext cx="2743200" cy="512064"/>
+          </a:xfrm>
+          <a:prstGeom prst="rect">
+            <a:avLst/>
+          </a:prstGeom>
+          <a:solidFill>
+            <a:srgbClr val="FFFFFF"/>
+          </a:solidFill>
+          <a:ln w="9525">
+            <a:solidFill>
+              <a:srgbClr val="D5E0DB"/>
+            </a:solidFill>
+            <a:prstDash val="solid"/>
+          </a:ln>
+        </p:spPr>
+      </p:sp>
+      <p:sp>
+        <p:nvSpPr>
+          <p:cNvPr id="41" name="Text 39"/>
+          <p:cNvSpPr/>
+          <p:nvPr/>
+        </p:nvSpPr>
+        <p:spPr>
+          <a:xfrm>
+            <a:off x="4645152" y="3867912"/>
+            <a:ext cx="2596896" cy="512064"/>
+          </a:xfrm>
+          <a:prstGeom prst="rect">
+            <a:avLst/>
+          </a:prstGeom>
+          <a:noFill/>
+          <a:ln/>
+        </p:spPr>
+        <p:txBody>
+          <a:bodyPr wrap="square" lIns="0" tIns="0" rIns="0" bIns="0" rtlCol="0" anchor="ctr"/>
+          <a:lstStyle/>
+          <a:p>
+            <a:pPr algn="ctr" indent="0" marL="0">
+              <a:buNone/>
+            </a:pPr>
+            <a:r>
+              <a:rPr lang="en-US" sz="1300" dirty="0">
+                <a:solidFill>
+                  <a:srgbClr val="1C2B27"/>
+                </a:solidFill>
+                <a:latin typeface="Calibri" pitchFamily="34" charset="0"/>
+                <a:ea typeface="Calibri" pitchFamily="34" charset="-122"/>
+                <a:cs typeface="Calibri" pitchFamily="34" charset="-120"/>
+              </a:rPr>
+              <a:t>96.7</a:t>
+            </a:r>
+            <a:endParaRPr lang="en-US" sz="1300" dirty="0"/>
+          </a:p>
+        </p:txBody>
+      </p:sp>
+      <p:sp>
+        <p:nvSpPr>
+          <p:cNvPr id="42" name="Shape 40"/>
+          <p:cNvSpPr/>
+          <p:nvPr/>
+        </p:nvSpPr>
+        <p:spPr>
+          <a:xfrm>
+            <a:off x="7406640" y="3867912"/>
+            <a:ext cx="1554480" cy="512064"/>
+          </a:xfrm>
+          <a:prstGeom prst="rect">
+            <a:avLst/>
+          </a:prstGeom>
+          <a:solidFill>
+            <a:srgbClr val="FFFFFF"/>
+          </a:solidFill>
+          <a:ln w="9525">
+            <a:solidFill>
+              <a:srgbClr val="D5E0DB"/>
+            </a:solidFill>
+            <a:prstDash val="solid"/>
+          </a:ln>
+        </p:spPr>
+      </p:sp>
+      <p:sp>
+        <p:nvSpPr>
+          <p:cNvPr id="43" name="Text 41"/>
+          <p:cNvSpPr/>
+          <p:nvPr/>
+        </p:nvSpPr>
+        <p:spPr>
+          <a:xfrm>
+            <a:off x="7479792" y="3867912"/>
+            <a:ext cx="1408176" cy="512064"/>
+          </a:xfrm>
+          <a:prstGeom prst="rect">
+            <a:avLst/>
+          </a:prstGeom>
+          <a:noFill/>
+          <a:ln/>
+        </p:spPr>
+        <p:txBody>
+          <a:bodyPr wrap="square" lIns="0" tIns="0" rIns="0" bIns="0" rtlCol="0" anchor="ctr"/>
+          <a:lstStyle/>
+          <a:p>
+            <a:pPr algn="ctr" indent="0" marL="0">
+              <a:buNone/>
+            </a:pPr>
+            <a:r>
+              <a:rPr lang="en-US" sz="1300" dirty="0">
+                <a:solidFill>
+                  <a:srgbClr val="1C2B27"/>
+                </a:solidFill>
+                <a:latin typeface="Calibri" pitchFamily="34" charset="0"/>
+                <a:ea typeface="Calibri" pitchFamily="34" charset="-122"/>
+                <a:cs typeface="Calibri" pitchFamily="34" charset="-120"/>
+              </a:rPr>
+              <a:t>12.8</a:t>
+            </a:r>
+            <a:endParaRPr lang="en-US" sz="1300" dirty="0"/>
+          </a:p>
+        </p:txBody>
+      </p:sp>
+      <p:sp>
+        <p:nvSpPr>
+          <p:cNvPr id="44" name="Shape 42"/>
+          <p:cNvSpPr/>
+          <p:nvPr/>
+        </p:nvSpPr>
+        <p:spPr>
+          <a:xfrm>
+            <a:off x="548640" y="4434840"/>
+            <a:ext cx="1097280" cy="512064"/>
+          </a:xfrm>
+          <a:prstGeom prst="rect">
+            <a:avLst/>
+          </a:prstGeom>
+          <a:solidFill>
+            <a:srgbClr val="F2F6F4"/>
+          </a:solidFill>
+          <a:ln w="9525">
+            <a:solidFill>
+              <a:srgbClr val="D5E0DB"/>
+            </a:solidFill>
+            <a:prstDash val="solid"/>
+          </a:ln>
+        </p:spPr>
+      </p:sp>
+      <p:sp>
+        <p:nvSpPr>
+          <p:cNvPr id="45" name="Text 43"/>
+          <p:cNvSpPr/>
+          <p:nvPr/>
+        </p:nvSpPr>
+        <p:spPr>
+          <a:xfrm>
+            <a:off x="621792" y="4434840"/>
+            <a:ext cx="950976" cy="512064"/>
+          </a:xfrm>
+          <a:prstGeom prst="rect">
+            <a:avLst/>
+          </a:prstGeom>
+          <a:noFill/>
+          <a:ln/>
+        </p:spPr>
+        <p:txBody>
+          <a:bodyPr wrap="square" lIns="0" tIns="0" rIns="0" bIns="0" rtlCol="0" anchor="ctr"/>
+          <a:lstStyle/>
+          <a:p>
+            <a:pPr algn="l" indent="0" marL="0">
+              <a:buNone/>
+            </a:pPr>
+            <a:r>
+              <a:rPr lang="en-US" sz="1300" b="1" dirty="0">
+                <a:solidFill>
+                  <a:srgbClr val="1C2B27"/>
+                </a:solidFill>
+                <a:latin typeface="Calibri" pitchFamily="34" charset="0"/>
+                <a:ea typeface="Calibri" pitchFamily="34" charset="-122"/>
+                <a:cs typeface="Calibri" pitchFamily="34" charset="-120"/>
+              </a:rPr>
+              <a:t>E30</a:t>
+            </a:r>
+            <a:endParaRPr lang="en-US" sz="1300" dirty="0"/>
+          </a:p>
+        </p:txBody>
+      </p:sp>
+      <p:sp>
+        <p:nvSpPr>
+          <p:cNvPr id="46" name="Shape 44"/>
+          <p:cNvSpPr/>
+          <p:nvPr/>
+        </p:nvSpPr>
+        <p:spPr>
+          <a:xfrm>
+            <a:off x="1737360" y="4434840"/>
+            <a:ext cx="2743200" cy="512064"/>
+          </a:xfrm>
+          <a:prstGeom prst="rect">
+            <a:avLst/>
+          </a:prstGeom>
+          <a:solidFill>
+            <a:srgbClr val="F2F6F4"/>
+          </a:solidFill>
+          <a:ln w="9525">
+            <a:solidFill>
+              <a:srgbClr val="D5E0DB"/>
+            </a:solidFill>
+            <a:prstDash val="solid"/>
+          </a:ln>
+        </p:spPr>
+      </p:sp>
+      <p:sp>
+        <p:nvSpPr>
+          <p:cNvPr id="47" name="Text 45"/>
+          <p:cNvSpPr/>
+          <p:nvPr/>
+        </p:nvSpPr>
+        <p:spPr>
+          <a:xfrm>
+            <a:off x="1810512" y="4434840"/>
+            <a:ext cx="2596896" cy="512064"/>
+          </a:xfrm>
+          <a:prstGeom prst="rect">
+            <a:avLst/>
+          </a:prstGeom>
+          <a:noFill/>
+          <a:ln/>
+        </p:spPr>
+        <p:txBody>
+          <a:bodyPr wrap="square" lIns="0" tIns="0" rIns="0" bIns="0" rtlCol="0" anchor="ctr"/>
+          <a:lstStyle/>
+          <a:p>
+            <a:pPr algn="ctr" indent="0" marL="0">
+              <a:buNone/>
+            </a:pPr>
+            <a:r>
+              <a:rPr lang="en-US" sz="1300" dirty="0">
+                <a:solidFill>
+                  <a:srgbClr val="1C2B27"/>
+                </a:solidFill>
+                <a:latin typeface="Calibri" pitchFamily="34" charset="0"/>
+                <a:ea typeface="Calibri" pitchFamily="34" charset="-122"/>
+                <a:cs typeface="Calibri" pitchFamily="34" charset="-120"/>
+              </a:rPr>
+              <a:t>82.0</a:t>
+            </a:r>
+            <a:endParaRPr lang="en-US" sz="1300" dirty="0"/>
+          </a:p>
+        </p:txBody>
+      </p:sp>
+      <p:sp>
+        <p:nvSpPr>
+          <p:cNvPr id="48" name="Shape 46"/>
+          <p:cNvSpPr/>
+          <p:nvPr/>
+        </p:nvSpPr>
+        <p:spPr>
+          <a:xfrm>
+            <a:off x="4572000" y="4434840"/>
+            <a:ext cx="2743200" cy="512064"/>
+          </a:xfrm>
+          <a:prstGeom prst="rect">
+            <a:avLst/>
+          </a:prstGeom>
+          <a:solidFill>
+            <a:srgbClr val="F2F6F4"/>
+          </a:solidFill>
+          <a:ln w="9525">
+            <a:solidFill>
+              <a:srgbClr val="D5E0DB"/>
+            </a:solidFill>
+            <a:prstDash val="solid"/>
+          </a:ln>
+        </p:spPr>
+      </p:sp>
+      <p:sp>
+        <p:nvSpPr>
+          <p:cNvPr id="49" name="Text 47"/>
+          <p:cNvSpPr/>
+          <p:nvPr/>
+        </p:nvSpPr>
+        <p:spPr>
+          <a:xfrm>
+            <a:off x="4645152" y="4434840"/>
+            <a:ext cx="2596896" cy="512064"/>
+          </a:xfrm>
+          <a:prstGeom prst="rect">
+            <a:avLst/>
+          </a:prstGeom>
+          <a:noFill/>
+          <a:ln/>
+        </p:spPr>
+        <p:txBody>
+          <a:bodyPr wrap="square" lIns="0" tIns="0" rIns="0" bIns="0" rtlCol="0" anchor="ctr"/>
+          <a:lstStyle/>
+          <a:p>
+            <a:pPr algn="ctr" indent="0" marL="0">
+              <a:buNone/>
+            </a:pPr>
+            <a:r>
+              <a:rPr lang="en-US" sz="1300" dirty="0">
+                <a:solidFill>
+                  <a:srgbClr val="1C2B27"/>
+                </a:solidFill>
+                <a:latin typeface="Calibri" pitchFamily="34" charset="0"/>
+                <a:ea typeface="Calibri" pitchFamily="34" charset="-122"/>
+                <a:cs typeface="Calibri" pitchFamily="34" charset="-120"/>
+              </a:rPr>
+              <a:t>97.3</a:t>
+            </a:r>
+            <a:endParaRPr lang="en-US" sz="1300" dirty="0"/>
+          </a:p>
+        </p:txBody>
+      </p:sp>
+      <p:sp>
+        <p:nvSpPr>
+          <p:cNvPr id="50" name="Shape 48"/>
+          <p:cNvSpPr/>
+          <p:nvPr/>
+        </p:nvSpPr>
+        <p:spPr>
+          <a:xfrm>
+            <a:off x="7406640" y="4434840"/>
+            <a:ext cx="1554480" cy="512064"/>
+          </a:xfrm>
+          <a:prstGeom prst="rect">
+            <a:avLst/>
+          </a:prstGeom>
+          <a:solidFill>
+            <a:srgbClr val="F2F6F4"/>
+          </a:solidFill>
+          <a:ln w="9525">
+            <a:solidFill>
+              <a:srgbClr val="D5E0DB"/>
+            </a:solidFill>
+            <a:prstDash val="solid"/>
+          </a:ln>
+        </p:spPr>
+      </p:sp>
+      <p:sp>
+        <p:nvSpPr>
+          <p:cNvPr id="51" name="Text 49"/>
+          <p:cNvSpPr/>
+          <p:nvPr/>
+        </p:nvSpPr>
+        <p:spPr>
+          <a:xfrm>
+            <a:off x="7479792" y="4434840"/>
+            <a:ext cx="1408176" cy="512064"/>
+          </a:xfrm>
+          <a:prstGeom prst="rect">
+            <a:avLst/>
+          </a:prstGeom>
+          <a:noFill/>
+          <a:ln/>
+        </p:spPr>
+        <p:txBody>
+          <a:bodyPr wrap="square" lIns="0" tIns="0" rIns="0" bIns="0" rtlCol="0" anchor="ctr"/>
+          <a:lstStyle/>
+          <a:p>
+            <a:pPr algn="ctr" indent="0" marL="0">
+              <a:buNone/>
+            </a:pPr>
+            <a:r>
+              <a:rPr lang="en-US" sz="1300" dirty="0">
+                <a:solidFill>
+                  <a:srgbClr val="1C2B27"/>
+                </a:solidFill>
+                <a:latin typeface="Calibri" pitchFamily="34" charset="0"/>
+                <a:ea typeface="Calibri" pitchFamily="34" charset="-122"/>
+                <a:cs typeface="Calibri" pitchFamily="34" charset="-120"/>
+              </a:rPr>
+              <a:t>14.2</a:t>
+            </a:r>
+            <a:endParaRPr lang="en-US" sz="1300" dirty="0"/>
+          </a:p>
+        </p:txBody>
+      </p:sp>
+      <p:sp>
+        <p:nvSpPr>
+          <p:cNvPr id="52" name="Text 50"/>
+          <p:cNvSpPr/>
+          <p:nvPr/>
+        </p:nvSpPr>
+        <p:spPr>
+          <a:xfrm>
+            <a:off x="548640" y="5120640"/>
+            <a:ext cx="8412480" cy="365760"/>
+          </a:xfrm>
+          <a:prstGeom prst="rect">
+            <a:avLst/>
+          </a:prstGeom>
+          <a:noFill/>
+          <a:ln/>
+        </p:spPr>
+        <p:txBody>
+          <a:bodyPr wrap="square" lIns="0" tIns="0" rIns="0" bIns="0" rtlCol="0" anchor="ctr"/>
+          <a:lstStyle/>
+          <a:p>
+            <a:pPr indent="0" marL="0">
+              <a:buNone/>
+            </a:pPr>
+            <a:r>
+              <a:rPr lang="en-US" sz="1050" i="1" dirty="0">
+                <a:solidFill>
+                  <a:srgbClr val="5C6B66"/>
+                </a:solidFill>
+                <a:latin typeface="Calibri" pitchFamily="34" charset="0"/>
+                <a:ea typeface="Calibri" pitchFamily="34" charset="-122"/>
+                <a:cs typeface="Calibri" pitchFamily="34" charset="-120"/>
+              </a:rPr>
+              <a:t>*valued at the retail XP95 spread (~₹2.25/RON point) — a willingness-to-pay ceiling; refining cost is lower (₹0.3–0.8/L per 4–5 points)</a:t>
+            </a:r>
+            <a:endParaRPr lang="en-US" sz="1050" dirty="0"/>
+          </a:p>
+        </p:txBody>
+      </p:sp>
+      <p:sp>
+        <p:nvSpPr>
+          <p:cNvPr id="53" name="Shape 51"/>
+          <p:cNvSpPr/>
+          <p:nvPr/>
+        </p:nvSpPr>
+        <p:spPr>
+          <a:xfrm>
+            <a:off x="9235440" y="1600200"/>
+            <a:ext cx="2423160" cy="3383280"/>
+          </a:xfrm>
+          <a:prstGeom prst="roundRect">
+            <a:avLst>
+              <a:gd name="adj" fmla="val 3019"/>
+            </a:avLst>
+          </a:prstGeom>
+          <a:solidFill>
+            <a:srgbClr val="0E3B2E"/>
+          </a:solidFill>
+          <a:ln w="9525">
+            <a:solidFill>
+              <a:srgbClr val="D5E0DB"/>
+            </a:solidFill>
+            <a:prstDash val="solid"/>
+          </a:ln>
+        </p:spPr>
+      </p:sp>
+      <p:sp>
+        <p:nvSpPr>
+          <p:cNvPr id="54" name="Text 52"/>
+          <p:cNvSpPr/>
+          <p:nvPr/>
+        </p:nvSpPr>
+        <p:spPr>
+          <a:xfrm>
+            <a:off x="9418320" y="1783080"/>
+            <a:ext cx="2057400" cy="777240"/>
+          </a:xfrm>
+          <a:prstGeom prst="rect">
+            <a:avLst/>
+          </a:prstGeom>
+          <a:noFill/>
+          <a:ln/>
+        </p:spPr>
+        <p:txBody>
+          <a:bodyPr wrap="square" lIns="0" tIns="0" rIns="0" bIns="0" rtlCol="0" anchor="ctr"/>
+          <a:lstStyle/>
+          <a:p>
+            <a:pPr indent="0" marL="0">
+              <a:buNone/>
+            </a:pPr>
+            <a:r>
+              <a:rPr lang="en-US" sz="1150" dirty="0">
+                <a:solidFill>
+                  <a:srgbClr val="CFE3DA"/>
+                </a:solidFill>
+                <a:latin typeface="Calibri" pitchFamily="34" charset="0"/>
+                <a:ea typeface="Calibri" pitchFamily="34" charset="-122"/>
+                <a:cs typeface="Calibri" pitchFamily="34" charset="-120"/>
+              </a:rPr>
+              <a:t>net E20 penalty on a RON95-calibrated engine</a:t>
+            </a:r>
+            <a:endParaRPr lang="en-US" sz="1150" dirty="0"/>
+          </a:p>
+        </p:txBody>
+      </p:sp>
+      <p:sp>
+        <p:nvSpPr>
+          <p:cNvPr id="55" name="Text 53"/>
+          <p:cNvSpPr/>
+          <p:nvPr/>
+        </p:nvSpPr>
+        <p:spPr>
+          <a:xfrm>
+            <a:off x="9418320" y="2560320"/>
+            <a:ext cx="2057400" cy="822960"/>
+          </a:xfrm>
+          <a:prstGeom prst="rect">
+            <a:avLst/>
+          </a:prstGeom>
+          <a:noFill/>
+          <a:ln/>
+        </p:spPr>
+        <p:txBody>
+          <a:bodyPr wrap="square" lIns="0" tIns="0" rIns="0" bIns="0" rtlCol="0" anchor="ctr"/>
+          <a:lstStyle/>
+          <a:p>
+            <a:pPr indent="0" marL="0">
+              <a:buNone/>
+            </a:pPr>
+            <a:r>
+              <a:rPr lang="en-US" sz="4000" b="1" dirty="0">
+                <a:solidFill>
+                  <a:srgbClr val="E3A72F"/>
+                </a:solidFill>
+                <a:latin typeface="Cambria" pitchFamily="34" charset="0"/>
+                <a:ea typeface="Cambria" pitchFamily="34" charset="-122"/>
+                <a:cs typeface="Cambria" pitchFamily="34" charset="-120"/>
+              </a:rPr>
+              <a:t>−1.8%</a:t>
+            </a:r>
+            <a:endParaRPr lang="en-US" sz="4000" dirty="0"/>
+          </a:p>
+        </p:txBody>
+      </p:sp>
+      <p:sp>
+        <p:nvSpPr>
+          <p:cNvPr id="56" name="Text 54"/>
+          <p:cNvSpPr/>
+          <p:nvPr/>
+        </p:nvSpPr>
+        <p:spPr>
+          <a:xfrm>
+            <a:off x="9418320" y="3429000"/>
+            <a:ext cx="2057400" cy="731520"/>
+          </a:xfrm>
+          <a:prstGeom prst="rect">
+            <a:avLst/>
+          </a:prstGeom>
+          <a:noFill/>
+          <a:ln/>
+        </p:spPr>
+        <p:txBody>
+          <a:bodyPr wrap="square" lIns="0" tIns="0" rIns="0" bIns="0" rtlCol="0" anchor="ctr"/>
+          <a:lstStyle/>
+          <a:p>
+            <a:pPr indent="0" marL="0">
+              <a:buNone/>
+            </a:pPr>
+            <a:r>
+              <a:rPr lang="en-US" sz="1100" dirty="0">
+                <a:solidFill>
+                  <a:srgbClr val="CFE3DA"/>
+                </a:solidFill>
+                <a:latin typeface="Calibri" pitchFamily="34" charset="0"/>
+                <a:ea typeface="Calibri" pitchFamily="34" charset="-122"/>
+                <a:cs typeface="Calibri" pitchFamily="34" charset="-120"/>
+              </a:rPr>
+              <a:t>−4% energy +2.2% from CR 10.5→12</a:t>
+            </a:r>
+            <a:endParaRPr lang="en-US" sz="1100" dirty="0"/>
+          </a:p>
+        </p:txBody>
+      </p:sp>
+      <p:sp>
+        <p:nvSpPr>
+          <p:cNvPr id="57" name="Text 55"/>
+          <p:cNvSpPr/>
+          <p:nvPr/>
+        </p:nvSpPr>
+        <p:spPr>
+          <a:xfrm>
+            <a:off x="548640" y="5623560"/>
+            <a:ext cx="11064240" cy="1097280"/>
+          </a:xfrm>
+          <a:prstGeom prst="rect">
+            <a:avLst/>
+          </a:prstGeom>
+          <a:noFill/>
+          <a:ln/>
+        </p:spPr>
+        <p:txBody>
+          <a:bodyPr wrap="square" lIns="0" tIns="0" rIns="0" bIns="0" rtlCol="0" anchor="t"/>
+          <a:lstStyle/>
+          <a:p>
+            <a:pPr marL="177800" indent="-177800">
+              <a:spcAft>
+                <a:spcPts val="800"/>
+              </a:spcAft>
+              <a:buSzPct val="100000"/>
+              <a:buChar char="•"/>
+            </a:pPr>
+            <a:r>
+              <a:rPr lang="en-US" sz="1250" dirty="0">
+                <a:solidFill>
+                  <a:srgbClr val="1C2B27"/>
+                </a:solidFill>
+                <a:latin typeface="Calibri" pitchFamily="34" charset="0"/>
+                <a:ea typeface="Calibri" pitchFamily="34" charset="-122"/>
+                <a:cs typeface="Calibri" pitchFamily="34" charset="-120"/>
+              </a:rPr>
+              <a:t>Today India blends to pump RON 91 → refiners quietly drop the blendstock to 85.7 and keep the saving. Holding the blendstock at 91 instead makes E20 a FREE national RON95 fuel — Brazil's E27 playbook: parity pricing compensates today's fleet, RON95 + high-compression E20+ engines erase the penalty as the fleet turns over (~2.9 cr new vehicles/yr)</a:t>
+            </a:r>
+            <a:endParaRPr lang="en-US" sz="1250" dirty="0"/>
+          </a:p>
+        </p:txBody>
+      </p:sp>
+    </p:spTree>
+  </p:cSld>
+  <p:clrMapOvr>
+    <a:masterClrMapping/>
+  </p:clrMapOvr>
+</p:sld>
+</file>
+
+<file path=ppt/slides/slide12.xml><?xml version="1.0" encoding="utf-8"?>
+<p:sld xmlns:a="http://schemas.openxmlformats.org/drawingml/2006/main" xmlns:r="http://schemas.openxmlformats.org/officeDocument/2006/relationships" xmlns:p="http://schemas.openxmlformats.org/presentationml/2006/main">
+  <p:cSld name="Slide 12">
+    <p:bg>
+      <p:bgPr>
+        <a:solidFill>
           <a:srgbClr val="0E3B2E"/>
         </a:solidFill>
       </p:bgPr>
@@ -3084,6 +5768,27 @@
                 <a:cs typeface="Calibri" pitchFamily="34" charset="-120"/>
               </a:rPr>
               <a:t>Walk the blend E20 → E27 with the fleet, not ahead of it (Brazil precedent); label pumps with energy content, not just blend %</a:t>
+            </a:r>
+            <a:endParaRPr lang="en-US" sz="1700" dirty="0"/>
+          </a:p>
+          <a:p>
+            <a:pPr marL="177800" indent="-177800">
+              <a:spcAft>
+                <a:spcPts val="1600"/>
+              </a:spcAft>
+              <a:buSzPct val="100000"/>
+              <a:buChar char="•"/>
+            </a:pPr>
+            <a:r>
+              <a:rPr lang="en-US" sz="1700" dirty="0">
+                <a:solidFill>
+                  <a:srgbClr val="FFFFFF"/>
+                </a:solidFill>
+                <a:latin typeface="Calibri" pitchFamily="34" charset="0"/>
+                <a:ea typeface="Calibri" pitchFamily="34" charset="-122"/>
+                <a:cs typeface="Calibri" pitchFamily="34" charset="-120"/>
+              </a:rPr>
+              <a:t>Label E20+ as RON95 (hold the blendstock at 91) — the free octane lets high-compression engines shrink the mileage penalty to ~−1.8% as the fleet turns over</a:t>
             </a:r>
             <a:endParaRPr lang="en-US" sz="1700" dirty="0"/>
           </a:p>

</xml_diff>

<commit_message>
docs: slide 12 — CBG incentive stack (GOBARdhan register, 8-lever grid)
Co-Authored-By: Claude Fable 5 <noreply@anthropic.com>
</commit_message>
<xml_diff>
--- a/docs/Volume_Dividend_Slides.pptx
+++ b/docs/Volume_Dividend_Slides.pptx
@@ -17,9 +17,10 @@
     <p:sldId id="265" r:id="rId11"/>
     <p:sldId id="266" r:id="rId12"/>
     <p:sldId id="267" r:id="rId13"/>
+    <p:sldId id="268" r:id="rId14"/>
   </p:sldIdLst>
   <p:notesMasterIdLst>
-    <p:notesMasterId r:id="rId14"/>
+    <p:notesMasterId r:id="rId15"/>
   </p:notesMasterIdLst>
   <p:sldSz cx="12192000" cy="6858000"/>
   <p:notesSz cx="6858000" cy="12192000"/>
@@ -2295,6 +2296,94 @@
             <a:fld id="{F7021451-1387-4CA6-816F-3879F97B5CBC}" type="slidenum">
               <a:rPr lang="en-US"/>
               <a:t>12</a:t>
+            </a:fld>
+            <a:endParaRPr lang="en-US"/>
+          </a:p>
+        </p:txBody>
+      </p:sp>
+    </p:spTree>
+    <p:extLst>
+      <p:ext uri="{BB962C8B-B14F-4D97-AF65-F5344CB8AC3E}">
+        <p14:creationId xmlns:p14="http://schemas.microsoft.com/office/powerpoint/2010/main" val="1024086991"/>
+      </p:ext>
+    </p:extLst>
+  </p:cSld>
+  <p:clrMapOvr>
+    <a:masterClrMapping/>
+  </p:clrMapOvr>
+</p:notes>
+</file>
+
+<file path=ppt/notesSlides/notesSlide13.xml><?xml version="1.0" encoding="utf-8"?>
+<p:notes xmlns:a="http://schemas.openxmlformats.org/drawingml/2006/main" xmlns:r="http://schemas.openxmlformats.org/officeDocument/2006/relationships" xmlns:p="http://schemas.openxmlformats.org/presentationml/2006/main">
+  <p:cSld>
+    <p:spTree>
+      <p:nvGrpSpPr>
+        <p:cNvPr id="1" name=""/>
+        <p:cNvGrpSpPr/>
+        <p:nvPr/>
+      </p:nvGrpSpPr>
+      <p:grpSpPr>
+        <a:xfrm>
+          <a:off x="0" y="0"/>
+          <a:ext cx="0" cy="0"/>
+          <a:chOff x="0" y="0"/>
+          <a:chExt cx="0" cy="0"/>
+        </a:xfrm>
+      </p:grpSpPr>
+      <p:sp>
+        <p:nvSpPr>
+          <p:cNvPr id="2" name="Slide Image Placeholder 1"/>
+          <p:cNvSpPr>
+            <a:spLocks noGrp="1" noRot="1" noChangeAspect="1"/>
+          </p:cNvSpPr>
+          <p:nvPr>
+            <p:ph type="sldImg"/>
+          </p:nvPr>
+        </p:nvSpPr>
+        <p:spPr/>
+      </p:sp>
+      <p:sp>
+        <p:nvSpPr>
+          <p:cNvPr id="3" name="Notes Placeholder 2"/>
+          <p:cNvSpPr>
+            <a:spLocks noGrp="1"/>
+          </p:cNvSpPr>
+          <p:nvPr>
+            <p:ph type="body" idx="1"/>
+          </p:nvPr>
+        </p:nvSpPr>
+        <p:spPr/>
+        <p:txBody>
+          <a:bodyPr/>
+          <a:lstStyle/>
+          <a:p>
+            <a:r>
+              <a:rPr lang="en-US" dirty="0"/>
+              <a:t/>
+            </a:r>
+            <a:endParaRPr lang="en-US" dirty="0"/>
+          </a:p>
+        </p:txBody>
+      </p:sp>
+      <p:sp>
+        <p:nvSpPr>
+          <p:cNvPr id="4" name="Slide Number Placeholder 3"/>
+          <p:cNvSpPr>
+            <a:spLocks noGrp="1"/>
+          </p:cNvSpPr>
+          <p:nvPr>
+            <p:ph type="sldNum" sz="quarter" idx="10"/>
+          </p:nvPr>
+        </p:nvSpPr>
+        <p:spPr/>
+        <p:txBody>
+          <a:bodyPr/>
+          <a:lstStyle/>
+          <a:p>
+            <a:fld id="{F7021451-1387-4CA6-816F-3879F97B5CBC}" type="slidenum">
+              <a:rPr lang="en-US"/>
+              <a:t>13</a:t>
             </a:fld>
             <a:endParaRPr lang="en-US"/>
           </a:p>
@@ -5631,6 +5720,1022 @@
     <p:bg>
       <p:bgPr>
         <a:solidFill>
+          <a:srgbClr val="FFFFFF"/>
+        </a:solidFill>
+      </p:bgPr>
+    </p:bg>
+    <p:spTree>
+      <p:nvGrpSpPr>
+        <p:cNvPr id="1" name=""/>
+        <p:cNvGrpSpPr/>
+        <p:nvPr/>
+      </p:nvGrpSpPr>
+      <p:grpSpPr>
+        <a:xfrm>
+          <a:off x="0" y="0"/>
+          <a:ext cx="0" cy="0"/>
+          <a:chOff x="0" y="0"/>
+          <a:chExt cx="0" cy="0"/>
+        </a:xfrm>
+      </p:grpSpPr>
+      <p:sp>
+        <p:nvSpPr>
+          <p:cNvPr id="2" name="Text 0"/>
+          <p:cNvSpPr/>
+          <p:nvPr/>
+        </p:nvSpPr>
+        <p:spPr>
+          <a:xfrm>
+            <a:off x="548640" y="320040"/>
+            <a:ext cx="11064240" cy="685800"/>
+          </a:xfrm>
+          <a:prstGeom prst="rect">
+            <a:avLst/>
+          </a:prstGeom>
+          <a:noFill/>
+          <a:ln/>
+        </p:spPr>
+        <p:txBody>
+          <a:bodyPr wrap="square" lIns="0" tIns="0" rIns="0" bIns="0" rtlCol="0" anchor="ctr"/>
+          <a:lstStyle/>
+          <a:p>
+            <a:pPr indent="0" marL="0">
+              <a:buNone/>
+            </a:pPr>
+            <a:r>
+              <a:rPr lang="en-US" sz="3000" b="1" dirty="0">
+                <a:solidFill>
+                  <a:srgbClr val="0E3B2E"/>
+                </a:solidFill>
+                <a:latin typeface="Cambria" pitchFamily="34" charset="0"/>
+                <a:ea typeface="Cambria" pitchFamily="34" charset="-122"/>
+                <a:cs typeface="Cambria" pitchFamily="34" charset="-120"/>
+              </a:rPr>
+              <a:t>The CBG incentive stack: every leg de-risked, all on-budget</a:t>
+            </a:r>
+            <a:endParaRPr lang="en-US" sz="3000" dirty="0"/>
+          </a:p>
+        </p:txBody>
+      </p:sp>
+      <p:sp>
+        <p:nvSpPr>
+          <p:cNvPr id="3" name="Text 1"/>
+          <p:cNvSpPr/>
+          <p:nvPr/>
+        </p:nvSpPr>
+        <p:spPr>
+          <a:xfrm>
+            <a:off x="548640" y="932688"/>
+            <a:ext cx="11064240" cy="365760"/>
+          </a:xfrm>
+          <a:prstGeom prst="rect">
+            <a:avLst/>
+          </a:prstGeom>
+          <a:noFill/>
+          <a:ln/>
+        </p:spPr>
+        <p:txBody>
+          <a:bodyPr wrap="square" lIns="0" tIns="0" rIns="0" bIns="0" rtlCol="0" anchor="ctr"/>
+          <a:lstStyle/>
+          <a:p>
+            <a:pPr indent="0" marL="0">
+              <a:buNone/>
+            </a:pPr>
+            <a:r>
+              <a:rPr lang="en-US" sz="1300" dirty="0">
+                <a:solidFill>
+                  <a:srgbClr val="5C6B66"/>
+                </a:solidFill>
+                <a:latin typeface="Calibri" pitchFamily="34" charset="0"/>
+                <a:ea typeface="Calibri" pitchFamily="34" charset="-122"/>
+                <a:cs typeface="Calibri" pitchFamily="34" charset="-120"/>
+              </a:rPr>
+              <a:t>GOBARdhan important-circulars register (70 circulars, ~half dated 2025-26) · full detail in the paper's Annex A</a:t>
+            </a:r>
+            <a:endParaRPr lang="en-US" sz="1300" dirty="0"/>
+          </a:p>
+        </p:txBody>
+      </p:sp>
+      <p:sp>
+        <p:nvSpPr>
+          <p:cNvPr id="4" name="Shape 2"/>
+          <p:cNvSpPr/>
+          <p:nvPr/>
+        </p:nvSpPr>
+        <p:spPr>
+          <a:xfrm>
+            <a:off x="548640" y="1554480"/>
+            <a:ext cx="5440680" cy="1060704"/>
+          </a:xfrm>
+          <a:prstGeom prst="roundRect">
+            <a:avLst>
+              <a:gd name="adj" fmla="val 6897"/>
+            </a:avLst>
+          </a:prstGeom>
+          <a:solidFill>
+            <a:srgbClr val="F2F6F4"/>
+          </a:solidFill>
+          <a:ln w="9525">
+            <a:solidFill>
+              <a:srgbClr val="D5E0DB"/>
+            </a:solidFill>
+            <a:prstDash val="solid"/>
+          </a:ln>
+        </p:spPr>
+      </p:sp>
+      <p:sp>
+        <p:nvSpPr>
+          <p:cNvPr id="5" name="Text 3"/>
+          <p:cNvSpPr/>
+          <p:nvPr/>
+        </p:nvSpPr>
+        <p:spPr>
+          <a:xfrm>
+            <a:off x="713232" y="1618488"/>
+            <a:ext cx="5120640" cy="310896"/>
+          </a:xfrm>
+          <a:prstGeom prst="rect">
+            <a:avLst/>
+          </a:prstGeom>
+          <a:noFill/>
+          <a:ln/>
+        </p:spPr>
+        <p:txBody>
+          <a:bodyPr wrap="square" lIns="0" tIns="0" rIns="0" bIns="0" rtlCol="0" anchor="ctr"/>
+          <a:lstStyle/>
+          <a:p>
+            <a:pPr indent="0" marL="0">
+              <a:buNone/>
+            </a:pPr>
+            <a:r>
+              <a:rPr lang="en-US" sz="1300" b="1" dirty="0">
+                <a:solidFill>
+                  <a:srgbClr val="0E3B2E"/>
+                </a:solidFill>
+                <a:latin typeface="Calibri" pitchFamily="34" charset="0"/>
+                <a:ea typeface="Calibri" pitchFamily="34" charset="-122"/>
+                <a:cs typeface="Calibri" pitchFamily="34" charset="-120"/>
+              </a:rPr>
+              <a:t>Offtake &amp; pricing</a:t>
+            </a:r>
+            <a:endParaRPr lang="en-US" sz="1300" dirty="0"/>
+          </a:p>
+        </p:txBody>
+      </p:sp>
+      <p:sp>
+        <p:nvSpPr>
+          <p:cNvPr id="6" name="Text 4"/>
+          <p:cNvSpPr/>
+          <p:nvPr/>
+        </p:nvSpPr>
+        <p:spPr>
+          <a:xfrm>
+            <a:off x="713232" y="1938528"/>
+            <a:ext cx="5120640" cy="640080"/>
+          </a:xfrm>
+          <a:prstGeom prst="rect">
+            <a:avLst/>
+          </a:prstGeom>
+          <a:noFill/>
+          <a:ln/>
+        </p:spPr>
+        <p:txBody>
+          <a:bodyPr wrap="square" lIns="0" tIns="0" rIns="0" bIns="0" rtlCol="0" anchor="ctr"/>
+          <a:lstStyle/>
+          <a:p>
+            <a:pPr indent="0" marL="0">
+              <a:buNone/>
+            </a:pPr>
+            <a:r>
+              <a:rPr lang="en-US" sz="1050" dirty="0">
+                <a:solidFill>
+                  <a:srgbClr val="5C6B66"/>
+                </a:solidFill>
+                <a:latin typeface="Calibri" pitchFamily="34" charset="0"/>
+                <a:ea typeface="Calibri" pitchFamily="34" charset="-122"/>
+                <a:cs typeface="Calibri" pitchFamily="34" charset="-120"/>
+              </a:rPr>
+              <a:t>SATAT assured ₹54/kg ex-plant (2022, rev. 2025) · CGD synchronization (2021→2026) · CBO mandate 1%→5% (2024)</a:t>
+            </a:r>
+            <a:endParaRPr lang="en-US" sz="1050" dirty="0"/>
+          </a:p>
+        </p:txBody>
+      </p:sp>
+      <p:sp>
+        <p:nvSpPr>
+          <p:cNvPr id="7" name="Shape 5"/>
+          <p:cNvSpPr/>
+          <p:nvPr/>
+        </p:nvSpPr>
+        <p:spPr>
+          <a:xfrm>
+            <a:off x="6217920" y="1554480"/>
+            <a:ext cx="5440680" cy="1060704"/>
+          </a:xfrm>
+          <a:prstGeom prst="roundRect">
+            <a:avLst>
+              <a:gd name="adj" fmla="val 6897"/>
+            </a:avLst>
+          </a:prstGeom>
+          <a:solidFill>
+            <a:srgbClr val="F2F6F4"/>
+          </a:solidFill>
+          <a:ln w="9525">
+            <a:solidFill>
+              <a:srgbClr val="D5E0DB"/>
+            </a:solidFill>
+            <a:prstDash val="solid"/>
+          </a:ln>
+        </p:spPr>
+      </p:sp>
+      <p:sp>
+        <p:nvSpPr>
+          <p:cNvPr id="8" name="Text 6"/>
+          <p:cNvSpPr/>
+          <p:nvPr/>
+        </p:nvSpPr>
+        <p:spPr>
+          <a:xfrm>
+            <a:off x="6382512" y="1618488"/>
+            <a:ext cx="5120640" cy="310896"/>
+          </a:xfrm>
+          <a:prstGeom prst="rect">
+            <a:avLst/>
+          </a:prstGeom>
+          <a:noFill/>
+          <a:ln/>
+        </p:spPr>
+        <p:txBody>
+          <a:bodyPr wrap="square" lIns="0" tIns="0" rIns="0" bIns="0" rtlCol="0" anchor="ctr"/>
+          <a:lstStyle/>
+          <a:p>
+            <a:pPr indent="0" marL="0">
+              <a:buNone/>
+            </a:pPr>
+            <a:r>
+              <a:rPr lang="en-US" sz="1300" b="1" dirty="0">
+                <a:solidFill>
+                  <a:srgbClr val="0E3B2E"/>
+                </a:solidFill>
+                <a:latin typeface="Calibri" pitchFamily="34" charset="0"/>
+                <a:ea typeface="Calibri" pitchFamily="34" charset="-122"/>
+                <a:cs typeface="Calibri" pitchFamily="34" charset="-120"/>
+              </a:rPr>
+              <a:t>Capital support</a:t>
+            </a:r>
+            <a:endParaRPr lang="en-US" sz="1300" dirty="0"/>
+          </a:p>
+        </p:txBody>
+      </p:sp>
+      <p:sp>
+        <p:nvSpPr>
+          <p:cNvPr id="9" name="Text 7"/>
+          <p:cNvSpPr/>
+          <p:nvPr/>
+        </p:nvSpPr>
+        <p:spPr>
+          <a:xfrm>
+            <a:off x="6382512" y="1938528"/>
+            <a:ext cx="5120640" cy="640080"/>
+          </a:xfrm>
+          <a:prstGeom prst="rect">
+            <a:avLst/>
+          </a:prstGeom>
+          <a:noFill/>
+          <a:ln/>
+        </p:spPr>
+        <p:txBody>
+          <a:bodyPr wrap="square" lIns="0" tIns="0" rIns="0" bIns="0" rtlCol="0" anchor="ctr"/>
+          <a:lstStyle/>
+          <a:p>
+            <a:pPr indent="0" marL="0">
+              <a:buNone/>
+            </a:pPr>
+            <a:r>
+              <a:rPr lang="en-US" sz="1050" dirty="0">
+                <a:solidFill>
+                  <a:srgbClr val="5C6B66"/>
+                </a:solidFill>
+                <a:latin typeface="Calibri" pitchFamily="34" charset="0"/>
+                <a:ea typeface="Calibri" pitchFamily="34" charset="-122"/>
+                <a:cs typeface="Calibri" pitchFamily="34" charset="-120"/>
+              </a:rPr>
+              <a:t>MNRE Waste-to-Energy CFA (2022, rev. 2025) · SBM 2.0 bio-methanation VGF (2025) · SASCI state capital assistance (2026)</a:t>
+            </a:r>
+            <a:endParaRPr lang="en-US" sz="1050" dirty="0"/>
+          </a:p>
+        </p:txBody>
+      </p:sp>
+      <p:sp>
+        <p:nvSpPr>
+          <p:cNvPr id="10" name="Shape 8"/>
+          <p:cNvSpPr/>
+          <p:nvPr/>
+        </p:nvSpPr>
+        <p:spPr>
+          <a:xfrm>
+            <a:off x="548640" y="2724912"/>
+            <a:ext cx="5440680" cy="1060704"/>
+          </a:xfrm>
+          <a:prstGeom prst="roundRect">
+            <a:avLst>
+              <a:gd name="adj" fmla="val 6897"/>
+            </a:avLst>
+          </a:prstGeom>
+          <a:solidFill>
+            <a:srgbClr val="F2F6F4"/>
+          </a:solidFill>
+          <a:ln w="9525">
+            <a:solidFill>
+              <a:srgbClr val="D5E0DB"/>
+            </a:solidFill>
+            <a:prstDash val="solid"/>
+          </a:ln>
+        </p:spPr>
+      </p:sp>
+      <p:sp>
+        <p:nvSpPr>
+          <p:cNvPr id="11" name="Text 9"/>
+          <p:cNvSpPr/>
+          <p:nvPr/>
+        </p:nvSpPr>
+        <p:spPr>
+          <a:xfrm>
+            <a:off x="713232" y="2788920"/>
+            <a:ext cx="5120640" cy="310896"/>
+          </a:xfrm>
+          <a:prstGeom prst="rect">
+            <a:avLst/>
+          </a:prstGeom>
+          <a:noFill/>
+          <a:ln/>
+        </p:spPr>
+        <p:txBody>
+          <a:bodyPr wrap="square" lIns="0" tIns="0" rIns="0" bIns="0" rtlCol="0" anchor="ctr"/>
+          <a:lstStyle/>
+          <a:p>
+            <a:pPr indent="0" marL="0">
+              <a:buNone/>
+            </a:pPr>
+            <a:r>
+              <a:rPr lang="en-US" sz="1300" b="1" dirty="0">
+                <a:solidFill>
+                  <a:srgbClr val="0E3B2E"/>
+                </a:solidFill>
+                <a:latin typeface="Calibri" pitchFamily="34" charset="0"/>
+                <a:ea typeface="Calibri" pitchFamily="34" charset="-122"/>
+                <a:cs typeface="Calibri" pitchFamily="34" charset="-120"/>
+              </a:rPr>
+              <a:t>Infrastructure &amp; feedstock</a:t>
+            </a:r>
+            <a:endParaRPr lang="en-US" sz="1300" dirty="0"/>
+          </a:p>
+        </p:txBody>
+      </p:sp>
+      <p:sp>
+        <p:nvSpPr>
+          <p:cNvPr id="12" name="Text 10"/>
+          <p:cNvSpPr/>
+          <p:nvPr/>
+        </p:nvSpPr>
+        <p:spPr>
+          <a:xfrm>
+            <a:off x="713232" y="3108960"/>
+            <a:ext cx="5120640" cy="640080"/>
+          </a:xfrm>
+          <a:prstGeom prst="rect">
+            <a:avLst/>
+          </a:prstGeom>
+          <a:noFill/>
+          <a:ln/>
+        </p:spPr>
+        <p:txBody>
+          <a:bodyPr wrap="square" lIns="0" tIns="0" rIns="0" bIns="0" rtlCol="0" anchor="ctr"/>
+          <a:lstStyle/>
+          <a:p>
+            <a:pPr indent="0" marL="0">
+              <a:buNone/>
+            </a:pPr>
+            <a:r>
+              <a:rPr lang="en-US" sz="1050" dirty="0">
+                <a:solidFill>
+                  <a:srgbClr val="5C6B66"/>
+                </a:solidFill>
+                <a:latin typeface="Calibri" pitchFamily="34" charset="0"/>
+                <a:ea typeface="Calibri" pitchFamily="34" charset="-122"/>
+                <a:cs typeface="Calibri" pitchFamily="34" charset="-120"/>
+              </a:rPr>
+              <a:t>DPI pipeline-connectivity scheme (2024→2026) · biomass aggregation machinery (2024-25) · crop-residue channelling (2023-24)</a:t>
+            </a:r>
+            <a:endParaRPr lang="en-US" sz="1050" dirty="0"/>
+          </a:p>
+        </p:txBody>
+      </p:sp>
+      <p:sp>
+        <p:nvSpPr>
+          <p:cNvPr id="13" name="Shape 11"/>
+          <p:cNvSpPr/>
+          <p:nvPr/>
+        </p:nvSpPr>
+        <p:spPr>
+          <a:xfrm>
+            <a:off x="6217920" y="2724912"/>
+            <a:ext cx="5440680" cy="1060704"/>
+          </a:xfrm>
+          <a:prstGeom prst="roundRect">
+            <a:avLst>
+              <a:gd name="adj" fmla="val 6897"/>
+            </a:avLst>
+          </a:prstGeom>
+          <a:solidFill>
+            <a:srgbClr val="0E3B2E"/>
+          </a:solidFill>
+          <a:ln w="9525">
+            <a:solidFill>
+              <a:srgbClr val="D5E0DB"/>
+            </a:solidFill>
+            <a:prstDash val="solid"/>
+          </a:ln>
+        </p:spPr>
+      </p:sp>
+      <p:sp>
+        <p:nvSpPr>
+          <p:cNvPr id="14" name="Text 12"/>
+          <p:cNvSpPr/>
+          <p:nvPr/>
+        </p:nvSpPr>
+        <p:spPr>
+          <a:xfrm>
+            <a:off x="6382512" y="2788920"/>
+            <a:ext cx="5120640" cy="310896"/>
+          </a:xfrm>
+          <a:prstGeom prst="rect">
+            <a:avLst/>
+          </a:prstGeom>
+          <a:noFill/>
+          <a:ln/>
+        </p:spPr>
+        <p:txBody>
+          <a:bodyPr wrap="square" lIns="0" tIns="0" rIns="0" bIns="0" rtlCol="0" anchor="ctr"/>
+          <a:lstStyle/>
+          <a:p>
+            <a:pPr indent="0" marL="0">
+              <a:buNone/>
+            </a:pPr>
+            <a:r>
+              <a:rPr lang="en-US" sz="1300" b="1" dirty="0">
+                <a:solidFill>
+                  <a:srgbClr val="E3A72F"/>
+                </a:solidFill>
+                <a:latin typeface="Calibri" pitchFamily="34" charset="0"/>
+                <a:ea typeface="Calibri" pitchFamily="34" charset="-122"/>
+                <a:cs typeface="Calibri" pitchFamily="34" charset="-120"/>
+              </a:rPr>
+              <a:t>Fertiliser (digestate) leg</a:t>
+            </a:r>
+            <a:endParaRPr lang="en-US" sz="1300" dirty="0"/>
+          </a:p>
+        </p:txBody>
+      </p:sp>
+      <p:sp>
+        <p:nvSpPr>
+          <p:cNvPr id="15" name="Text 13"/>
+          <p:cNvSpPr/>
+          <p:nvPr/>
+        </p:nvSpPr>
+        <p:spPr>
+          <a:xfrm>
+            <a:off x="6382512" y="3108960"/>
+            <a:ext cx="5120640" cy="640080"/>
+          </a:xfrm>
+          <a:prstGeom prst="rect">
+            <a:avLst/>
+          </a:prstGeom>
+          <a:noFill/>
+          <a:ln/>
+        </p:spPr>
+        <p:txBody>
+          <a:bodyPr wrap="square" lIns="0" tIns="0" rIns="0" bIns="0" rtlCol="0" anchor="ctr"/>
+          <a:lstStyle/>
+          <a:p>
+            <a:pPr indent="0" marL="0">
+              <a:buNone/>
+            </a:pPr>
+            <a:r>
+              <a:rPr lang="en-US" sz="1050" dirty="0">
+                <a:solidFill>
+                  <a:srgbClr val="E8F1EC"/>
+                </a:solidFill>
+                <a:latin typeface="Calibri" pitchFamily="34" charset="0"/>
+                <a:ea typeface="Calibri" pitchFamily="34" charset="-122"/>
+                <a:cs typeface="Calibri" pitchFamily="34" charset="-120"/>
+              </a:rPr>
+              <a:t>FCO Schedule VIII 'Organic Carbon Enhancer' (2025, gazette-verified) · Bulk Sale Notifications I–VII · MDA ~₹1,500/t · ICAR practice guide</a:t>
+            </a:r>
+            <a:endParaRPr lang="en-US" sz="1050" dirty="0"/>
+          </a:p>
+        </p:txBody>
+      </p:sp>
+      <p:sp>
+        <p:nvSpPr>
+          <p:cNvPr id="16" name="Shape 14"/>
+          <p:cNvSpPr/>
+          <p:nvPr/>
+        </p:nvSpPr>
+        <p:spPr>
+          <a:xfrm>
+            <a:off x="548640" y="3895344"/>
+            <a:ext cx="5440680" cy="1060704"/>
+          </a:xfrm>
+          <a:prstGeom prst="roundRect">
+            <a:avLst>
+              <a:gd name="adj" fmla="val 6897"/>
+            </a:avLst>
+          </a:prstGeom>
+          <a:solidFill>
+            <a:srgbClr val="F2F6F4"/>
+          </a:solidFill>
+          <a:ln w="9525">
+            <a:solidFill>
+              <a:srgbClr val="D5E0DB"/>
+            </a:solidFill>
+            <a:prstDash val="solid"/>
+          </a:ln>
+        </p:spPr>
+      </p:sp>
+      <p:sp>
+        <p:nvSpPr>
+          <p:cNvPr id="17" name="Text 15"/>
+          <p:cNvSpPr/>
+          <p:nvPr/>
+        </p:nvSpPr>
+        <p:spPr>
+          <a:xfrm>
+            <a:off x="713232" y="3959352"/>
+            <a:ext cx="5120640" cy="310896"/>
+          </a:xfrm>
+          <a:prstGeom prst="rect">
+            <a:avLst/>
+          </a:prstGeom>
+          <a:noFill/>
+          <a:ln/>
+        </p:spPr>
+        <p:txBody>
+          <a:bodyPr wrap="square" lIns="0" tIns="0" rIns="0" bIns="0" rtlCol="0" anchor="ctr"/>
+          <a:lstStyle/>
+          <a:p>
+            <a:pPr indent="0" marL="0">
+              <a:buNone/>
+            </a:pPr>
+            <a:r>
+              <a:rPr lang="en-US" sz="1300" b="1" dirty="0">
+                <a:solidFill>
+                  <a:srgbClr val="0E3B2E"/>
+                </a:solidFill>
+                <a:latin typeface="Calibri" pitchFamily="34" charset="0"/>
+                <a:ea typeface="Calibri" pitchFamily="34" charset="-122"/>
+                <a:cs typeface="Calibri" pitchFamily="34" charset="-120"/>
+              </a:rPr>
+              <a:t>Finance access</a:t>
+            </a:r>
+            <a:endParaRPr lang="en-US" sz="1300" dirty="0"/>
+          </a:p>
+        </p:txBody>
+      </p:sp>
+      <p:sp>
+        <p:nvSpPr>
+          <p:cNvPr id="18" name="Text 16"/>
+          <p:cNvSpPr/>
+          <p:nvPr/>
+        </p:nvSpPr>
+        <p:spPr>
+          <a:xfrm>
+            <a:off x="713232" y="4279392"/>
+            <a:ext cx="5120640" cy="640080"/>
+          </a:xfrm>
+          <a:prstGeom prst="rect">
+            <a:avLst/>
+          </a:prstGeom>
+          <a:noFill/>
+          <a:ln/>
+        </p:spPr>
+        <p:txBody>
+          <a:bodyPr wrap="square" lIns="0" tIns="0" rIns="0" bIns="0" rtlCol="0" anchor="ctr"/>
+          <a:lstStyle/>
+          <a:p>
+            <a:pPr indent="0" marL="0">
+              <a:buNone/>
+            </a:pPr>
+            <a:r>
+              <a:rPr lang="en-US" sz="1050" dirty="0">
+                <a:solidFill>
+                  <a:srgbClr val="5C6B66"/>
+                </a:solidFill>
+                <a:latin typeface="Calibri" pitchFamily="34" charset="0"/>
+                <a:ea typeface="Calibri" pitchFamily="34" charset="-122"/>
+                <a:cs typeface="Calibri" pitchFamily="34" charset="-120"/>
+              </a:rPr>
+              <a:t>RBI Priority Sector Lending (2020) · Agriculture Infrastructure Fund (2020/23) · AHIDF (2022)</a:t>
+            </a:r>
+            <a:endParaRPr lang="en-US" sz="1050" dirty="0"/>
+          </a:p>
+        </p:txBody>
+      </p:sp>
+      <p:sp>
+        <p:nvSpPr>
+          <p:cNvPr id="19" name="Shape 17"/>
+          <p:cNvSpPr/>
+          <p:nvPr/>
+        </p:nvSpPr>
+        <p:spPr>
+          <a:xfrm>
+            <a:off x="6217920" y="3895344"/>
+            <a:ext cx="5440680" cy="1060704"/>
+          </a:xfrm>
+          <a:prstGeom prst="roundRect">
+            <a:avLst>
+              <a:gd name="adj" fmla="val 6897"/>
+            </a:avLst>
+          </a:prstGeom>
+          <a:solidFill>
+            <a:srgbClr val="F2F6F4"/>
+          </a:solidFill>
+          <a:ln w="9525">
+            <a:solidFill>
+              <a:srgbClr val="D5E0DB"/>
+            </a:solidFill>
+            <a:prstDash val="solid"/>
+          </a:ln>
+        </p:spPr>
+      </p:sp>
+      <p:sp>
+        <p:nvSpPr>
+          <p:cNvPr id="20" name="Text 18"/>
+          <p:cNvSpPr/>
+          <p:nvPr/>
+        </p:nvSpPr>
+        <p:spPr>
+          <a:xfrm>
+            <a:off x="6382512" y="3959352"/>
+            <a:ext cx="5120640" cy="310896"/>
+          </a:xfrm>
+          <a:prstGeom prst="rect">
+            <a:avLst/>
+          </a:prstGeom>
+          <a:noFill/>
+          <a:ln/>
+        </p:spPr>
+        <p:txBody>
+          <a:bodyPr wrap="square" lIns="0" tIns="0" rIns="0" bIns="0" rtlCol="0" anchor="ctr"/>
+          <a:lstStyle/>
+          <a:p>
+            <a:pPr indent="0" marL="0">
+              <a:buNone/>
+            </a:pPr>
+            <a:r>
+              <a:rPr lang="en-US" sz="1300" b="1" dirty="0">
+                <a:solidFill>
+                  <a:srgbClr val="0E3B2E"/>
+                </a:solidFill>
+                <a:latin typeface="Calibri" pitchFamily="34" charset="0"/>
+                <a:ea typeface="Calibri" pitchFamily="34" charset="-122"/>
+                <a:cs typeface="Calibri" pitchFamily="34" charset="-120"/>
+              </a:rPr>
+              <a:t>Tax &amp; carbon</a:t>
+            </a:r>
+            <a:endParaRPr lang="en-US" sz="1300" dirty="0"/>
+          </a:p>
+        </p:txBody>
+      </p:sp>
+      <p:sp>
+        <p:nvSpPr>
+          <p:cNvPr id="21" name="Text 19"/>
+          <p:cNvSpPr/>
+          <p:nvPr/>
+        </p:nvSpPr>
+        <p:spPr>
+          <a:xfrm>
+            <a:off x="6382512" y="4279392"/>
+            <a:ext cx="5120640" cy="640080"/>
+          </a:xfrm>
+          <a:prstGeom prst="rect">
+            <a:avLst/>
+          </a:prstGeom>
+          <a:noFill/>
+          <a:ln/>
+        </p:spPr>
+        <p:txBody>
+          <a:bodyPr wrap="square" lIns="0" tIns="0" rIns="0" bIns="0" rtlCol="0" anchor="ctr"/>
+          <a:lstStyle/>
+          <a:p>
+            <a:pPr indent="0" marL="0">
+              <a:buNone/>
+            </a:pPr>
+            <a:r>
+              <a:rPr lang="en-US" sz="1050" dirty="0">
+                <a:solidFill>
+                  <a:srgbClr val="5C6B66"/>
+                </a:solidFill>
+                <a:latin typeface="Calibri" pitchFamily="34" charset="0"/>
+                <a:ea typeface="Calibri" pitchFamily="34" charset="-122"/>
+                <a:cs typeface="Calibri" pitchFamily="34" charset="-120"/>
+              </a:rPr>
+              <a:t>5% GST · excise exemption on CBG-blended CNG (2023) · carbon-credit eligibility (MoEFCC 2023)</a:t>
+            </a:r>
+            <a:endParaRPr lang="en-US" sz="1050" dirty="0"/>
+          </a:p>
+        </p:txBody>
+      </p:sp>
+      <p:sp>
+        <p:nvSpPr>
+          <p:cNvPr id="22" name="Shape 20"/>
+          <p:cNvSpPr/>
+          <p:nvPr/>
+        </p:nvSpPr>
+        <p:spPr>
+          <a:xfrm>
+            <a:off x="548640" y="5065776"/>
+            <a:ext cx="5440680" cy="1060704"/>
+          </a:xfrm>
+          <a:prstGeom prst="roundRect">
+            <a:avLst>
+              <a:gd name="adj" fmla="val 6897"/>
+            </a:avLst>
+          </a:prstGeom>
+          <a:solidFill>
+            <a:srgbClr val="F2F6F4"/>
+          </a:solidFill>
+          <a:ln w="9525">
+            <a:solidFill>
+              <a:srgbClr val="D5E0DB"/>
+            </a:solidFill>
+            <a:prstDash val="solid"/>
+          </a:ln>
+        </p:spPr>
+      </p:sp>
+      <p:sp>
+        <p:nvSpPr>
+          <p:cNvPr id="23" name="Text 21"/>
+          <p:cNvSpPr/>
+          <p:nvPr/>
+        </p:nvSpPr>
+        <p:spPr>
+          <a:xfrm>
+            <a:off x="713232" y="5129784"/>
+            <a:ext cx="5120640" cy="310896"/>
+          </a:xfrm>
+          <a:prstGeom prst="rect">
+            <a:avLst/>
+          </a:prstGeom>
+          <a:noFill/>
+          <a:ln/>
+        </p:spPr>
+        <p:txBody>
+          <a:bodyPr wrap="square" lIns="0" tIns="0" rIns="0" bIns="0" rtlCol="0" anchor="ctr"/>
+          <a:lstStyle/>
+          <a:p>
+            <a:pPr indent="0" marL="0">
+              <a:buNone/>
+            </a:pPr>
+            <a:r>
+              <a:rPr lang="en-US" sz="1300" b="1" dirty="0">
+                <a:solidFill>
+                  <a:srgbClr val="0E3B2E"/>
+                </a:solidFill>
+                <a:latin typeface="Calibri" pitchFamily="34" charset="0"/>
+                <a:ea typeface="Calibri" pitchFamily="34" charset="-122"/>
+                <a:cs typeface="Calibri" pitchFamily="34" charset="-120"/>
+              </a:rPr>
+              <a:t>Standards &amp; easing</a:t>
+            </a:r>
+            <a:endParaRPr lang="en-US" sz="1300" dirty="0"/>
+          </a:p>
+        </p:txBody>
+      </p:sp>
+      <p:sp>
+        <p:nvSpPr>
+          <p:cNvPr id="24" name="Text 22"/>
+          <p:cNvSpPr/>
+          <p:nvPr/>
+        </p:nvSpPr>
+        <p:spPr>
+          <a:xfrm>
+            <a:off x="713232" y="5449824"/>
+            <a:ext cx="5120640" cy="640080"/>
+          </a:xfrm>
+          <a:prstGeom prst="rect">
+            <a:avLst/>
+          </a:prstGeom>
+          <a:noFill/>
+          <a:ln/>
+        </p:spPr>
+        <p:txBody>
+          <a:bodyPr wrap="square" lIns="0" tIns="0" rIns="0" bIns="0" rtlCol="0" anchor="ctr"/>
+          <a:lstStyle/>
+          <a:p>
+            <a:pPr indent="0" marL="0">
+              <a:buNone/>
+            </a:pPr>
+            <a:r>
+              <a:rPr lang="en-US" sz="1050" dirty="0">
+                <a:solidFill>
+                  <a:srgbClr val="5C6B66"/>
+                </a:solidFill>
+                <a:latin typeface="Calibri" pitchFamily="34" charset="0"/>
+                <a:ea typeface="Calibri" pitchFamily="34" charset="-122"/>
+                <a:cs typeface="Calibri" pitchFamily="34" charset="-120"/>
+              </a:rPr>
+              <a:t>IS 16087:2025 (= legal CNG fungibility) · MoRTH bio-CNG fuel notification (2015) · CPCB re-categorisation (2021/25)</a:t>
+            </a:r>
+            <a:endParaRPr lang="en-US" sz="1050" dirty="0"/>
+          </a:p>
+        </p:txBody>
+      </p:sp>
+      <p:sp>
+        <p:nvSpPr>
+          <p:cNvPr id="25" name="Shape 23"/>
+          <p:cNvSpPr/>
+          <p:nvPr/>
+        </p:nvSpPr>
+        <p:spPr>
+          <a:xfrm>
+            <a:off x="6217920" y="5065776"/>
+            <a:ext cx="5440680" cy="1060704"/>
+          </a:xfrm>
+          <a:prstGeom prst="roundRect">
+            <a:avLst>
+              <a:gd name="adj" fmla="val 6897"/>
+            </a:avLst>
+          </a:prstGeom>
+          <a:solidFill>
+            <a:srgbClr val="F2F6F4"/>
+          </a:solidFill>
+          <a:ln w="9525">
+            <a:solidFill>
+              <a:srgbClr val="D5E0DB"/>
+            </a:solidFill>
+            <a:prstDash val="solid"/>
+          </a:ln>
+        </p:spPr>
+      </p:sp>
+      <p:sp>
+        <p:nvSpPr>
+          <p:cNvPr id="26" name="Text 24"/>
+          <p:cNvSpPr/>
+          <p:nvPr/>
+        </p:nvSpPr>
+        <p:spPr>
+          <a:xfrm>
+            <a:off x="6382512" y="5129784"/>
+            <a:ext cx="5120640" cy="310896"/>
+          </a:xfrm>
+          <a:prstGeom prst="rect">
+            <a:avLst/>
+          </a:prstGeom>
+          <a:noFill/>
+          <a:ln/>
+        </p:spPr>
+        <p:txBody>
+          <a:bodyPr wrap="square" lIns="0" tIns="0" rIns="0" bIns="0" rtlCol="0" anchor="ctr"/>
+          <a:lstStyle/>
+          <a:p>
+            <a:pPr indent="0" marL="0">
+              <a:buNone/>
+            </a:pPr>
+            <a:r>
+              <a:rPr lang="en-US" sz="1300" b="1" dirty="0">
+                <a:solidFill>
+                  <a:srgbClr val="0E3B2E"/>
+                </a:solidFill>
+                <a:latin typeface="Calibri" pitchFamily="34" charset="0"/>
+                <a:ea typeface="Calibri" pitchFamily="34" charset="-122"/>
+                <a:cs typeface="Calibri" pitchFamily="34" charset="-120"/>
+              </a:rPr>
+              <a:t>State layer</a:t>
+            </a:r>
+            <a:endParaRPr lang="en-US" sz="1300" dirty="0"/>
+          </a:p>
+        </p:txBody>
+      </p:sp>
+      <p:sp>
+        <p:nvSpPr>
+          <p:cNvPr id="27" name="Text 25"/>
+          <p:cNvSpPr/>
+          <p:nvPr/>
+        </p:nvSpPr>
+        <p:spPr>
+          <a:xfrm>
+            <a:off x="6382512" y="5449824"/>
+            <a:ext cx="5120640" cy="640080"/>
+          </a:xfrm>
+          <a:prstGeom prst="rect">
+            <a:avLst/>
+          </a:prstGeom>
+          <a:noFill/>
+          <a:ln/>
+        </p:spPr>
+        <p:txBody>
+          <a:bodyPr wrap="square" lIns="0" tIns="0" rIns="0" bIns="0" rtlCol="0" anchor="ctr"/>
+          <a:lstStyle/>
+          <a:p>
+            <a:pPr indent="0" marL="0">
+              <a:buNone/>
+            </a:pPr>
+            <a:r>
+              <a:rPr lang="en-US" sz="1050" dirty="0">
+                <a:solidFill>
+                  <a:srgbClr val="5C6B66"/>
+                </a:solidFill>
+                <a:latin typeface="Calibri" pitchFamily="34" charset="0"/>
+                <a:ea typeface="Calibri" pitchFamily="34" charset="-122"/>
+                <a:cs typeface="Calibri" pitchFamily="34" charset="-120"/>
+              </a:rPr>
+              <a:t>UP · Bihar · Rajasthan · AP · Assam · MP · Chhattisgarh (Jul-2026) + MoPNG Model State CBG Policy (Apr-2026)</a:t>
+            </a:r>
+            <a:endParaRPr lang="en-US" sz="1050" dirty="0"/>
+          </a:p>
+        </p:txBody>
+      </p:sp>
+      <p:sp>
+        <p:nvSpPr>
+          <p:cNvPr id="28" name="Shape 26"/>
+          <p:cNvSpPr/>
+          <p:nvPr/>
+        </p:nvSpPr>
+        <p:spPr>
+          <a:xfrm>
+            <a:off x="548640" y="6217920"/>
+            <a:ext cx="11109960" cy="548640"/>
+          </a:xfrm>
+          <a:prstGeom prst="roundRect">
+            <a:avLst>
+              <a:gd name="adj" fmla="val 13333"/>
+            </a:avLst>
+          </a:prstGeom>
+          <a:solidFill>
+            <a:srgbClr val="0E3B2E"/>
+          </a:solidFill>
+          <a:ln w="9525">
+            <a:solidFill>
+              <a:srgbClr val="D5E0DB"/>
+            </a:solidFill>
+            <a:prstDash val="solid"/>
+          </a:ln>
+        </p:spPr>
+      </p:sp>
+      <p:sp>
+        <p:nvSpPr>
+          <p:cNvPr id="29" name="Text 27"/>
+          <p:cNvSpPr/>
+          <p:nvPr/>
+        </p:nvSpPr>
+        <p:spPr>
+          <a:xfrm>
+            <a:off x="777240" y="6245352"/>
+            <a:ext cx="10698480" cy="493776"/>
+          </a:xfrm>
+          <a:prstGeom prst="rect">
+            <a:avLst/>
+          </a:prstGeom>
+          <a:noFill/>
+          <a:ln/>
+        </p:spPr>
+        <p:txBody>
+          <a:bodyPr wrap="square" lIns="0" tIns="0" rIns="0" bIns="0" rtlCol="0" anchor="ctr"/>
+          <a:lstStyle/>
+          <a:p>
+            <a:pPr indent="0" marL="0">
+              <a:buNone/>
+            </a:pPr>
+            <a:r>
+              <a:rPr lang="en-US" sz="1200" b="1" dirty="0">
+                <a:solidFill>
+                  <a:srgbClr val="FFFFFF"/>
+                </a:solidFill>
+                <a:latin typeface="Calibri" pitchFamily="34" charset="0"/>
+                <a:ea typeface="Calibri" pitchFamily="34" charset="-122"/>
+                <a:cs typeface="Calibri" pitchFamily="34" charset="-120"/>
+              </a:rPr>
+              <a:t>Feedstock, capex, debt, gas revenue, digestate revenue, carbon revenue — all supported ON-BUDGET and ex-plant: the structural opposite of ethanol's consumer-funded volume dividend.</a:t>
+            </a:r>
+            <a:endParaRPr lang="en-US" sz="1200" dirty="0"/>
+          </a:p>
+        </p:txBody>
+      </p:sp>
+    </p:spTree>
+  </p:cSld>
+  <p:clrMapOvr>
+    <a:masterClrMapping/>
+  </p:clrMapOvr>
+</p:sld>
+</file>
+
+<file path=ppt/slides/slide13.xml><?xml version="1.0" encoding="utf-8"?>
+<p:sld xmlns:a="http://schemas.openxmlformats.org/drawingml/2006/main" xmlns:r="http://schemas.openxmlformats.org/officeDocument/2006/relationships" xmlns:p="http://schemas.openxmlformats.org/presentationml/2006/main">
+  <p:cSld name="Slide 13">
+    <p:bg>
+      <p:bgPr>
+        <a:solidFill>
           <a:srgbClr val="0E3B2E"/>
         </a:solidFill>
       </p:bgPr>

</xml_diff>

<commit_message>
docs: paper section 10 (DME in LPG, LERC basis) + slide 13 — the fourth quadrant
Four-quadrant table completes the framework: ethanol (taxed, dilutes ->
exchequer gains), biodiesel (mild), CBG (parity, honest), DME (subsidised,
-37%/kg -> consumer AND exchequer pay). Glossary + sources extended.

Co-Authored-By: Claude Fable 5 <noreply@anthropic.com>
</commit_message>
<xml_diff>
--- a/docs/Volume_Dividend_Slides.pptx
+++ b/docs/Volume_Dividend_Slides.pptx
@@ -18,9 +18,10 @@
     <p:sldId id="266" r:id="rId12"/>
     <p:sldId id="267" r:id="rId13"/>
     <p:sldId id="268" r:id="rId14"/>
+    <p:sldId id="269" r:id="rId15"/>
   </p:sldIdLst>
   <p:notesMasterIdLst>
-    <p:notesMasterId r:id="rId15"/>
+    <p:notesMasterId r:id="rId16"/>
   </p:notesMasterIdLst>
   <p:sldSz cx="12192000" cy="6858000"/>
   <p:notesSz cx="6858000" cy="12192000"/>
@@ -2384,6 +2385,94 @@
             <a:fld id="{F7021451-1387-4CA6-816F-3879F97B5CBC}" type="slidenum">
               <a:rPr lang="en-US"/>
               <a:t>13</a:t>
+            </a:fld>
+            <a:endParaRPr lang="en-US"/>
+          </a:p>
+        </p:txBody>
+      </p:sp>
+    </p:spTree>
+    <p:extLst>
+      <p:ext uri="{BB962C8B-B14F-4D97-AF65-F5344CB8AC3E}">
+        <p14:creationId xmlns:p14="http://schemas.microsoft.com/office/powerpoint/2010/main" val="1024086991"/>
+      </p:ext>
+    </p:extLst>
+  </p:cSld>
+  <p:clrMapOvr>
+    <a:masterClrMapping/>
+  </p:clrMapOvr>
+</p:notes>
+</file>
+
+<file path=ppt/notesSlides/notesSlide14.xml><?xml version="1.0" encoding="utf-8"?>
+<p:notes xmlns:a="http://schemas.openxmlformats.org/drawingml/2006/main" xmlns:r="http://schemas.openxmlformats.org/officeDocument/2006/relationships" xmlns:p="http://schemas.openxmlformats.org/presentationml/2006/main">
+  <p:cSld>
+    <p:spTree>
+      <p:nvGrpSpPr>
+        <p:cNvPr id="1" name=""/>
+        <p:cNvGrpSpPr/>
+        <p:nvPr/>
+      </p:nvGrpSpPr>
+      <p:grpSpPr>
+        <a:xfrm>
+          <a:off x="0" y="0"/>
+          <a:ext cx="0" cy="0"/>
+          <a:chOff x="0" y="0"/>
+          <a:chExt cx="0" cy="0"/>
+        </a:xfrm>
+      </p:grpSpPr>
+      <p:sp>
+        <p:nvSpPr>
+          <p:cNvPr id="2" name="Slide Image Placeholder 1"/>
+          <p:cNvSpPr>
+            <a:spLocks noGrp="1" noRot="1" noChangeAspect="1"/>
+          </p:cNvSpPr>
+          <p:nvPr>
+            <p:ph type="sldImg"/>
+          </p:nvPr>
+        </p:nvSpPr>
+        <p:spPr/>
+      </p:sp>
+      <p:sp>
+        <p:nvSpPr>
+          <p:cNvPr id="3" name="Notes Placeholder 2"/>
+          <p:cNvSpPr>
+            <a:spLocks noGrp="1"/>
+          </p:cNvSpPr>
+          <p:nvPr>
+            <p:ph type="body" idx="1"/>
+          </p:nvPr>
+        </p:nvSpPr>
+        <p:spPr/>
+        <p:txBody>
+          <a:bodyPr/>
+          <a:lstStyle/>
+          <a:p>
+            <a:r>
+              <a:rPr lang="en-US" dirty="0"/>
+              <a:t/>
+            </a:r>
+            <a:endParaRPr lang="en-US" dirty="0"/>
+          </a:p>
+        </p:txBody>
+      </p:sp>
+      <p:sp>
+        <p:nvSpPr>
+          <p:cNvPr id="4" name="Slide Number Placeholder 3"/>
+          <p:cNvSpPr>
+            <a:spLocks noGrp="1"/>
+          </p:cNvSpPr>
+          <p:nvPr>
+            <p:ph type="sldNum" sz="quarter" idx="10"/>
+          </p:nvPr>
+        </p:nvSpPr>
+        <p:spPr/>
+        <p:txBody>
+          <a:bodyPr/>
+          <a:lstStyle/>
+          <a:p>
+            <a:fld id="{F7021451-1387-4CA6-816F-3879F97B5CBC}" type="slidenum">
+              <a:rPr lang="en-US"/>
+              <a:t>14</a:t>
             </a:fld>
             <a:endParaRPr lang="en-US"/>
           </a:p>
@@ -6736,6 +6825,1625 @@
     <p:bg>
       <p:bgPr>
         <a:solidFill>
+          <a:srgbClr val="FFFFFF"/>
+        </a:solidFill>
+      </p:bgPr>
+    </p:bg>
+    <p:spTree>
+      <p:nvGrpSpPr>
+        <p:cNvPr id="1" name=""/>
+        <p:cNvGrpSpPr/>
+        <p:nvPr/>
+      </p:nvGrpSpPr>
+      <p:grpSpPr>
+        <a:xfrm>
+          <a:off x="0" y="0"/>
+          <a:ext cx="0" cy="0"/>
+          <a:chOff x="0" y="0"/>
+          <a:chExt cx="0" cy="0"/>
+        </a:xfrm>
+      </p:grpSpPr>
+      <p:sp>
+        <p:nvSpPr>
+          <p:cNvPr id="2" name="Text 0"/>
+          <p:cNvSpPr/>
+          <p:nvPr/>
+        </p:nvSpPr>
+        <p:spPr>
+          <a:xfrm>
+            <a:off x="548640" y="320040"/>
+            <a:ext cx="11064240" cy="685800"/>
+          </a:xfrm>
+          <a:prstGeom prst="rect">
+            <a:avLst/>
+          </a:prstGeom>
+          <a:noFill/>
+          <a:ln/>
+        </p:spPr>
+        <p:txBody>
+          <a:bodyPr wrap="square" lIns="0" tIns="0" rIns="0" bIns="0" rtlCol="0" anchor="ctr"/>
+          <a:lstStyle/>
+          <a:p>
+            <a:pPr indent="0" marL="0">
+              <a:buNone/>
+            </a:pPr>
+            <a:r>
+              <a:rPr lang="en-US" sz="3000" b="1" dirty="0">
+                <a:solidFill>
+                  <a:srgbClr val="0E3B2E"/>
+                </a:solidFill>
+                <a:latin typeface="Cambria" pitchFamily="34" charset="0"/>
+                <a:ea typeface="Cambria" pitchFamily="34" charset="-122"/>
+                <a:cs typeface="Cambria" pitchFamily="34" charset="-120"/>
+              </a:rPr>
+              <a:t>DME in LPG: the fourth quadrant — the dividend inverts</a:t>
+            </a:r>
+            <a:endParaRPr lang="en-US" sz="3000" dirty="0"/>
+          </a:p>
+        </p:txBody>
+      </p:sp>
+      <p:sp>
+        <p:nvSpPr>
+          <p:cNvPr id="3" name="Text 1"/>
+          <p:cNvSpPr/>
+          <p:nvPr/>
+        </p:nvSpPr>
+        <p:spPr>
+          <a:xfrm>
+            <a:off x="548640" y="932688"/>
+            <a:ext cx="11064240" cy="365760"/>
+          </a:xfrm>
+          <a:prstGeom prst="rect">
+            <a:avLst/>
+          </a:prstGeom>
+          <a:noFill/>
+          <a:ln/>
+        </p:spPr>
+        <p:txBody>
+          <a:bodyPr wrap="square" lIns="0" tIns="0" rIns="0" bIns="0" rtlCol="0" anchor="ctr"/>
+          <a:lstStyle/>
+          <a:p>
+            <a:pPr indent="0" marL="0">
+              <a:buNone/>
+            </a:pPr>
+            <a:r>
+              <a:rPr lang="en-US" sz="1300" dirty="0">
+                <a:solidFill>
+                  <a:srgbClr val="5C6B66"/>
+                </a:solidFill>
+                <a:latin typeface="Calibri" pitchFamily="34" charset="0"/>
+                <a:ea typeface="Calibri" pitchFamily="34" charset="-122"/>
+                <a:cs typeface="Calibri" pitchFamily="34" charset="-120"/>
+              </a:rPr>
+              <a:t>DME 28.8 vs LPG 45.8 MJ/kg (−37%) · LERC-measured −5.26% at DME20 (IS 4246) · BIS IS 18698:2024 caps blends at 20%</a:t>
+            </a:r>
+            <a:endParaRPr lang="en-US" sz="1300" dirty="0"/>
+          </a:p>
+        </p:txBody>
+      </p:sp>
+      <p:sp>
+        <p:nvSpPr>
+          <p:cNvPr id="4" name="Shape 2"/>
+          <p:cNvSpPr/>
+          <p:nvPr/>
+        </p:nvSpPr>
+        <p:spPr>
+          <a:xfrm>
+            <a:off x="548640" y="1600200"/>
+            <a:ext cx="2103120" cy="603504"/>
+          </a:xfrm>
+          <a:prstGeom prst="rect">
+            <a:avLst/>
+          </a:prstGeom>
+          <a:solidFill>
+            <a:srgbClr val="0E3B2E"/>
+          </a:solidFill>
+          <a:ln w="9525">
+            <a:solidFill>
+              <a:srgbClr val="D5E0DB"/>
+            </a:solidFill>
+            <a:prstDash val="solid"/>
+          </a:ln>
+        </p:spPr>
+      </p:sp>
+      <p:sp>
+        <p:nvSpPr>
+          <p:cNvPr id="5" name="Text 3"/>
+          <p:cNvSpPr/>
+          <p:nvPr/>
+        </p:nvSpPr>
+        <p:spPr>
+          <a:xfrm>
+            <a:off x="621792" y="1600200"/>
+            <a:ext cx="1956816" cy="603504"/>
+          </a:xfrm>
+          <a:prstGeom prst="rect">
+            <a:avLst/>
+          </a:prstGeom>
+          <a:noFill/>
+          <a:ln/>
+        </p:spPr>
+        <p:txBody>
+          <a:bodyPr wrap="square" lIns="0" tIns="0" rIns="0" bIns="0" rtlCol="0" anchor="ctr"/>
+          <a:lstStyle/>
+          <a:p>
+            <a:pPr algn="l" indent="0" marL="0">
+              <a:buNone/>
+            </a:pPr>
+            <a:r>
+              <a:rPr lang="en-US" sz="1150" b="1" dirty="0">
+                <a:solidFill>
+                  <a:srgbClr val="FFFFFF"/>
+                </a:solidFill>
+                <a:latin typeface="Calibri" pitchFamily="34" charset="0"/>
+                <a:ea typeface="Calibri" pitchFamily="34" charset="-122"/>
+                <a:cs typeface="Calibri" pitchFamily="34" charset="-120"/>
+              </a:rPr>
+              <a:t>Blend</a:t>
+            </a:r>
+            <a:endParaRPr lang="en-US" sz="1150" dirty="0"/>
+          </a:p>
+        </p:txBody>
+      </p:sp>
+      <p:sp>
+        <p:nvSpPr>
+          <p:cNvPr id="6" name="Shape 4"/>
+          <p:cNvSpPr/>
+          <p:nvPr/>
+        </p:nvSpPr>
+        <p:spPr>
+          <a:xfrm>
+            <a:off x="2651760" y="1600200"/>
+            <a:ext cx="1371600" cy="603504"/>
+          </a:xfrm>
+          <a:prstGeom prst="rect">
+            <a:avLst/>
+          </a:prstGeom>
+          <a:solidFill>
+            <a:srgbClr val="0E3B2E"/>
+          </a:solidFill>
+          <a:ln w="9525">
+            <a:solidFill>
+              <a:srgbClr val="D5E0DB"/>
+            </a:solidFill>
+            <a:prstDash val="solid"/>
+          </a:ln>
+        </p:spPr>
+      </p:sp>
+      <p:sp>
+        <p:nvSpPr>
+          <p:cNvPr id="7" name="Text 5"/>
+          <p:cNvSpPr/>
+          <p:nvPr/>
+        </p:nvSpPr>
+        <p:spPr>
+          <a:xfrm>
+            <a:off x="2724912" y="1600200"/>
+            <a:ext cx="1225296" cy="603504"/>
+          </a:xfrm>
+          <a:prstGeom prst="rect">
+            <a:avLst/>
+          </a:prstGeom>
+          <a:noFill/>
+          <a:ln/>
+        </p:spPr>
+        <p:txBody>
+          <a:bodyPr wrap="square" lIns="0" tIns="0" rIns="0" bIns="0" rtlCol="0" anchor="ctr"/>
+          <a:lstStyle/>
+          <a:p>
+            <a:pPr algn="ctr" indent="0" marL="0">
+              <a:buNone/>
+            </a:pPr>
+            <a:r>
+              <a:rPr lang="en-US" sz="1150" b="1" dirty="0">
+                <a:solidFill>
+                  <a:srgbClr val="FFFFFF"/>
+                </a:solidFill>
+                <a:latin typeface="Calibri" pitchFamily="34" charset="0"/>
+                <a:ea typeface="Calibri" pitchFamily="34" charset="-122"/>
+                <a:cs typeface="Calibri" pitchFamily="34" charset="-120"/>
+              </a:rPr>
+              <a:t>Dilution</a:t>
+            </a:r>
+            <a:endParaRPr lang="en-US" sz="1150" dirty="0"/>
+          </a:p>
+        </p:txBody>
+      </p:sp>
+      <p:sp>
+        <p:nvSpPr>
+          <p:cNvPr id="8" name="Shape 6"/>
+          <p:cNvSpPr/>
+          <p:nvPr/>
+        </p:nvSpPr>
+        <p:spPr>
+          <a:xfrm>
+            <a:off x="4023360" y="1600200"/>
+            <a:ext cx="1828800" cy="603504"/>
+          </a:xfrm>
+          <a:prstGeom prst="rect">
+            <a:avLst/>
+          </a:prstGeom>
+          <a:solidFill>
+            <a:srgbClr val="0E3B2E"/>
+          </a:solidFill>
+          <a:ln w="9525">
+            <a:solidFill>
+              <a:srgbClr val="D5E0DB"/>
+            </a:solidFill>
+            <a:prstDash val="solid"/>
+          </a:ln>
+        </p:spPr>
+      </p:sp>
+      <p:sp>
+        <p:nvSpPr>
+          <p:cNvPr id="9" name="Text 7"/>
+          <p:cNvSpPr/>
+          <p:nvPr/>
+        </p:nvSpPr>
+        <p:spPr>
+          <a:xfrm>
+            <a:off x="4096512" y="1600200"/>
+            <a:ext cx="1682496" cy="603504"/>
+          </a:xfrm>
+          <a:prstGeom prst="rect">
+            <a:avLst/>
+          </a:prstGeom>
+          <a:noFill/>
+          <a:ln/>
+        </p:spPr>
+        <p:txBody>
+          <a:bodyPr wrap="square" lIns="0" tIns="0" rIns="0" bIns="0" rtlCol="0" anchor="ctr"/>
+          <a:lstStyle/>
+          <a:p>
+            <a:pPr algn="ctr" indent="0" marL="0">
+              <a:buNone/>
+            </a:pPr>
+            <a:r>
+              <a:rPr lang="en-US" sz="1150" b="1" dirty="0">
+                <a:solidFill>
+                  <a:srgbClr val="FFFFFF"/>
+                </a:solidFill>
+                <a:latin typeface="Calibri" pitchFamily="34" charset="0"/>
+                <a:ea typeface="Calibri" pitchFamily="34" charset="-122"/>
+                <a:cs typeface="Calibri" pitchFamily="34" charset="-120"/>
+              </a:rPr>
+              <a:t>Fiscal status</a:t>
+            </a:r>
+            <a:endParaRPr lang="en-US" sz="1150" dirty="0"/>
+          </a:p>
+        </p:txBody>
+      </p:sp>
+      <p:sp>
+        <p:nvSpPr>
+          <p:cNvPr id="10" name="Shape 8"/>
+          <p:cNvSpPr/>
+          <p:nvPr/>
+        </p:nvSpPr>
+        <p:spPr>
+          <a:xfrm>
+            <a:off x="5852160" y="1600200"/>
+            <a:ext cx="3017520" cy="603504"/>
+          </a:xfrm>
+          <a:prstGeom prst="rect">
+            <a:avLst/>
+          </a:prstGeom>
+          <a:solidFill>
+            <a:srgbClr val="0E3B2E"/>
+          </a:solidFill>
+          <a:ln w="9525">
+            <a:solidFill>
+              <a:srgbClr val="D5E0DB"/>
+            </a:solidFill>
+            <a:prstDash val="solid"/>
+          </a:ln>
+        </p:spPr>
+      </p:sp>
+      <p:sp>
+        <p:nvSpPr>
+          <p:cNvPr id="11" name="Text 9"/>
+          <p:cNvSpPr/>
+          <p:nvPr/>
+        </p:nvSpPr>
+        <p:spPr>
+          <a:xfrm>
+            <a:off x="5925312" y="1600200"/>
+            <a:ext cx="2871216" cy="603504"/>
+          </a:xfrm>
+          <a:prstGeom prst="rect">
+            <a:avLst/>
+          </a:prstGeom>
+          <a:noFill/>
+          <a:ln/>
+        </p:spPr>
+        <p:txBody>
+          <a:bodyPr wrap="square" lIns="0" tIns="0" rIns="0" bIns="0" rtlCol="0" anchor="ctr"/>
+          <a:lstStyle/>
+          <a:p>
+            <a:pPr algn="ctr" indent="0" marL="0">
+              <a:buNone/>
+            </a:pPr>
+            <a:r>
+              <a:rPr lang="en-US" sz="1150" b="1" dirty="0">
+                <a:solidFill>
+                  <a:srgbClr val="FFFFFF"/>
+                </a:solidFill>
+                <a:latin typeface="Calibri" pitchFamily="34" charset="0"/>
+                <a:ea typeface="Calibri" pitchFamily="34" charset="-122"/>
+                <a:cs typeface="Calibri" pitchFamily="34" charset="-120"/>
+              </a:rPr>
+              <a:t>Volume effect lands on</a:t>
+            </a:r>
+            <a:endParaRPr lang="en-US" sz="1150" dirty="0"/>
+          </a:p>
+        </p:txBody>
+      </p:sp>
+      <p:sp>
+        <p:nvSpPr>
+          <p:cNvPr id="12" name="Shape 10"/>
+          <p:cNvSpPr/>
+          <p:nvPr/>
+        </p:nvSpPr>
+        <p:spPr>
+          <a:xfrm>
+            <a:off x="548640" y="2258568"/>
+            <a:ext cx="2103120" cy="603504"/>
+          </a:xfrm>
+          <a:prstGeom prst="rect">
+            <a:avLst/>
+          </a:prstGeom>
+          <a:solidFill>
+            <a:srgbClr val="F2F6F4"/>
+          </a:solidFill>
+          <a:ln w="9525">
+            <a:solidFill>
+              <a:srgbClr val="D5E0DB"/>
+            </a:solidFill>
+            <a:prstDash val="solid"/>
+          </a:ln>
+        </p:spPr>
+      </p:sp>
+      <p:sp>
+        <p:nvSpPr>
+          <p:cNvPr id="13" name="Text 11"/>
+          <p:cNvSpPr/>
+          <p:nvPr/>
+        </p:nvSpPr>
+        <p:spPr>
+          <a:xfrm>
+            <a:off x="621792" y="2258568"/>
+            <a:ext cx="1956816" cy="603504"/>
+          </a:xfrm>
+          <a:prstGeom prst="rect">
+            <a:avLst/>
+          </a:prstGeom>
+          <a:noFill/>
+          <a:ln/>
+        </p:spPr>
+        <p:txBody>
+          <a:bodyPr wrap="square" lIns="0" tIns="0" rIns="0" bIns="0" rtlCol="0" anchor="ctr"/>
+          <a:lstStyle/>
+          <a:p>
+            <a:pPr algn="l" indent="0" marL="0">
+              <a:buNone/>
+            </a:pPr>
+            <a:r>
+              <a:rPr lang="en-US" sz="1200" b="1" dirty="0">
+                <a:solidFill>
+                  <a:srgbClr val="1C2B27"/>
+                </a:solidFill>
+                <a:latin typeface="Calibri" pitchFamily="34" charset="0"/>
+                <a:ea typeface="Calibri" pitchFamily="34" charset="-122"/>
+                <a:cs typeface="Calibri" pitchFamily="34" charset="-120"/>
+              </a:rPr>
+              <a:t>Ethanol in petrol</a:t>
+            </a:r>
+            <a:endParaRPr lang="en-US" sz="1200" dirty="0"/>
+          </a:p>
+        </p:txBody>
+      </p:sp>
+      <p:sp>
+        <p:nvSpPr>
+          <p:cNvPr id="14" name="Shape 12"/>
+          <p:cNvSpPr/>
+          <p:nvPr/>
+        </p:nvSpPr>
+        <p:spPr>
+          <a:xfrm>
+            <a:off x="2651760" y="2258568"/>
+            <a:ext cx="1371600" cy="603504"/>
+          </a:xfrm>
+          <a:prstGeom prst="rect">
+            <a:avLst/>
+          </a:prstGeom>
+          <a:solidFill>
+            <a:srgbClr val="F2F6F4"/>
+          </a:solidFill>
+          <a:ln w="9525">
+            <a:solidFill>
+              <a:srgbClr val="D5E0DB"/>
+            </a:solidFill>
+            <a:prstDash val="solid"/>
+          </a:ln>
+        </p:spPr>
+      </p:sp>
+      <p:sp>
+        <p:nvSpPr>
+          <p:cNvPr id="15" name="Text 13"/>
+          <p:cNvSpPr/>
+          <p:nvPr/>
+        </p:nvSpPr>
+        <p:spPr>
+          <a:xfrm>
+            <a:off x="2724912" y="2258568"/>
+            <a:ext cx="1225296" cy="603504"/>
+          </a:xfrm>
+          <a:prstGeom prst="rect">
+            <a:avLst/>
+          </a:prstGeom>
+          <a:noFill/>
+          <a:ln/>
+        </p:spPr>
+        <p:txBody>
+          <a:bodyPr wrap="square" lIns="0" tIns="0" rIns="0" bIns="0" rtlCol="0" anchor="ctr"/>
+          <a:lstStyle/>
+          <a:p>
+            <a:pPr algn="ctr" indent="0" marL="0">
+              <a:buNone/>
+            </a:pPr>
+            <a:r>
+              <a:rPr lang="en-US" sz="1200" dirty="0">
+                <a:solidFill>
+                  <a:srgbClr val="1C2B27"/>
+                </a:solidFill>
+                <a:latin typeface="Calibri" pitchFamily="34" charset="0"/>
+                <a:ea typeface="Calibri" pitchFamily="34" charset="-122"/>
+                <a:cs typeface="Calibri" pitchFamily="34" charset="-120"/>
+              </a:rPr>
+              <a:t>−34% /L</a:t>
+            </a:r>
+            <a:endParaRPr lang="en-US" sz="1200" dirty="0"/>
+          </a:p>
+        </p:txBody>
+      </p:sp>
+      <p:sp>
+        <p:nvSpPr>
+          <p:cNvPr id="16" name="Shape 14"/>
+          <p:cNvSpPr/>
+          <p:nvPr/>
+        </p:nvSpPr>
+        <p:spPr>
+          <a:xfrm>
+            <a:off x="4023360" y="2258568"/>
+            <a:ext cx="1828800" cy="603504"/>
+          </a:xfrm>
+          <a:prstGeom prst="rect">
+            <a:avLst/>
+          </a:prstGeom>
+          <a:solidFill>
+            <a:srgbClr val="F2F6F4"/>
+          </a:solidFill>
+          <a:ln w="9525">
+            <a:solidFill>
+              <a:srgbClr val="D5E0DB"/>
+            </a:solidFill>
+            <a:prstDash val="solid"/>
+          </a:ln>
+        </p:spPr>
+      </p:sp>
+      <p:sp>
+        <p:nvSpPr>
+          <p:cNvPr id="17" name="Text 15"/>
+          <p:cNvSpPr/>
+          <p:nvPr/>
+        </p:nvSpPr>
+        <p:spPr>
+          <a:xfrm>
+            <a:off x="4096512" y="2258568"/>
+            <a:ext cx="1682496" cy="603504"/>
+          </a:xfrm>
+          <a:prstGeom prst="rect">
+            <a:avLst/>
+          </a:prstGeom>
+          <a:noFill/>
+          <a:ln/>
+        </p:spPr>
+        <p:txBody>
+          <a:bodyPr wrap="square" lIns="0" tIns="0" rIns="0" bIns="0" rtlCol="0" anchor="ctr"/>
+          <a:lstStyle/>
+          <a:p>
+            <a:pPr algn="ctr" indent="0" marL="0">
+              <a:buNone/>
+            </a:pPr>
+            <a:r>
+              <a:rPr lang="en-US" sz="1200" dirty="0">
+                <a:solidFill>
+                  <a:srgbClr val="1C2B27"/>
+                </a:solidFill>
+                <a:latin typeface="Calibri" pitchFamily="34" charset="0"/>
+                <a:ea typeface="Calibri" pitchFamily="34" charset="-122"/>
+                <a:cs typeface="Calibri" pitchFamily="34" charset="-120"/>
+              </a:rPr>
+              <a:t>heavily taxed</a:t>
+            </a:r>
+            <a:endParaRPr lang="en-US" sz="1200" dirty="0"/>
+          </a:p>
+        </p:txBody>
+      </p:sp>
+      <p:sp>
+        <p:nvSpPr>
+          <p:cNvPr id="18" name="Shape 16"/>
+          <p:cNvSpPr/>
+          <p:nvPr/>
+        </p:nvSpPr>
+        <p:spPr>
+          <a:xfrm>
+            <a:off x="5852160" y="2258568"/>
+            <a:ext cx="3017520" cy="603504"/>
+          </a:xfrm>
+          <a:prstGeom prst="rect">
+            <a:avLst/>
+          </a:prstGeom>
+          <a:solidFill>
+            <a:srgbClr val="F2F6F4"/>
+          </a:solidFill>
+          <a:ln w="9525">
+            <a:solidFill>
+              <a:srgbClr val="D5E0DB"/>
+            </a:solidFill>
+            <a:prstDash val="solid"/>
+          </a:ln>
+        </p:spPr>
+      </p:sp>
+      <p:sp>
+        <p:nvSpPr>
+          <p:cNvPr id="19" name="Text 17"/>
+          <p:cNvSpPr/>
+          <p:nvPr/>
+        </p:nvSpPr>
+        <p:spPr>
+          <a:xfrm>
+            <a:off x="5925312" y="2258568"/>
+            <a:ext cx="2871216" cy="603504"/>
+          </a:xfrm>
+          <a:prstGeom prst="rect">
+            <a:avLst/>
+          </a:prstGeom>
+          <a:noFill/>
+          <a:ln/>
+        </p:spPr>
+        <p:txBody>
+          <a:bodyPr wrap="square" lIns="0" tIns="0" rIns="0" bIns="0" rtlCol="0" anchor="ctr"/>
+          <a:lstStyle/>
+          <a:p>
+            <a:pPr algn="ctr" indent="0" marL="0">
+              <a:buNone/>
+            </a:pPr>
+            <a:r>
+              <a:rPr lang="en-US" sz="1200" dirty="0">
+                <a:solidFill>
+                  <a:srgbClr val="1C2B27"/>
+                </a:solidFill>
+                <a:latin typeface="Calibri" pitchFamily="34" charset="0"/>
+                <a:ea typeface="Calibri" pitchFamily="34" charset="-122"/>
+                <a:cs typeface="Calibri" pitchFamily="34" charset="-120"/>
+              </a:rPr>
+              <a:t>consumer pays; exchequer + trade collect</a:t>
+            </a:r>
+            <a:endParaRPr lang="en-US" sz="1200" dirty="0"/>
+          </a:p>
+        </p:txBody>
+      </p:sp>
+      <p:sp>
+        <p:nvSpPr>
+          <p:cNvPr id="20" name="Shape 18"/>
+          <p:cNvSpPr/>
+          <p:nvPr/>
+        </p:nvSpPr>
+        <p:spPr>
+          <a:xfrm>
+            <a:off x="548640" y="2916936"/>
+            <a:ext cx="2103120" cy="603504"/>
+          </a:xfrm>
+          <a:prstGeom prst="rect">
+            <a:avLst/>
+          </a:prstGeom>
+          <a:solidFill>
+            <a:srgbClr val="FFFFFF"/>
+          </a:solidFill>
+          <a:ln w="9525">
+            <a:solidFill>
+              <a:srgbClr val="D5E0DB"/>
+            </a:solidFill>
+            <a:prstDash val="solid"/>
+          </a:ln>
+        </p:spPr>
+      </p:sp>
+      <p:sp>
+        <p:nvSpPr>
+          <p:cNvPr id="21" name="Text 19"/>
+          <p:cNvSpPr/>
+          <p:nvPr/>
+        </p:nvSpPr>
+        <p:spPr>
+          <a:xfrm>
+            <a:off x="621792" y="2916936"/>
+            <a:ext cx="1956816" cy="603504"/>
+          </a:xfrm>
+          <a:prstGeom prst="rect">
+            <a:avLst/>
+          </a:prstGeom>
+          <a:noFill/>
+          <a:ln/>
+        </p:spPr>
+        <p:txBody>
+          <a:bodyPr wrap="square" lIns="0" tIns="0" rIns="0" bIns="0" rtlCol="0" anchor="ctr"/>
+          <a:lstStyle/>
+          <a:p>
+            <a:pPr algn="l" indent="0" marL="0">
+              <a:buNone/>
+            </a:pPr>
+            <a:r>
+              <a:rPr lang="en-US" sz="1200" b="1" dirty="0">
+                <a:solidFill>
+                  <a:srgbClr val="1C2B27"/>
+                </a:solidFill>
+                <a:latin typeface="Calibri" pitchFamily="34" charset="0"/>
+                <a:ea typeface="Calibri" pitchFamily="34" charset="-122"/>
+                <a:cs typeface="Calibri" pitchFamily="34" charset="-120"/>
+              </a:rPr>
+              <a:t>Biodiesel in diesel</a:t>
+            </a:r>
+            <a:endParaRPr lang="en-US" sz="1200" dirty="0"/>
+          </a:p>
+        </p:txBody>
+      </p:sp>
+      <p:sp>
+        <p:nvSpPr>
+          <p:cNvPr id="22" name="Shape 20"/>
+          <p:cNvSpPr/>
+          <p:nvPr/>
+        </p:nvSpPr>
+        <p:spPr>
+          <a:xfrm>
+            <a:off x="2651760" y="2916936"/>
+            <a:ext cx="1371600" cy="603504"/>
+          </a:xfrm>
+          <a:prstGeom prst="rect">
+            <a:avLst/>
+          </a:prstGeom>
+          <a:solidFill>
+            <a:srgbClr val="FFFFFF"/>
+          </a:solidFill>
+          <a:ln w="9525">
+            <a:solidFill>
+              <a:srgbClr val="D5E0DB"/>
+            </a:solidFill>
+            <a:prstDash val="solid"/>
+          </a:ln>
+        </p:spPr>
+      </p:sp>
+      <p:sp>
+        <p:nvSpPr>
+          <p:cNvPr id="23" name="Text 21"/>
+          <p:cNvSpPr/>
+          <p:nvPr/>
+        </p:nvSpPr>
+        <p:spPr>
+          <a:xfrm>
+            <a:off x="2724912" y="2916936"/>
+            <a:ext cx="1225296" cy="603504"/>
+          </a:xfrm>
+          <a:prstGeom prst="rect">
+            <a:avLst/>
+          </a:prstGeom>
+          <a:noFill/>
+          <a:ln/>
+        </p:spPr>
+        <p:txBody>
+          <a:bodyPr wrap="square" lIns="0" tIns="0" rIns="0" bIns="0" rtlCol="0" anchor="ctr"/>
+          <a:lstStyle/>
+          <a:p>
+            <a:pPr algn="ctr" indent="0" marL="0">
+              <a:buNone/>
+            </a:pPr>
+            <a:r>
+              <a:rPr lang="en-US" sz="1200" dirty="0">
+                <a:solidFill>
+                  <a:srgbClr val="1C2B27"/>
+                </a:solidFill>
+                <a:latin typeface="Calibri" pitchFamily="34" charset="0"/>
+                <a:ea typeface="Calibri" pitchFamily="34" charset="-122"/>
+                <a:cs typeface="Calibri" pitchFamily="34" charset="-120"/>
+              </a:rPr>
+              <a:t>−8% /L</a:t>
+            </a:r>
+            <a:endParaRPr lang="en-US" sz="1200" dirty="0"/>
+          </a:p>
+        </p:txBody>
+      </p:sp>
+      <p:sp>
+        <p:nvSpPr>
+          <p:cNvPr id="24" name="Shape 22"/>
+          <p:cNvSpPr/>
+          <p:nvPr/>
+        </p:nvSpPr>
+        <p:spPr>
+          <a:xfrm>
+            <a:off x="4023360" y="2916936"/>
+            <a:ext cx="1828800" cy="603504"/>
+          </a:xfrm>
+          <a:prstGeom prst="rect">
+            <a:avLst/>
+          </a:prstGeom>
+          <a:solidFill>
+            <a:srgbClr val="FFFFFF"/>
+          </a:solidFill>
+          <a:ln w="9525">
+            <a:solidFill>
+              <a:srgbClr val="D5E0DB"/>
+            </a:solidFill>
+            <a:prstDash val="solid"/>
+          </a:ln>
+        </p:spPr>
+      </p:sp>
+      <p:sp>
+        <p:nvSpPr>
+          <p:cNvPr id="25" name="Text 23"/>
+          <p:cNvSpPr/>
+          <p:nvPr/>
+        </p:nvSpPr>
+        <p:spPr>
+          <a:xfrm>
+            <a:off x="4096512" y="2916936"/>
+            <a:ext cx="1682496" cy="603504"/>
+          </a:xfrm>
+          <a:prstGeom prst="rect">
+            <a:avLst/>
+          </a:prstGeom>
+          <a:noFill/>
+          <a:ln/>
+        </p:spPr>
+        <p:txBody>
+          <a:bodyPr wrap="square" lIns="0" tIns="0" rIns="0" bIns="0" rtlCol="0" anchor="ctr"/>
+          <a:lstStyle/>
+          <a:p>
+            <a:pPr algn="ctr" indent="0" marL="0">
+              <a:buNone/>
+            </a:pPr>
+            <a:r>
+              <a:rPr lang="en-US" sz="1200" dirty="0">
+                <a:solidFill>
+                  <a:srgbClr val="1C2B27"/>
+                </a:solidFill>
+                <a:latin typeface="Calibri" pitchFamily="34" charset="0"/>
+                <a:ea typeface="Calibri" pitchFamily="34" charset="-122"/>
+                <a:cs typeface="Calibri" pitchFamily="34" charset="-120"/>
+              </a:rPr>
+              <a:t>taxed</a:t>
+            </a:r>
+            <a:endParaRPr lang="en-US" sz="1200" dirty="0"/>
+          </a:p>
+        </p:txBody>
+      </p:sp>
+      <p:sp>
+        <p:nvSpPr>
+          <p:cNvPr id="26" name="Shape 24"/>
+          <p:cNvSpPr/>
+          <p:nvPr/>
+        </p:nvSpPr>
+        <p:spPr>
+          <a:xfrm>
+            <a:off x="5852160" y="2916936"/>
+            <a:ext cx="3017520" cy="603504"/>
+          </a:xfrm>
+          <a:prstGeom prst="rect">
+            <a:avLst/>
+          </a:prstGeom>
+          <a:solidFill>
+            <a:srgbClr val="FFFFFF"/>
+          </a:solidFill>
+          <a:ln w="9525">
+            <a:solidFill>
+              <a:srgbClr val="D5E0DB"/>
+            </a:solidFill>
+            <a:prstDash val="solid"/>
+          </a:ln>
+        </p:spPr>
+      </p:sp>
+      <p:sp>
+        <p:nvSpPr>
+          <p:cNvPr id="27" name="Text 25"/>
+          <p:cNvSpPr/>
+          <p:nvPr/>
+        </p:nvSpPr>
+        <p:spPr>
+          <a:xfrm>
+            <a:off x="5925312" y="2916936"/>
+            <a:ext cx="2871216" cy="603504"/>
+          </a:xfrm>
+          <a:prstGeom prst="rect">
+            <a:avLst/>
+          </a:prstGeom>
+          <a:noFill/>
+          <a:ln/>
+        </p:spPr>
+        <p:txBody>
+          <a:bodyPr wrap="square" lIns="0" tIns="0" rIns="0" bIns="0" rtlCol="0" anchor="ctr"/>
+          <a:lstStyle/>
+          <a:p>
+            <a:pPr algn="ctr" indent="0" marL="0">
+              <a:buNone/>
+            </a:pPr>
+            <a:r>
+              <a:rPr lang="en-US" sz="1200" dirty="0">
+                <a:solidFill>
+                  <a:srgbClr val="1C2B27"/>
+                </a:solidFill>
+                <a:latin typeface="Calibri" pitchFamily="34" charset="0"/>
+                <a:ea typeface="Calibri" pitchFamily="34" charset="-122"/>
+                <a:cs typeface="Calibri" pitchFamily="34" charset="-120"/>
+              </a:rPr>
+              <a:t>mild; cascades into freight</a:t>
+            </a:r>
+            <a:endParaRPr lang="en-US" sz="1200" dirty="0"/>
+          </a:p>
+        </p:txBody>
+      </p:sp>
+      <p:sp>
+        <p:nvSpPr>
+          <p:cNvPr id="28" name="Shape 26"/>
+          <p:cNvSpPr/>
+          <p:nvPr/>
+        </p:nvSpPr>
+        <p:spPr>
+          <a:xfrm>
+            <a:off x="548640" y="3575304"/>
+            <a:ext cx="2103120" cy="603504"/>
+          </a:xfrm>
+          <a:prstGeom prst="rect">
+            <a:avLst/>
+          </a:prstGeom>
+          <a:solidFill>
+            <a:srgbClr val="F2F6F4"/>
+          </a:solidFill>
+          <a:ln w="9525">
+            <a:solidFill>
+              <a:srgbClr val="D5E0DB"/>
+            </a:solidFill>
+            <a:prstDash val="solid"/>
+          </a:ln>
+        </p:spPr>
+      </p:sp>
+      <p:sp>
+        <p:nvSpPr>
+          <p:cNvPr id="29" name="Text 27"/>
+          <p:cNvSpPr/>
+          <p:nvPr/>
+        </p:nvSpPr>
+        <p:spPr>
+          <a:xfrm>
+            <a:off x="621792" y="3575304"/>
+            <a:ext cx="1956816" cy="603504"/>
+          </a:xfrm>
+          <a:prstGeom prst="rect">
+            <a:avLst/>
+          </a:prstGeom>
+          <a:noFill/>
+          <a:ln/>
+        </p:spPr>
+        <p:txBody>
+          <a:bodyPr wrap="square" lIns="0" tIns="0" rIns="0" bIns="0" rtlCol="0" anchor="ctr"/>
+          <a:lstStyle/>
+          <a:p>
+            <a:pPr algn="l" indent="0" marL="0">
+              <a:buNone/>
+            </a:pPr>
+            <a:r>
+              <a:rPr lang="en-US" sz="1200" b="1" dirty="0">
+                <a:solidFill>
+                  <a:srgbClr val="1C2B27"/>
+                </a:solidFill>
+                <a:latin typeface="Calibri" pitchFamily="34" charset="0"/>
+                <a:ea typeface="Calibri" pitchFamily="34" charset="-122"/>
+                <a:cs typeface="Calibri" pitchFamily="34" charset="-120"/>
+              </a:rPr>
+              <a:t>CBG in CNG</a:t>
+            </a:r>
+            <a:endParaRPr lang="en-US" sz="1200" dirty="0"/>
+          </a:p>
+        </p:txBody>
+      </p:sp>
+      <p:sp>
+        <p:nvSpPr>
+          <p:cNvPr id="30" name="Shape 28"/>
+          <p:cNvSpPr/>
+          <p:nvPr/>
+        </p:nvSpPr>
+        <p:spPr>
+          <a:xfrm>
+            <a:off x="2651760" y="3575304"/>
+            <a:ext cx="1371600" cy="603504"/>
+          </a:xfrm>
+          <a:prstGeom prst="rect">
+            <a:avLst/>
+          </a:prstGeom>
+          <a:solidFill>
+            <a:srgbClr val="F2F6F4"/>
+          </a:solidFill>
+          <a:ln w="9525">
+            <a:solidFill>
+              <a:srgbClr val="D5E0DB"/>
+            </a:solidFill>
+            <a:prstDash val="solid"/>
+          </a:ln>
+        </p:spPr>
+      </p:sp>
+      <p:sp>
+        <p:nvSpPr>
+          <p:cNvPr id="31" name="Text 29"/>
+          <p:cNvSpPr/>
+          <p:nvPr/>
+        </p:nvSpPr>
+        <p:spPr>
+          <a:xfrm>
+            <a:off x="2724912" y="3575304"/>
+            <a:ext cx="1225296" cy="603504"/>
+          </a:xfrm>
+          <a:prstGeom prst="rect">
+            <a:avLst/>
+          </a:prstGeom>
+          <a:noFill/>
+          <a:ln/>
+        </p:spPr>
+        <p:txBody>
+          <a:bodyPr wrap="square" lIns="0" tIns="0" rIns="0" bIns="0" rtlCol="0" anchor="ctr"/>
+          <a:lstStyle/>
+          <a:p>
+            <a:pPr algn="ctr" indent="0" marL="0">
+              <a:buNone/>
+            </a:pPr>
+            <a:r>
+              <a:rPr lang="en-US" sz="1200" dirty="0">
+                <a:solidFill>
+                  <a:srgbClr val="1C2B27"/>
+                </a:solidFill>
+                <a:latin typeface="Calibri" pitchFamily="34" charset="0"/>
+                <a:ea typeface="Calibri" pitchFamily="34" charset="-122"/>
+                <a:cs typeface="Calibri" pitchFamily="34" charset="-120"/>
+              </a:rPr>
+              <a:t>~0% /kg</a:t>
+            </a:r>
+            <a:endParaRPr lang="en-US" sz="1200" dirty="0"/>
+          </a:p>
+        </p:txBody>
+      </p:sp>
+      <p:sp>
+        <p:nvSpPr>
+          <p:cNvPr id="32" name="Shape 30"/>
+          <p:cNvSpPr/>
+          <p:nvPr/>
+        </p:nvSpPr>
+        <p:spPr>
+          <a:xfrm>
+            <a:off x="4023360" y="3575304"/>
+            <a:ext cx="1828800" cy="603504"/>
+          </a:xfrm>
+          <a:prstGeom prst="rect">
+            <a:avLst/>
+          </a:prstGeom>
+          <a:solidFill>
+            <a:srgbClr val="F2F6F4"/>
+          </a:solidFill>
+          <a:ln w="9525">
+            <a:solidFill>
+              <a:srgbClr val="D5E0DB"/>
+            </a:solidFill>
+            <a:prstDash val="solid"/>
+          </a:ln>
+        </p:spPr>
+      </p:sp>
+      <p:sp>
+        <p:nvSpPr>
+          <p:cNvPr id="33" name="Text 31"/>
+          <p:cNvSpPr/>
+          <p:nvPr/>
+        </p:nvSpPr>
+        <p:spPr>
+          <a:xfrm>
+            <a:off x="4096512" y="3575304"/>
+            <a:ext cx="1682496" cy="603504"/>
+          </a:xfrm>
+          <a:prstGeom prst="rect">
+            <a:avLst/>
+          </a:prstGeom>
+          <a:noFill/>
+          <a:ln/>
+        </p:spPr>
+        <p:txBody>
+          <a:bodyPr wrap="square" lIns="0" tIns="0" rIns="0" bIns="0" rtlCol="0" anchor="ctr"/>
+          <a:lstStyle/>
+          <a:p>
+            <a:pPr algn="ctr" indent="0" marL="0">
+              <a:buNone/>
+            </a:pPr>
+            <a:r>
+              <a:rPr lang="en-US" sz="1200" dirty="0">
+                <a:solidFill>
+                  <a:srgbClr val="1C2B27"/>
+                </a:solidFill>
+                <a:latin typeface="Calibri" pitchFamily="34" charset="0"/>
+                <a:ea typeface="Calibri" pitchFamily="34" charset="-122"/>
+                <a:cs typeface="Calibri" pitchFamily="34" charset="-120"/>
+              </a:rPr>
+              <a:t>lightly taxed</a:t>
+            </a:r>
+            <a:endParaRPr lang="en-US" sz="1200" dirty="0"/>
+          </a:p>
+        </p:txBody>
+      </p:sp>
+      <p:sp>
+        <p:nvSpPr>
+          <p:cNvPr id="34" name="Shape 32"/>
+          <p:cNvSpPr/>
+          <p:nvPr/>
+        </p:nvSpPr>
+        <p:spPr>
+          <a:xfrm>
+            <a:off x="5852160" y="3575304"/>
+            <a:ext cx="3017520" cy="603504"/>
+          </a:xfrm>
+          <a:prstGeom prst="rect">
+            <a:avLst/>
+          </a:prstGeom>
+          <a:solidFill>
+            <a:srgbClr val="F2F6F4"/>
+          </a:solidFill>
+          <a:ln w="9525">
+            <a:solidFill>
+              <a:srgbClr val="D5E0DB"/>
+            </a:solidFill>
+            <a:prstDash val="solid"/>
+          </a:ln>
+        </p:spPr>
+      </p:sp>
+      <p:sp>
+        <p:nvSpPr>
+          <p:cNvPr id="35" name="Text 33"/>
+          <p:cNvSpPr/>
+          <p:nvPr/>
+        </p:nvSpPr>
+        <p:spPr>
+          <a:xfrm>
+            <a:off x="5925312" y="3575304"/>
+            <a:ext cx="2871216" cy="603504"/>
+          </a:xfrm>
+          <a:prstGeom prst="rect">
+            <a:avLst/>
+          </a:prstGeom>
+          <a:noFill/>
+          <a:ln/>
+        </p:spPr>
+        <p:txBody>
+          <a:bodyPr wrap="square" lIns="0" tIns="0" rIns="0" bIns="0" rtlCol="0" anchor="ctr"/>
+          <a:lstStyle/>
+          <a:p>
+            <a:pPr algn="ctr" indent="0" marL="0">
+              <a:buNone/>
+            </a:pPr>
+            <a:r>
+              <a:rPr lang="en-US" sz="1200" dirty="0">
+                <a:solidFill>
+                  <a:srgbClr val="1C2B27"/>
+                </a:solidFill>
+                <a:latin typeface="Calibri" pitchFamily="34" charset="0"/>
+                <a:ea typeface="Calibri" pitchFamily="34" charset="-122"/>
+                <a:cs typeface="Calibri" pitchFamily="34" charset="-120"/>
+              </a:rPr>
+              <a:t>nobody — the honest blend</a:t>
+            </a:r>
+            <a:endParaRPr lang="en-US" sz="1200" dirty="0"/>
+          </a:p>
+        </p:txBody>
+      </p:sp>
+      <p:sp>
+        <p:nvSpPr>
+          <p:cNvPr id="36" name="Shape 34"/>
+          <p:cNvSpPr/>
+          <p:nvPr/>
+        </p:nvSpPr>
+        <p:spPr>
+          <a:xfrm>
+            <a:off x="548640" y="4233672"/>
+            <a:ext cx="2103120" cy="603504"/>
+          </a:xfrm>
+          <a:prstGeom prst="rect">
+            <a:avLst/>
+          </a:prstGeom>
+          <a:solidFill>
+            <a:srgbClr val="16523F"/>
+          </a:solidFill>
+          <a:ln w="9525">
+            <a:solidFill>
+              <a:srgbClr val="D5E0DB"/>
+            </a:solidFill>
+            <a:prstDash val="solid"/>
+          </a:ln>
+        </p:spPr>
+      </p:sp>
+      <p:sp>
+        <p:nvSpPr>
+          <p:cNvPr id="37" name="Text 35"/>
+          <p:cNvSpPr/>
+          <p:nvPr/>
+        </p:nvSpPr>
+        <p:spPr>
+          <a:xfrm>
+            <a:off x="621792" y="4233672"/>
+            <a:ext cx="1956816" cy="603504"/>
+          </a:xfrm>
+          <a:prstGeom prst="rect">
+            <a:avLst/>
+          </a:prstGeom>
+          <a:noFill/>
+          <a:ln/>
+        </p:spPr>
+        <p:txBody>
+          <a:bodyPr wrap="square" lIns="0" tIns="0" rIns="0" bIns="0" rtlCol="0" anchor="ctr"/>
+          <a:lstStyle/>
+          <a:p>
+            <a:pPr algn="l" indent="0" marL="0">
+              <a:buNone/>
+            </a:pPr>
+            <a:r>
+              <a:rPr lang="en-US" sz="1200" b="1" dirty="0">
+                <a:solidFill>
+                  <a:srgbClr val="FFFFFF"/>
+                </a:solidFill>
+                <a:latin typeface="Calibri" pitchFamily="34" charset="0"/>
+                <a:ea typeface="Calibri" pitchFamily="34" charset="-122"/>
+                <a:cs typeface="Calibri" pitchFamily="34" charset="-120"/>
+              </a:rPr>
+              <a:t>DME in LPG</a:t>
+            </a:r>
+            <a:endParaRPr lang="en-US" sz="1200" dirty="0"/>
+          </a:p>
+        </p:txBody>
+      </p:sp>
+      <p:sp>
+        <p:nvSpPr>
+          <p:cNvPr id="38" name="Shape 36"/>
+          <p:cNvSpPr/>
+          <p:nvPr/>
+        </p:nvSpPr>
+        <p:spPr>
+          <a:xfrm>
+            <a:off x="2651760" y="4233672"/>
+            <a:ext cx="1371600" cy="603504"/>
+          </a:xfrm>
+          <a:prstGeom prst="rect">
+            <a:avLst/>
+          </a:prstGeom>
+          <a:solidFill>
+            <a:srgbClr val="16523F"/>
+          </a:solidFill>
+          <a:ln w="9525">
+            <a:solidFill>
+              <a:srgbClr val="D5E0DB"/>
+            </a:solidFill>
+            <a:prstDash val="solid"/>
+          </a:ln>
+        </p:spPr>
+      </p:sp>
+      <p:sp>
+        <p:nvSpPr>
+          <p:cNvPr id="39" name="Text 37"/>
+          <p:cNvSpPr/>
+          <p:nvPr/>
+        </p:nvSpPr>
+        <p:spPr>
+          <a:xfrm>
+            <a:off x="2724912" y="4233672"/>
+            <a:ext cx="1225296" cy="603504"/>
+          </a:xfrm>
+          <a:prstGeom prst="rect">
+            <a:avLst/>
+          </a:prstGeom>
+          <a:noFill/>
+          <a:ln/>
+        </p:spPr>
+        <p:txBody>
+          <a:bodyPr wrap="square" lIns="0" tIns="0" rIns="0" bIns="0" rtlCol="0" anchor="ctr"/>
+          <a:lstStyle/>
+          <a:p>
+            <a:pPr algn="ctr" indent="0" marL="0">
+              <a:buNone/>
+            </a:pPr>
+            <a:r>
+              <a:rPr lang="en-US" sz="1200" dirty="0">
+                <a:solidFill>
+                  <a:srgbClr val="FFFFFF"/>
+                </a:solidFill>
+                <a:latin typeface="Calibri" pitchFamily="34" charset="0"/>
+                <a:ea typeface="Calibri" pitchFamily="34" charset="-122"/>
+                <a:cs typeface="Calibri" pitchFamily="34" charset="-120"/>
+              </a:rPr>
+              <a:t>−37% /kg</a:t>
+            </a:r>
+            <a:endParaRPr lang="en-US" sz="1200" dirty="0"/>
+          </a:p>
+        </p:txBody>
+      </p:sp>
+      <p:sp>
+        <p:nvSpPr>
+          <p:cNvPr id="40" name="Shape 38"/>
+          <p:cNvSpPr/>
+          <p:nvPr/>
+        </p:nvSpPr>
+        <p:spPr>
+          <a:xfrm>
+            <a:off x="4023360" y="4233672"/>
+            <a:ext cx="1828800" cy="603504"/>
+          </a:xfrm>
+          <a:prstGeom prst="rect">
+            <a:avLst/>
+          </a:prstGeom>
+          <a:solidFill>
+            <a:srgbClr val="16523F"/>
+          </a:solidFill>
+          <a:ln w="9525">
+            <a:solidFill>
+              <a:srgbClr val="D5E0DB"/>
+            </a:solidFill>
+            <a:prstDash val="solid"/>
+          </a:ln>
+        </p:spPr>
+      </p:sp>
+      <p:sp>
+        <p:nvSpPr>
+          <p:cNvPr id="41" name="Text 39"/>
+          <p:cNvSpPr/>
+          <p:nvPr/>
+        </p:nvSpPr>
+        <p:spPr>
+          <a:xfrm>
+            <a:off x="4096512" y="4233672"/>
+            <a:ext cx="1682496" cy="603504"/>
+          </a:xfrm>
+          <a:prstGeom prst="rect">
+            <a:avLst/>
+          </a:prstGeom>
+          <a:noFill/>
+          <a:ln/>
+        </p:spPr>
+        <p:txBody>
+          <a:bodyPr wrap="square" lIns="0" tIns="0" rIns="0" bIns="0" rtlCol="0" anchor="ctr"/>
+          <a:lstStyle/>
+          <a:p>
+            <a:pPr algn="ctr" indent="0" marL="0">
+              <a:buNone/>
+            </a:pPr>
+            <a:r>
+              <a:rPr lang="en-US" sz="1200" dirty="0">
+                <a:solidFill>
+                  <a:srgbClr val="FFFFFF"/>
+                </a:solidFill>
+                <a:latin typeface="Calibri" pitchFamily="34" charset="0"/>
+                <a:ea typeface="Calibri" pitchFamily="34" charset="-122"/>
+                <a:cs typeface="Calibri" pitchFamily="34" charset="-120"/>
+              </a:rPr>
+              <a:t>SUBSIDISED</a:t>
+            </a:r>
+            <a:endParaRPr lang="en-US" sz="1200" dirty="0"/>
+          </a:p>
+        </p:txBody>
+      </p:sp>
+      <p:sp>
+        <p:nvSpPr>
+          <p:cNvPr id="42" name="Shape 40"/>
+          <p:cNvSpPr/>
+          <p:nvPr/>
+        </p:nvSpPr>
+        <p:spPr>
+          <a:xfrm>
+            <a:off x="5852160" y="4233672"/>
+            <a:ext cx="3017520" cy="603504"/>
+          </a:xfrm>
+          <a:prstGeom prst="rect">
+            <a:avLst/>
+          </a:prstGeom>
+          <a:solidFill>
+            <a:srgbClr val="16523F"/>
+          </a:solidFill>
+          <a:ln w="9525">
+            <a:solidFill>
+              <a:srgbClr val="D5E0DB"/>
+            </a:solidFill>
+            <a:prstDash val="solid"/>
+          </a:ln>
+        </p:spPr>
+      </p:sp>
+      <p:sp>
+        <p:nvSpPr>
+          <p:cNvPr id="43" name="Text 41"/>
+          <p:cNvSpPr/>
+          <p:nvPr/>
+        </p:nvSpPr>
+        <p:spPr>
+          <a:xfrm>
+            <a:off x="5925312" y="4233672"/>
+            <a:ext cx="2871216" cy="603504"/>
+          </a:xfrm>
+          <a:prstGeom prst="rect">
+            <a:avLst/>
+          </a:prstGeom>
+          <a:noFill/>
+          <a:ln/>
+        </p:spPr>
+        <p:txBody>
+          <a:bodyPr wrap="square" lIns="0" tIns="0" rIns="0" bIns="0" rtlCol="0" anchor="ctr"/>
+          <a:lstStyle/>
+          <a:p>
+            <a:pPr algn="ctr" indent="0" marL="0">
+              <a:buNone/>
+            </a:pPr>
+            <a:r>
+              <a:rPr lang="en-US" sz="1200" dirty="0">
+                <a:solidFill>
+                  <a:srgbClr val="FFFFFF"/>
+                </a:solidFill>
+                <a:latin typeface="Calibri" pitchFamily="34" charset="0"/>
+                <a:ea typeface="Calibri" pitchFamily="34" charset="-122"/>
+                <a:cs typeface="Calibri" pitchFamily="34" charset="-120"/>
+              </a:rPr>
+              <a:t>consumer AND exchequer pay</a:t>
+            </a:r>
+            <a:endParaRPr lang="en-US" sz="1200" dirty="0"/>
+          </a:p>
+        </p:txBody>
+      </p:sp>
+      <p:sp>
+        <p:nvSpPr>
+          <p:cNvPr id="44" name="Shape 42"/>
+          <p:cNvSpPr/>
+          <p:nvPr/>
+        </p:nvSpPr>
+        <p:spPr>
+          <a:xfrm>
+            <a:off x="9235440" y="1600200"/>
+            <a:ext cx="2423160" cy="3246120"/>
+          </a:xfrm>
+          <a:prstGeom prst="roundRect">
+            <a:avLst>
+              <a:gd name="adj" fmla="val 3019"/>
+            </a:avLst>
+          </a:prstGeom>
+          <a:solidFill>
+            <a:srgbClr val="0E3B2E"/>
+          </a:solidFill>
+          <a:ln w="9525">
+            <a:solidFill>
+              <a:srgbClr val="D5E0DB"/>
+            </a:solidFill>
+            <a:prstDash val="solid"/>
+          </a:ln>
+        </p:spPr>
+      </p:sp>
+      <p:sp>
+        <p:nvSpPr>
+          <p:cNvPr id="45" name="Text 43"/>
+          <p:cNvSpPr/>
+          <p:nvPr/>
+        </p:nvSpPr>
+        <p:spPr>
+          <a:xfrm>
+            <a:off x="9418320" y="1783080"/>
+            <a:ext cx="2057400" cy="640080"/>
+          </a:xfrm>
+          <a:prstGeom prst="rect">
+            <a:avLst/>
+          </a:prstGeom>
+          <a:noFill/>
+          <a:ln/>
+        </p:spPr>
+        <p:txBody>
+          <a:bodyPr wrap="square" lIns="0" tIns="0" rIns="0" bIns="0" rtlCol="0" anchor="ctr"/>
+          <a:lstStyle/>
+          <a:p>
+            <a:pPr indent="0" marL="0">
+              <a:buNone/>
+            </a:pPr>
+            <a:r>
+              <a:rPr lang="en-US" sz="1150" dirty="0">
+                <a:solidFill>
+                  <a:srgbClr val="CFE3DA"/>
+                </a:solidFill>
+                <a:latin typeface="Calibri" pitchFamily="34" charset="0"/>
+                <a:ea typeface="Calibri" pitchFamily="34" charset="-122"/>
+                <a:cs typeface="Calibri" pitchFamily="34" charset="-120"/>
+              </a:rPr>
+              <a:t>DME20 at unchanged cylinder price</a:t>
+            </a:r>
+            <a:endParaRPr lang="en-US" sz="1150" dirty="0"/>
+          </a:p>
+        </p:txBody>
+      </p:sp>
+      <p:sp>
+        <p:nvSpPr>
+          <p:cNvPr id="46" name="Text 44"/>
+          <p:cNvSpPr/>
+          <p:nvPr/>
+        </p:nvSpPr>
+        <p:spPr>
+          <a:xfrm>
+            <a:off x="9418320" y="2423160"/>
+            <a:ext cx="2057400" cy="640080"/>
+          </a:xfrm>
+          <a:prstGeom prst="rect">
+            <a:avLst/>
+          </a:prstGeom>
+          <a:noFill/>
+          <a:ln/>
+        </p:spPr>
+        <p:txBody>
+          <a:bodyPr wrap="square" lIns="0" tIns="0" rIns="0" bIns="0" rtlCol="0" anchor="ctr"/>
+          <a:lstStyle/>
+          <a:p>
+            <a:pPr indent="0" marL="0">
+              <a:buNone/>
+            </a:pPr>
+            <a:r>
+              <a:rPr lang="en-US" sz="3000" b="1" dirty="0">
+                <a:solidFill>
+                  <a:srgbClr val="C0392B"/>
+                </a:solidFill>
+                <a:latin typeface="Cambria" pitchFamily="34" charset="0"/>
+                <a:ea typeface="Cambria" pitchFamily="34" charset="-122"/>
+                <a:cs typeface="Cambria" pitchFamily="34" charset="-120"/>
+              </a:rPr>
+              <a:t>+₹312/yr</a:t>
+            </a:r>
+            <a:endParaRPr lang="en-US" sz="3000" dirty="0"/>
+          </a:p>
+        </p:txBody>
+      </p:sp>
+      <p:sp>
+        <p:nvSpPr>
+          <p:cNvPr id="47" name="Text 45"/>
+          <p:cNvSpPr/>
+          <p:nvPr/>
+        </p:nvSpPr>
+        <p:spPr>
+          <a:xfrm>
+            <a:off x="9418320" y="3108960"/>
+            <a:ext cx="2057400" cy="1554480"/>
+          </a:xfrm>
+          <a:prstGeom prst="rect">
+            <a:avLst/>
+          </a:prstGeom>
+          <a:noFill/>
+          <a:ln/>
+        </p:spPr>
+        <p:txBody>
+          <a:bodyPr wrap="square" lIns="0" tIns="0" rIns="0" bIns="0" rtlCol="0" anchor="ctr"/>
+          <a:lstStyle/>
+          <a:p>
+            <a:pPr indent="0" marL="0">
+              <a:buNone/>
+            </a:pPr>
+            <a:r>
+              <a:rPr lang="en-US" sz="1100" dirty="0">
+                <a:solidFill>
+                  <a:srgbClr val="CFE3DA"/>
+                </a:solidFill>
+                <a:latin typeface="Calibri" pitchFamily="34" charset="0"/>
+                <a:ea typeface="Calibri" pitchFamily="34" charset="-122"/>
+                <a:cs typeface="Calibri" pitchFamily="34" charset="-120"/>
+              </a:rPr>
+              <a:t>per household — plus ₹1,201 cr/yr extra PMUY subsidy. Parity cylinder = ₹761 vs ₹803</a:t>
+            </a:r>
+            <a:endParaRPr lang="en-US" sz="1100" dirty="0"/>
+          </a:p>
+        </p:txBody>
+      </p:sp>
+      <p:sp>
+        <p:nvSpPr>
+          <p:cNvPr id="48" name="Text 46"/>
+          <p:cNvSpPr/>
+          <p:nvPr/>
+        </p:nvSpPr>
+        <p:spPr>
+          <a:xfrm>
+            <a:off x="548640" y="5120640"/>
+            <a:ext cx="11064240" cy="1554480"/>
+          </a:xfrm>
+          <a:prstGeom prst="rect">
+            <a:avLst/>
+          </a:prstGeom>
+          <a:noFill/>
+          <a:ln/>
+        </p:spPr>
+        <p:txBody>
+          <a:bodyPr wrap="square" lIns="0" tIns="0" rIns="0" bIns="0" rtlCol="0" anchor="t"/>
+          <a:lstStyle/>
+          <a:p>
+            <a:pPr marL="177800" indent="-177800">
+              <a:spcAft>
+                <a:spcPts val="800"/>
+              </a:spcAft>
+              <a:buSzPct val="100000"/>
+              <a:buChar char="•"/>
+            </a:pPr>
+            <a:r>
+              <a:rPr lang="en-US" sz="1200" dirty="0">
+                <a:solidFill>
+                  <a:srgbClr val="1C2B27"/>
+                </a:solidFill>
+                <a:latin typeface="Calibri" pitchFamily="34" charset="0"/>
+                <a:ea typeface="Calibri" pitchFamily="34" charset="-122"/>
+                <a:cs typeface="Calibri" pitchFamily="34" charset="-120"/>
+              </a:rPr>
+              <a:t>Ethanol's dilution EARNS the exchequer excise; DME's dilution BILLS it — a hidden levy on the Ujjwala merit good with the subsidy bill co-paying (₹9,325 cr consumer + ₹1,201 cr PMUY at DME20 on the full pool)</a:t>
+            </a:r>
+            <a:endParaRPr lang="en-US" sz="1200" dirty="0"/>
+          </a:p>
+          <a:p>
+            <a:pPr marL="177800" indent="-177800">
+              <a:spcAft>
+                <a:spcPts val="800"/>
+              </a:spcAft>
+              <a:buSzPct val="100000"/>
+              <a:buChar char="•"/>
+            </a:pPr>
+            <a:r>
+              <a:rPr lang="en-US" sz="1200" dirty="0">
+                <a:solidFill>
+                  <a:srgbClr val="1C2B27"/>
+                </a:solidFill>
+                <a:latin typeface="Calibri" pitchFamily="34" charset="0"/>
+                <a:ea typeface="Calibri" pitchFamily="34" charset="-122"/>
+                <a:cs typeface="Calibri" pitchFamily="34" charset="-120"/>
+              </a:rPr>
+              <a:t>Economics don't clear: energy-neutral DME must price ≤₹32.7/kg but methanol-route feedstock alone is ₹33.6/kg — import substitution is honest only on coal/bio-DME, and DME20 needs 6.3 MMT/yr (~6× India's methanol output)</a:t>
+            </a:r>
+            <a:endParaRPr lang="en-US" sz="1200" dirty="0"/>
+          </a:p>
+          <a:p>
+            <a:pPr marL="177800" indent="-177800">
+              <a:spcAft>
+                <a:spcPts val="800"/>
+              </a:spcAft>
+              <a:buSzPct val="100000"/>
+              <a:buChar char="•"/>
+            </a:pPr>
+            <a:r>
+              <a:rPr lang="en-US" sz="1200" dirty="0">
+                <a:solidFill>
+                  <a:srgbClr val="1C2B27"/>
+                </a:solidFill>
+                <a:latin typeface="Calibri" pitchFamily="34" charset="0"/>
+                <a:ea typeface="Calibri" pitchFamily="34" charset="-122"/>
+                <a:cs typeface="Calibri" pitchFamily="34" charset="-120"/>
+              </a:rPr>
+              <a:t>Guardrails if pursued: energy-parity cylinder pricing + domestic-carbon DME only</a:t>
+            </a:r>
+            <a:endParaRPr lang="en-US" sz="1200" dirty="0"/>
+          </a:p>
+        </p:txBody>
+      </p:sp>
+    </p:spTree>
+  </p:cSld>
+  <p:clrMapOvr>
+    <a:masterClrMapping/>
+  </p:clrMapOvr>
+</p:sld>
+</file>
+
+<file path=ppt/slides/slide14.xml><?xml version="1.0" encoding="utf-8"?>
+<p:sld xmlns:a="http://schemas.openxmlformats.org/drawingml/2006/main" xmlns:r="http://schemas.openxmlformats.org/officeDocument/2006/relationships" xmlns:p="http://schemas.openxmlformats.org/presentationml/2006/main">
+  <p:cSld name="Slide 14">
+    <p:bg>
+      <p:bgPr>
+        <a:solidFill>
           <a:srgbClr val="0E3B2E"/>
         </a:solidFill>
       </p:bgPr>

</xml_diff>